<commit_message>
feat: add rapid digital-run liquidity stress scenario
Add a severe exploratory deposit-run scenario with front-loaded outflows, scenario-specific HQLA market-value shocks, a seven-day survival horizon, expanded validation, and refreshed ALCO deliverables.
</commit_message>
<xml_diff>
--- a/presentation/Aurelia_Bank_ALM_Executive_Deck_EN.pptx
+++ b/presentation/Aurelia_Bank_ALM_Executive_Deck_EN.pptx
@@ -2,24 +2,24 @@
 <file path=ppt/presentation.xml><?xml version="1.0" encoding="utf-8"?>
 <p:presentation xmlns:p="http://schemas.openxmlformats.org/presentationml/2006/main">
   <p:sldMasterIdLst>
-    <p:sldMasterId xmlns:r="http://schemas.openxmlformats.org/officeDocument/2006/relationships" id="2147483648" r:id="R62bf010aeee04786"/>
+    <p:sldMasterId xmlns:r="http://schemas.openxmlformats.org/officeDocument/2006/relationships" id="2147483648" r:id="Rbfc5fa283ecb4372"/>
   </p:sldMasterIdLst>
   <p:notesMasterIdLst>
-    <p:notesMasterId xmlns:r="http://schemas.openxmlformats.org/officeDocument/2006/relationships" r:id="Rf65c5ba3d62f42aa"/>
+    <p:notesMasterId xmlns:r="http://schemas.openxmlformats.org/officeDocument/2006/relationships" r:id="Rd033183a6f3f4f7c"/>
   </p:notesMasterIdLst>
   <p:sldIdLst>
-    <p:sldId xmlns:r="http://schemas.openxmlformats.org/officeDocument/2006/relationships" id="256" r:id="Rfff94b1676394775"/>
-    <p:sldId xmlns:r="http://schemas.openxmlformats.org/officeDocument/2006/relationships" id="257" r:id="R1c7041bea51343ac"/>
-    <p:sldId xmlns:r="http://schemas.openxmlformats.org/officeDocument/2006/relationships" id="258" r:id="R76b489be907d4585"/>
-    <p:sldId xmlns:r="http://schemas.openxmlformats.org/officeDocument/2006/relationships" id="259" r:id="Rea645cfbc4b2446b"/>
-    <p:sldId xmlns:r="http://schemas.openxmlformats.org/officeDocument/2006/relationships" id="260" r:id="Rf82b9bac9b614900"/>
-    <p:sldId xmlns:r="http://schemas.openxmlformats.org/officeDocument/2006/relationships" id="261" r:id="R0ad7e86bd09d4bdc"/>
-    <p:sldId xmlns:r="http://schemas.openxmlformats.org/officeDocument/2006/relationships" id="262" r:id="R5af340d451e9467e"/>
-    <p:sldId xmlns:r="http://schemas.openxmlformats.org/officeDocument/2006/relationships" id="263" r:id="R6630b06da5764727"/>
-    <p:sldId xmlns:r="http://schemas.openxmlformats.org/officeDocument/2006/relationships" id="264" r:id="Rafcf3656c79148cd"/>
-    <p:sldId xmlns:r="http://schemas.openxmlformats.org/officeDocument/2006/relationships" id="265" r:id="R85e2eb2553264485"/>
-    <p:sldId xmlns:r="http://schemas.openxmlformats.org/officeDocument/2006/relationships" id="266" r:id="R961f9fa1333649f0"/>
-    <p:sldId xmlns:r="http://schemas.openxmlformats.org/officeDocument/2006/relationships" id="267" r:id="R2b94ee4ce58547ea"/>
+    <p:sldId xmlns:r="http://schemas.openxmlformats.org/officeDocument/2006/relationships" id="256" r:id="Rb7d663c555884971"/>
+    <p:sldId xmlns:r="http://schemas.openxmlformats.org/officeDocument/2006/relationships" id="257" r:id="R8023b39412bd4b41"/>
+    <p:sldId xmlns:r="http://schemas.openxmlformats.org/officeDocument/2006/relationships" id="258" r:id="Rc2f4dc4ef5e44ffd"/>
+    <p:sldId xmlns:r="http://schemas.openxmlformats.org/officeDocument/2006/relationships" id="259" r:id="Raa20ae3cae1f42b4"/>
+    <p:sldId xmlns:r="http://schemas.openxmlformats.org/officeDocument/2006/relationships" id="260" r:id="R544e7b40912649eb"/>
+    <p:sldId xmlns:r="http://schemas.openxmlformats.org/officeDocument/2006/relationships" id="261" r:id="Rd3c687e7e20b44b7"/>
+    <p:sldId xmlns:r="http://schemas.openxmlformats.org/officeDocument/2006/relationships" id="262" r:id="R92ad7e2ea79b4632"/>
+    <p:sldId xmlns:r="http://schemas.openxmlformats.org/officeDocument/2006/relationships" id="263" r:id="R6dca238ad31248ee"/>
+    <p:sldId xmlns:r="http://schemas.openxmlformats.org/officeDocument/2006/relationships" id="264" r:id="Rd459189973df4402"/>
+    <p:sldId xmlns:r="http://schemas.openxmlformats.org/officeDocument/2006/relationships" id="265" r:id="R541b456075154eb5"/>
+    <p:sldId xmlns:r="http://schemas.openxmlformats.org/officeDocument/2006/relationships" id="266" r:id="R1a1593e3b29f4a4f"/>
+    <p:sldId xmlns:r="http://schemas.openxmlformats.org/officeDocument/2006/relationships" id="267" r:id="Rc89af6a95e134ae6"/>
   </p:sldIdLst>
   <p:sldSz cx="12192000" cy="6858000"/>
   <p:notesSz cx="6858000" cy="9144000"/>
@@ -618,7 +618,32 @@
           <a:lstStyle xmlns:a="http://schemas.openxmlformats.org/drawingml/2006/main"/>
           <a:p xmlns:a="http://schemas.openxmlformats.org/drawingml/2006/main">
             <a:r>
-              <a:t>Separate model validity from business-risk status. The accounting identity, data controls and test suite pass; the FX risk breach remains deliberately visible.</a:t>
+              <a:t>Separate model validity from business-risk status. All 46 automated tests pass, line coverage is 93.88%, and the formal FX risk breach remains deliberately visible.</a:t>
+            </a:r>
+          </a:p>
+          <a:p xmlns:a="http://schemas.openxmlformats.org/drawingml/2006/main">
+            <a:r>
+              <a:t/>
+            </a:r>
+          </a:p>
+          <a:p xmlns:a="http://schemas.openxmlformats.org/drawingml/2006/main">
+            <a:r>
+              <a:t>[Sources]</a:t>
+            </a:r>
+          </a:p>
+          <a:p xmlns:a="http://schemas.openxmlformats.org/drawingml/2006/main">
+            <a:r>
+              <a:t>tests/</a:t>
+            </a:r>
+          </a:p>
+          <a:p xmlns:a="http://schemas.openxmlformats.org/drawingml/2006/main">
+            <a:r>
+              <a:t>docs/validation_report.md</a:t>
+            </a:r>
+          </a:p>
+          <a:p xmlns:a="http://schemas.openxmlformats.org/drawingml/2006/main">
+            <a:r>
+              <a:t>.github/workflows/ci.yml</a:t>
             </a:r>
           </a:p>
         </p:txBody>
@@ -688,7 +713,27 @@
           <a:lstStyle xmlns:a="http://schemas.openxmlformats.org/drawingml/2006/main"/>
           <a:p xmlns:a="http://schemas.openxmlformats.org/drawingml/2006/main">
             <a:r>
-              <a:t>Close on the explicit decision. Ask ALCO to approve the sequence and assign Treasury, ALM, Market Risk and Finance owners. Require a documented post-trade rerun before the action is considered complete.</a:t>
+              <a:t>Close on the explicit decision. Ask ALCO to approve the sequence, activate the rapid-run contingency workstream, assign Treasury, ALM, Market Risk and Finance owners, and require a documented post-trade rerun.</a:t>
+            </a:r>
+          </a:p>
+          <a:p xmlns:a="http://schemas.openxmlformats.org/drawingml/2006/main">
+            <a:r>
+              <a:t/>
+            </a:r>
+          </a:p>
+          <a:p xmlns:a="http://schemas.openxmlformats.org/drawingml/2006/main">
+            <a:r>
+              <a:t>[Sources]</a:t>
+            </a:r>
+          </a:p>
+          <a:p xmlns:a="http://schemas.openxmlformats.org/drawingml/2006/main">
+            <a:r>
+              <a:t>docs/alco_playbook.md</a:t>
+            </a:r>
+          </a:p>
+          <a:p xmlns:a="http://schemas.openxmlformats.org/drawingml/2006/main">
+            <a:r>
+              <a:t>docs/rapid_digital_run_scenario.md</a:t>
             </a:r>
           </a:p>
         </p:txBody>
@@ -758,7 +803,27 @@
           <a:lstStyle xmlns:a="http://schemas.openxmlformats.org/drawingml/2006/main"/>
           <a:p xmlns:a="http://schemas.openxmlformats.org/drawingml/2006/main">
             <a:r>
-              <a:t>Lead with the two decisions. Clarify that combined-stress LCR is a management warning, while the formal limit breach is the aggregate FX open position.</a:t>
+              <a:t>Lead with the formal FX breach, then the severe exploratory liquidity result. The rapid-run scenario is a management vulnerability test, not a Basel-prescribed regulatory scenario.</a:t>
+            </a:r>
+          </a:p>
+          <a:p xmlns:a="http://schemas.openxmlformats.org/drawingml/2006/main">
+            <a:r>
+              <a:t/>
+            </a:r>
+          </a:p>
+          <a:p xmlns:a="http://schemas.openxmlformats.org/drawingml/2006/main">
+            <a:r>
+              <a:t>[Sources]</a:t>
+            </a:r>
+          </a:p>
+          <a:p xmlns:a="http://schemas.openxmlformats.org/drawingml/2006/main">
+            <a:r>
+              <a:t>artifacts/results/executive_summary.json</a:t>
+            </a:r>
+          </a:p>
+          <a:p xmlns:a="http://schemas.openxmlformats.org/drawingml/2006/main">
+            <a:r>
+              <a:t>docs/rapid_digital_run_scenario.md</a:t>
             </a:r>
           </a:p>
         </p:txBody>
@@ -1218,7 +1283,7 @@
           <a:lstStyle xmlns:a="http://schemas.openxmlformats.org/drawingml/2006/main"/>
           <a:p xmlns:a="http://schemas.openxmlformats.org/drawingml/2006/main">
             <a:r>
-              <a:t>State explicitly that the output is a proxy for portfolio analytics, not a regulatory return. The combined scenario triggers a management warning because the proxy is below 100% and survival is exactly at the floor.</a:t>
+              <a:t>State explicitly that the outputs are transparent management proxies, not regulatory returns. Under the severe exploratory rapid-run scenario, 55% of 30-day outflows arrive on day 1, 85% by day 7, stressed HQLA loses TRY 1.46bn, the LCR proxy falls to 78.1% and survival reaches seven days.</a:t>
             </a:r>
           </a:p>
           <a:p xmlns:a="http://schemas.openxmlformats.org/drawingml/2006/main">
@@ -1239,6 +1304,16 @@
           <a:p xmlns:a="http://schemas.openxmlformats.org/drawingml/2006/main">
             <a:r>
               <a:t>https://www.bis.org/basel_framework/chapter/NSF/20.htm</a:t>
+            </a:r>
+          </a:p>
+          <a:p xmlns:a="http://schemas.openxmlformats.org/drawingml/2006/main">
+            <a:r>
+              <a:t>artifacts/results/liquidity.csv</a:t>
+            </a:r>
+          </a:p>
+          <a:p xmlns:a="http://schemas.openxmlformats.org/drawingml/2006/main">
+            <a:r>
+              <a:t>docs/rapid_digital_run_scenario.md</a:t>
             </a:r>
           </a:p>
         </p:txBody>
@@ -1376,7 +1451,7 @@
   </p:cSld>
   <p:clrMap bg1="lt1" tx1="dk1" bg2="lt2" tx2="dk2" accent1="accent1" accent2="accent2" accent3="accent3" accent4="accent4" accent5="accent5" accent6="accent6" hlink="hlink" folHlink="folHlink"/>
   <p:sldLayoutIdLst>
-    <p:sldLayoutId xmlns:r="http://schemas.openxmlformats.org/officeDocument/2006/relationships" id="2147483649" r:id="R548b92fb6a564e97"/>
+    <p:sldLayoutId xmlns:r="http://schemas.openxmlformats.org/officeDocument/2006/relationships" id="2147483649" r:id="R00e18b07ada74c11"/>
   </p:sldLayoutIdLst>
   <p:txStyles>
     <p:titleStyle>
@@ -2905,9 +2980,18 @@
               </a:solidFill>
             </c:spPr>
           </c:dPt>
+          <c:dPt>
+            <c:idx val="4"/>
+            <c:invertIfNegative val="0"/>
+            <c:spPr>
+              <a:solidFill xmlns:a="http://schemas.openxmlformats.org/drawingml/2006/main">
+                <a:srgbClr val="7F1D1D"/>
+              </a:solidFill>
+            </c:spPr>
+          </c:dPt>
           <c:cat>
             <c:strLit>
-              <c:ptCount val="4"/>
+              <c:ptCount val="5"/>
               <c:pt idx="0">
                 <c:v>base</c:v>
               </c:pt>
@@ -2920,12 +3004,15 @@
               <c:pt idx="3">
                 <c:v>combined</c:v>
               </c:pt>
+              <c:pt idx="4">
+                <c:v>rapid run</c:v>
+              </c:pt>
             </c:strLit>
           </c:cat>
           <c:val>
             <c:numLit>
               <c:formatCode>0.0</c:formatCode>
-              <c:ptCount val="4"/>
+              <c:ptCount val="5"/>
               <c:pt idx="0">
                 <c:v>158.721676</c:v>
               </c:pt>
@@ -2937,6 +3024,9 @@
               </c:pt>
               <c:pt idx="3">
                 <c:v>94.833642</c:v>
+              </c:pt>
+              <c:pt idx="4">
+                <c:v>78.091516</c:v>
               </c:pt>
             </c:numLit>
           </c:val>
@@ -3344,6 +3434,7 @@
           <a:lstStyle xmlns:a="http://schemas.openxmlformats.org/drawingml/2006/main"/>
           <a:p xmlns:a="http://schemas.openxmlformats.org/drawingml/2006/main">
             <a:pPr algn="l">
+              <a:buNone/>
               <a:defRPr sz="1125" b="1" i="0">
                 <a:solidFill>
                   <a:srgbClr val="167CA5"/>
@@ -3425,6 +3516,7 @@
           <a:lstStyle xmlns:a="http://schemas.openxmlformats.org/drawingml/2006/main"/>
           <a:p xmlns:a="http://schemas.openxmlformats.org/drawingml/2006/main">
             <a:pPr algn="l">
+              <a:buNone/>
               <a:defRPr sz="4950" b="1" i="0">
                 <a:solidFill>
                   <a:srgbClr val="101820"/>
@@ -3442,6 +3534,7 @@
           </a:p>
           <a:p xmlns:a="http://schemas.openxmlformats.org/drawingml/2006/main">
             <a:pPr algn="l">
+              <a:buNone/>
               <a:defRPr sz="4950" b="1" i="0">
                 <a:solidFill>
                   <a:srgbClr val="101820"/>
@@ -3492,6 +3585,7 @@
           <a:lstStyle xmlns:a="http://schemas.openxmlformats.org/drawingml/2006/main"/>
           <a:p xmlns:a="http://schemas.openxmlformats.org/drawingml/2006/main">
             <a:pPr algn="l">
+              <a:buNone/>
               <a:defRPr sz="1950" b="0" i="0">
                 <a:solidFill>
                   <a:srgbClr val="56616F"/>
@@ -3604,6 +3698,7 @@
           <a:lstStyle xmlns:a="http://schemas.openxmlformats.org/drawingml/2006/main"/>
           <a:p xmlns:a="http://schemas.openxmlformats.org/drawingml/2006/main">
             <a:pPr algn="l">
+              <a:buNone/>
               <a:defRPr sz="2550" b="1" i="0">
                 <a:solidFill>
                   <a:srgbClr val="101820"/>
@@ -3654,6 +3749,7 @@
           <a:lstStyle xmlns:a="http://schemas.openxmlformats.org/drawingml/2006/main"/>
           <a:p xmlns:a="http://schemas.openxmlformats.org/drawingml/2006/main">
             <a:pPr algn="l">
+              <a:buNone/>
               <a:defRPr sz="1275" b="0" i="0">
                 <a:solidFill>
                   <a:srgbClr val="56616F"/>
@@ -3676,6 +3772,7 @@
           </a:p>
           <a:p xmlns:a="http://schemas.openxmlformats.org/drawingml/2006/main">
             <a:pPr algn="l">
+              <a:buNone/>
               <a:defRPr sz="1275" b="0" i="0">
                 <a:solidFill>
                   <a:srgbClr val="56616F"/>
@@ -3698,6 +3795,7 @@
           </a:p>
           <a:p xmlns:a="http://schemas.openxmlformats.org/drawingml/2006/main">
             <a:pPr algn="l">
+              <a:buNone/>
               <a:defRPr sz="1275" b="0" i="0">
                 <a:solidFill>
                   <a:srgbClr val="56616F"/>
@@ -3748,6 +3846,7 @@
           <a:lstStyle xmlns:a="http://schemas.openxmlformats.org/drawingml/2006/main"/>
           <a:p xmlns:a="http://schemas.openxmlformats.org/drawingml/2006/main">
             <a:pPr algn="l">
+              <a:buNone/>
               <a:defRPr sz="1200" b="0" i="0">
                 <a:solidFill>
                   <a:srgbClr val="56616F"/>
@@ -3798,6 +3897,7 @@
           <a:lstStyle xmlns:a="http://schemas.openxmlformats.org/drawingml/2006/main"/>
           <a:p xmlns:a="http://schemas.openxmlformats.org/drawingml/2006/main">
             <a:pPr algn="r">
+              <a:buNone/>
               <a:defRPr sz="1200" b="1" i="0">
                 <a:solidFill>
                   <a:srgbClr val="101820"/>
@@ -3877,6 +3977,7 @@
           <a:lstStyle xmlns:a="http://schemas.openxmlformats.org/drawingml/2006/main"/>
           <a:p xmlns:a="http://schemas.openxmlformats.org/drawingml/2006/main">
             <a:pPr algn="l">
+              <a:buNone/>
               <a:defRPr sz="975" b="1" i="0">
                 <a:solidFill>
                   <a:srgbClr val="56616F"/>
@@ -3927,6 +4028,7 @@
           <a:lstStyle xmlns:a="http://schemas.openxmlformats.org/drawingml/2006/main"/>
           <a:p xmlns:a="http://schemas.openxmlformats.org/drawingml/2006/main">
             <a:pPr algn="r">
+              <a:buNone/>
               <a:defRPr sz="975" b="1" i="0">
                 <a:solidFill>
                   <a:srgbClr val="56616F"/>
@@ -4008,6 +4110,7 @@
           <a:lstStyle xmlns:a="http://schemas.openxmlformats.org/drawingml/2006/main"/>
           <a:p xmlns:a="http://schemas.openxmlformats.org/drawingml/2006/main">
             <a:pPr algn="l">
+              <a:buNone/>
               <a:defRPr sz="825" b="0" i="0">
                 <a:solidFill>
                   <a:srgbClr val="56616F"/>
@@ -4058,6 +4161,7 @@
           <a:lstStyle xmlns:a="http://schemas.openxmlformats.org/drawingml/2006/main"/>
           <a:p xmlns:a="http://schemas.openxmlformats.org/drawingml/2006/main">
             <a:pPr algn="r">
+              <a:buNone/>
               <a:defRPr sz="825" b="0" i="0">
                 <a:solidFill>
                   <a:srgbClr val="56616F"/>
@@ -4108,6 +4212,7 @@
           <a:lstStyle xmlns:a="http://schemas.openxmlformats.org/drawingml/2006/main"/>
           <a:p xmlns:a="http://schemas.openxmlformats.org/drawingml/2006/main">
             <a:pPr algn="l">
+              <a:buNone/>
               <a:defRPr sz="3000" b="1" i="0">
                 <a:solidFill>
                   <a:srgbClr val="101820"/>
@@ -4158,6 +4263,7 @@
           <a:lstStyle xmlns:a="http://schemas.openxmlformats.org/drawingml/2006/main"/>
           <a:p xmlns:a="http://schemas.openxmlformats.org/drawingml/2006/main">
             <a:pPr algn="l">
+              <a:buNone/>
               <a:defRPr sz="1350" b="0" i="0">
                 <a:solidFill>
                   <a:srgbClr val="56616F"/>
@@ -4208,6 +4314,7 @@
           <a:lstStyle xmlns:a="http://schemas.openxmlformats.org/drawingml/2006/main"/>
           <a:p xmlns:a="http://schemas.openxmlformats.org/drawingml/2006/main">
             <a:pPr algn="l">
+              <a:buNone/>
               <a:defRPr sz="1350" b="1" i="0">
                 <a:solidFill>
                   <a:srgbClr val="0B3D52"/>
@@ -4289,6 +4396,7 @@
           <a:lstStyle xmlns:a="http://schemas.openxmlformats.org/drawingml/2006/main"/>
           <a:p xmlns:a="http://schemas.openxmlformats.org/drawingml/2006/main">
             <a:pPr algn="l">
+              <a:buNone/>
               <a:defRPr sz="2550" b="1" i="0">
                 <a:solidFill>
                   <a:srgbClr val="F97316"/>
@@ -4339,6 +4447,7 @@
           <a:lstStyle xmlns:a="http://schemas.openxmlformats.org/drawingml/2006/main"/>
           <a:p xmlns:a="http://schemas.openxmlformats.org/drawingml/2006/main">
             <a:pPr algn="l">
+              <a:buNone/>
               <a:defRPr sz="1200" b="0" i="0">
                 <a:solidFill>
                   <a:srgbClr val="56616F"/>
@@ -4389,6 +4498,7 @@
           <a:lstStyle xmlns:a="http://schemas.openxmlformats.org/drawingml/2006/main"/>
           <a:p xmlns:a="http://schemas.openxmlformats.org/drawingml/2006/main">
             <a:pPr algn="ctr">
+              <a:buNone/>
               <a:defRPr sz="2550" b="1" i="0">
                 <a:solidFill>
                   <a:srgbClr val="167CA5"/>
@@ -4439,6 +4549,7 @@
           <a:lstStyle xmlns:a="http://schemas.openxmlformats.org/drawingml/2006/main"/>
           <a:p xmlns:a="http://schemas.openxmlformats.org/drawingml/2006/main">
             <a:pPr algn="l">
+              <a:buNone/>
               <a:defRPr sz="2550" b="1" i="0">
                 <a:solidFill>
                   <a:srgbClr val="101820"/>
@@ -4489,6 +4600,7 @@
           <a:lstStyle xmlns:a="http://schemas.openxmlformats.org/drawingml/2006/main"/>
           <a:p xmlns:a="http://schemas.openxmlformats.org/drawingml/2006/main">
             <a:pPr algn="l">
+              <a:buNone/>
               <a:defRPr sz="1200" b="0" i="0">
                 <a:solidFill>
                   <a:srgbClr val="56616F"/>
@@ -4539,6 +4651,7 @@
           <a:lstStyle xmlns:a="http://schemas.openxmlformats.org/drawingml/2006/main"/>
           <a:p xmlns:a="http://schemas.openxmlformats.org/drawingml/2006/main">
             <a:pPr algn="l">
+              <a:buNone/>
               <a:defRPr sz="1500" b="0" i="0">
                 <a:solidFill>
                   <a:srgbClr val="101820"/>
@@ -4556,6 +4669,7 @@
           </a:p>
           <a:p xmlns:a="http://schemas.openxmlformats.org/drawingml/2006/main">
             <a:pPr algn="l">
+              <a:buNone/>
               <a:defRPr sz="1500" b="0" i="0">
                 <a:solidFill>
                   <a:srgbClr val="101820"/>
@@ -4573,6 +4687,7 @@
           </a:p>
           <a:p xmlns:a="http://schemas.openxmlformats.org/drawingml/2006/main">
             <a:pPr algn="l">
+              <a:buNone/>
               <a:defRPr sz="1500" b="0" i="0">
                 <a:solidFill>
                   <a:srgbClr val="101820"/>
@@ -4623,6 +4738,7 @@
           <a:lstStyle xmlns:a="http://schemas.openxmlformats.org/drawingml/2006/main"/>
           <a:p xmlns:a="http://schemas.openxmlformats.org/drawingml/2006/main">
             <a:pPr algn="l">
+              <a:buNone/>
               <a:defRPr sz="1350" b="1" i="0">
                 <a:solidFill>
                   <a:srgbClr val="0B3D52"/>
@@ -4704,6 +4820,7 @@
           <a:lstStyle xmlns:a="http://schemas.openxmlformats.org/drawingml/2006/main"/>
           <a:p xmlns:a="http://schemas.openxmlformats.org/drawingml/2006/main">
             <a:pPr algn="l">
+              <a:buNone/>
               <a:defRPr sz="2550" b="1" i="0">
                 <a:solidFill>
                   <a:srgbClr val="F97316"/>
@@ -4754,6 +4871,7 @@
           <a:lstStyle xmlns:a="http://schemas.openxmlformats.org/drawingml/2006/main"/>
           <a:p xmlns:a="http://schemas.openxmlformats.org/drawingml/2006/main">
             <a:pPr algn="l">
+              <a:buNone/>
               <a:defRPr sz="1200" b="0" i="0">
                 <a:solidFill>
                   <a:srgbClr val="56616F"/>
@@ -4804,6 +4922,7 @@
           <a:lstStyle xmlns:a="http://schemas.openxmlformats.org/drawingml/2006/main"/>
           <a:p xmlns:a="http://schemas.openxmlformats.org/drawingml/2006/main">
             <a:pPr algn="ctr">
+              <a:buNone/>
               <a:defRPr sz="2550" b="1" i="0">
                 <a:solidFill>
                   <a:srgbClr val="167CA5"/>
@@ -4854,6 +4973,7 @@
           <a:lstStyle xmlns:a="http://schemas.openxmlformats.org/drawingml/2006/main"/>
           <a:p xmlns:a="http://schemas.openxmlformats.org/drawingml/2006/main">
             <a:pPr algn="l">
+              <a:buNone/>
               <a:defRPr sz="2550" b="1" i="0">
                 <a:solidFill>
                   <a:srgbClr val="101820"/>
@@ -4904,6 +5024,7 @@
           <a:lstStyle xmlns:a="http://schemas.openxmlformats.org/drawingml/2006/main"/>
           <a:p xmlns:a="http://schemas.openxmlformats.org/drawingml/2006/main">
             <a:pPr algn="l">
+              <a:buNone/>
               <a:defRPr sz="1200" b="0" i="0">
                 <a:solidFill>
                   <a:srgbClr val="56616F"/>
@@ -4954,6 +5075,7 @@
           <a:lstStyle xmlns:a="http://schemas.openxmlformats.org/drawingml/2006/main"/>
           <a:p xmlns:a="http://schemas.openxmlformats.org/drawingml/2006/main">
             <a:pPr algn="l">
+              <a:buNone/>
               <a:defRPr sz="1500" b="0" i="0">
                 <a:solidFill>
                   <a:srgbClr val="101820"/>
@@ -4971,6 +5093,7 @@
           </a:p>
           <a:p xmlns:a="http://schemas.openxmlformats.org/drawingml/2006/main">
             <a:pPr algn="l">
+              <a:buNone/>
               <a:defRPr sz="1500" b="0" i="0">
                 <a:solidFill>
                   <a:srgbClr val="101820"/>
@@ -4988,6 +5111,7 @@
           </a:p>
           <a:p xmlns:a="http://schemas.openxmlformats.org/drawingml/2006/main">
             <a:pPr algn="l">
+              <a:buNone/>
               <a:defRPr sz="1500" b="0" i="0">
                 <a:solidFill>
                   <a:srgbClr val="101820"/>
@@ -5069,6 +5193,7 @@
           <a:lstStyle xmlns:a="http://schemas.openxmlformats.org/drawingml/2006/main"/>
           <a:p xmlns:a="http://schemas.openxmlformats.org/drawingml/2006/main">
             <a:pPr algn="l">
+              <a:buNone/>
               <a:defRPr sz="1725" b="1" i="0">
                 <a:solidFill>
                   <a:srgbClr val="101820"/>
@@ -5148,6 +5273,7 @@
           <a:lstStyle xmlns:a="http://schemas.openxmlformats.org/drawingml/2006/main"/>
           <a:p xmlns:a="http://schemas.openxmlformats.org/drawingml/2006/main">
             <a:pPr algn="l">
+              <a:buNone/>
               <a:defRPr sz="975" b="1" i="0">
                 <a:solidFill>
                   <a:srgbClr val="56616F"/>
@@ -5198,6 +5324,7 @@
           <a:lstStyle xmlns:a="http://schemas.openxmlformats.org/drawingml/2006/main"/>
           <a:p xmlns:a="http://schemas.openxmlformats.org/drawingml/2006/main">
             <a:pPr algn="r">
+              <a:buNone/>
               <a:defRPr sz="975" b="1" i="0">
                 <a:solidFill>
                   <a:srgbClr val="56616F"/>
@@ -5279,6 +5406,7 @@
           <a:lstStyle xmlns:a="http://schemas.openxmlformats.org/drawingml/2006/main"/>
           <a:p xmlns:a="http://schemas.openxmlformats.org/drawingml/2006/main">
             <a:pPr algn="l">
+              <a:buNone/>
               <a:defRPr sz="825" b="0" i="0">
                 <a:solidFill>
                   <a:srgbClr val="56616F"/>
@@ -5329,6 +5457,7 @@
           <a:lstStyle xmlns:a="http://schemas.openxmlformats.org/drawingml/2006/main"/>
           <a:p xmlns:a="http://schemas.openxmlformats.org/drawingml/2006/main">
             <a:pPr algn="r">
+              <a:buNone/>
               <a:defRPr sz="825" b="0" i="0">
                 <a:solidFill>
                   <a:srgbClr val="56616F"/>
@@ -5379,6 +5508,7 @@
           <a:lstStyle xmlns:a="http://schemas.openxmlformats.org/drawingml/2006/main"/>
           <a:p xmlns:a="http://schemas.openxmlformats.org/drawingml/2006/main">
             <a:pPr algn="l">
+              <a:buNone/>
               <a:defRPr sz="3000" b="1" i="0">
                 <a:solidFill>
                   <a:srgbClr val="101820"/>
@@ -5429,6 +5559,7 @@
           <a:lstStyle xmlns:a="http://schemas.openxmlformats.org/drawingml/2006/main"/>
           <a:p xmlns:a="http://schemas.openxmlformats.org/drawingml/2006/main">
             <a:pPr algn="l">
+              <a:buNone/>
               <a:defRPr sz="1350" b="0" i="0">
                 <a:solidFill>
                   <a:srgbClr val="56616F"/>
@@ -5479,6 +5610,7 @@
           <a:lstStyle xmlns:a="http://schemas.openxmlformats.org/drawingml/2006/main"/>
           <a:p xmlns:a="http://schemas.openxmlformats.org/drawingml/2006/main">
             <a:pPr algn="l">
+              <a:buNone/>
               <a:defRPr sz="1350" b="1" i="0">
                 <a:solidFill>
                   <a:srgbClr val="0B3D52"/>
@@ -5560,6 +5692,7 @@
           <a:lstStyle xmlns:a="http://schemas.openxmlformats.org/drawingml/2006/main"/>
           <a:p xmlns:a="http://schemas.openxmlformats.org/drawingml/2006/main">
             <a:pPr algn="l">
+              <a:buNone/>
               <a:defRPr sz="1425" b="1" i="0">
                 <a:solidFill>
                   <a:srgbClr val="101820"/>
@@ -5610,6 +5743,7 @@
           <a:lstStyle xmlns:a="http://schemas.openxmlformats.org/drawingml/2006/main"/>
           <a:p xmlns:a="http://schemas.openxmlformats.org/drawingml/2006/main">
             <a:pPr algn="r">
+              <a:buNone/>
               <a:defRPr sz="1500" b="1" i="0">
                 <a:solidFill>
                   <a:srgbClr val="101820"/>
@@ -5660,6 +5794,7 @@
           <a:lstStyle xmlns:a="http://schemas.openxmlformats.org/drawingml/2006/main"/>
           <a:p xmlns:a="http://schemas.openxmlformats.org/drawingml/2006/main">
             <a:pPr algn="r">
+              <a:buNone/>
               <a:defRPr sz="1200" b="1" i="0">
                 <a:solidFill>
                   <a:srgbClr val="15803D"/>
@@ -5710,6 +5845,7 @@
           <a:lstStyle xmlns:a="http://schemas.openxmlformats.org/drawingml/2006/main"/>
           <a:p xmlns:a="http://schemas.openxmlformats.org/drawingml/2006/main">
             <a:pPr algn="l">
+              <a:buNone/>
               <a:defRPr sz="1425" b="1" i="0">
                 <a:solidFill>
                   <a:srgbClr val="101820"/>
@@ -5760,6 +5896,7 @@
           <a:lstStyle xmlns:a="http://schemas.openxmlformats.org/drawingml/2006/main"/>
           <a:p xmlns:a="http://schemas.openxmlformats.org/drawingml/2006/main">
             <a:pPr algn="r">
+              <a:buNone/>
               <a:defRPr sz="1500" b="1" i="0">
                 <a:solidFill>
                   <a:srgbClr val="101820"/>
@@ -5810,6 +5947,7 @@
           <a:lstStyle xmlns:a="http://schemas.openxmlformats.org/drawingml/2006/main"/>
           <a:p xmlns:a="http://schemas.openxmlformats.org/drawingml/2006/main">
             <a:pPr algn="r">
+              <a:buNone/>
               <a:defRPr sz="1200" b="1" i="0">
                 <a:solidFill>
                   <a:srgbClr val="15803D"/>
@@ -5891,6 +6029,7 @@
           <a:lstStyle xmlns:a="http://schemas.openxmlformats.org/drawingml/2006/main"/>
           <a:p xmlns:a="http://schemas.openxmlformats.org/drawingml/2006/main">
             <a:pPr algn="l">
+              <a:buNone/>
               <a:defRPr sz="1425" b="1" i="0">
                 <a:solidFill>
                   <a:srgbClr val="101820"/>
@@ -5941,6 +6080,7 @@
           <a:lstStyle xmlns:a="http://schemas.openxmlformats.org/drawingml/2006/main"/>
           <a:p xmlns:a="http://schemas.openxmlformats.org/drawingml/2006/main">
             <a:pPr algn="r">
+              <a:buNone/>
               <a:defRPr sz="1500" b="1" i="0">
                 <a:solidFill>
                   <a:srgbClr val="101820"/>
@@ -5991,6 +6131,7 @@
           <a:lstStyle xmlns:a="http://schemas.openxmlformats.org/drawingml/2006/main"/>
           <a:p xmlns:a="http://schemas.openxmlformats.org/drawingml/2006/main">
             <a:pPr algn="r">
+              <a:buNone/>
               <a:defRPr sz="1200" b="1" i="0">
                 <a:solidFill>
                   <a:srgbClr val="F97316"/>
@@ -6041,6 +6182,7 @@
           <a:lstStyle xmlns:a="http://schemas.openxmlformats.org/drawingml/2006/main"/>
           <a:p xmlns:a="http://schemas.openxmlformats.org/drawingml/2006/main">
             <a:pPr algn="l">
+              <a:buNone/>
               <a:defRPr sz="1425" b="1" i="0">
                 <a:solidFill>
                   <a:srgbClr val="101820"/>
@@ -6091,6 +6233,7 @@
           <a:lstStyle xmlns:a="http://schemas.openxmlformats.org/drawingml/2006/main"/>
           <a:p xmlns:a="http://schemas.openxmlformats.org/drawingml/2006/main">
             <a:pPr algn="r">
+              <a:buNone/>
               <a:defRPr sz="1500" b="1" i="0">
                 <a:solidFill>
                   <a:srgbClr val="101820"/>
@@ -6103,7 +6246,7 @@
                   <a:srgbClr val="101820"/>
                 </a:solidFill>
               </a:rPr>
-              <a:t>43</a:t>
+              <a:t>46</a:t>
             </a:r>
           </a:p>
         </p:txBody>
@@ -6141,6 +6284,7 @@
           <a:lstStyle xmlns:a="http://schemas.openxmlformats.org/drawingml/2006/main"/>
           <a:p xmlns:a="http://schemas.openxmlformats.org/drawingml/2006/main">
             <a:pPr algn="r">
+              <a:buNone/>
               <a:defRPr sz="1200" b="1" i="0">
                 <a:solidFill>
                   <a:srgbClr val="15803D"/>
@@ -6222,6 +6366,7 @@
           <a:lstStyle xmlns:a="http://schemas.openxmlformats.org/drawingml/2006/main"/>
           <a:p xmlns:a="http://schemas.openxmlformats.org/drawingml/2006/main">
             <a:pPr algn="l">
+              <a:buNone/>
               <a:defRPr sz="1425" b="1" i="0">
                 <a:solidFill>
                   <a:srgbClr val="101820"/>
@@ -6272,6 +6417,7 @@
           <a:lstStyle xmlns:a="http://schemas.openxmlformats.org/drawingml/2006/main"/>
           <a:p xmlns:a="http://schemas.openxmlformats.org/drawingml/2006/main">
             <a:pPr algn="r">
+              <a:buNone/>
               <a:defRPr sz="1500" b="1" i="0">
                 <a:solidFill>
                   <a:srgbClr val="101820"/>
@@ -6284,7 +6430,7 @@
                   <a:srgbClr val="101820"/>
                 </a:solidFill>
               </a:rPr>
-              <a:t>94.88%</a:t>
+              <a:t>93.88%</a:t>
             </a:r>
           </a:p>
         </p:txBody>
@@ -6322,6 +6468,7 @@
           <a:lstStyle xmlns:a="http://schemas.openxmlformats.org/drawingml/2006/main"/>
           <a:p xmlns:a="http://schemas.openxmlformats.org/drawingml/2006/main">
             <a:pPr algn="r">
+              <a:buNone/>
               <a:defRPr sz="1200" b="1" i="0">
                 <a:solidFill>
                   <a:srgbClr val="15803D"/>
@@ -6403,6 +6550,7 @@
           <a:lstStyle xmlns:a="http://schemas.openxmlformats.org/drawingml/2006/main"/>
           <a:p xmlns:a="http://schemas.openxmlformats.org/drawingml/2006/main">
             <a:pPr algn="l">
+              <a:buNone/>
               <a:defRPr sz="1350" b="1" i="0">
                 <a:solidFill>
                   <a:srgbClr val="0B3D52"/>
@@ -6453,6 +6601,7 @@
           <a:lstStyle xmlns:a="http://schemas.openxmlformats.org/drawingml/2006/main"/>
           <a:p xmlns:a="http://schemas.openxmlformats.org/drawingml/2006/main">
             <a:pPr algn="l">
+              <a:buNone/>
               <a:defRPr sz="1650" b="0" i="0">
                 <a:solidFill>
                   <a:srgbClr val="101820"/>
@@ -6475,6 +6624,7 @@
           </a:p>
           <a:p xmlns:a="http://schemas.openxmlformats.org/drawingml/2006/main">
             <a:pPr algn="l">
+              <a:buNone/>
               <a:defRPr sz="1650" b="0" i="0">
                 <a:solidFill>
                   <a:srgbClr val="101820"/>
@@ -6497,6 +6647,7 @@
           </a:p>
           <a:p xmlns:a="http://schemas.openxmlformats.org/drawingml/2006/main">
             <a:pPr algn="l">
+              <a:buNone/>
               <a:defRPr sz="1650" b="0" i="0">
                 <a:solidFill>
                   <a:srgbClr val="101820"/>
@@ -6519,6 +6670,7 @@
           </a:p>
           <a:p xmlns:a="http://schemas.openxmlformats.org/drawingml/2006/main">
             <a:pPr algn="l">
+              <a:buNone/>
               <a:defRPr sz="1650" b="0" i="0">
                 <a:solidFill>
                   <a:srgbClr val="101820"/>
@@ -6541,6 +6693,7 @@
           </a:p>
           <a:p xmlns:a="http://schemas.openxmlformats.org/drawingml/2006/main">
             <a:pPr algn="l">
+              <a:buNone/>
               <a:defRPr sz="1650" b="0" i="0">
                 <a:solidFill>
                   <a:srgbClr val="101820"/>
@@ -6591,6 +6744,7 @@
           <a:lstStyle xmlns:a="http://schemas.openxmlformats.org/drawingml/2006/main"/>
           <a:p xmlns:a="http://schemas.openxmlformats.org/drawingml/2006/main">
             <a:pPr algn="l">
+              <a:buNone/>
               <a:defRPr sz="1500" b="1" i="0">
                 <a:solidFill>
                   <a:srgbClr val="101820"/>
@@ -6670,6 +6824,7 @@
           <a:lstStyle xmlns:a="http://schemas.openxmlformats.org/drawingml/2006/main"/>
           <a:p xmlns:a="http://schemas.openxmlformats.org/drawingml/2006/main">
             <a:pPr algn="l">
+              <a:buNone/>
               <a:defRPr sz="975" b="1" i="0">
                 <a:solidFill>
                   <a:srgbClr val="56616F"/>
@@ -6720,6 +6875,7 @@
           <a:lstStyle xmlns:a="http://schemas.openxmlformats.org/drawingml/2006/main"/>
           <a:p xmlns:a="http://schemas.openxmlformats.org/drawingml/2006/main">
             <a:pPr algn="r">
+              <a:buNone/>
               <a:defRPr sz="975" b="1" i="0">
                 <a:solidFill>
                   <a:srgbClr val="56616F"/>
@@ -6801,6 +6957,7 @@
           <a:lstStyle xmlns:a="http://schemas.openxmlformats.org/drawingml/2006/main"/>
           <a:p xmlns:a="http://schemas.openxmlformats.org/drawingml/2006/main">
             <a:pPr algn="l">
+              <a:buNone/>
               <a:defRPr sz="825" b="0" i="0">
                 <a:solidFill>
                   <a:srgbClr val="56616F"/>
@@ -6851,6 +7008,7 @@
           <a:lstStyle xmlns:a="http://schemas.openxmlformats.org/drawingml/2006/main"/>
           <a:p xmlns:a="http://schemas.openxmlformats.org/drawingml/2006/main">
             <a:pPr algn="r">
+              <a:buNone/>
               <a:defRPr sz="825" b="0" i="0">
                 <a:solidFill>
                   <a:srgbClr val="56616F"/>
@@ -6901,6 +7059,7 @@
           <a:lstStyle xmlns:a="http://schemas.openxmlformats.org/drawingml/2006/main"/>
           <a:p xmlns:a="http://schemas.openxmlformats.org/drawingml/2006/main">
             <a:pPr algn="l">
+              <a:buNone/>
               <a:defRPr sz="3000" b="1" i="0">
                 <a:solidFill>
                   <a:srgbClr val="101820"/>
@@ -6951,6 +7110,7 @@
           <a:lstStyle xmlns:a="http://schemas.openxmlformats.org/drawingml/2006/main"/>
           <a:p xmlns:a="http://schemas.openxmlformats.org/drawingml/2006/main">
             <a:pPr algn="l">
+              <a:buNone/>
               <a:defRPr sz="1350" b="0" i="0">
                 <a:solidFill>
                   <a:srgbClr val="56616F"/>
@@ -7063,6 +7223,7 @@
           <a:lstStyle xmlns:a="http://schemas.openxmlformats.org/drawingml/2006/main"/>
           <a:p xmlns:a="http://schemas.openxmlformats.org/drawingml/2006/main">
             <a:pPr algn="ctr">
+              <a:buNone/>
               <a:defRPr sz="1200" b="1" i="0">
                 <a:solidFill>
                   <a:srgbClr val="56616F"/>
@@ -7113,6 +7274,7 @@
           <a:lstStyle xmlns:a="http://schemas.openxmlformats.org/drawingml/2006/main"/>
           <a:p xmlns:a="http://schemas.openxmlformats.org/drawingml/2006/main">
             <a:pPr algn="ctr">
+              <a:buNone/>
               <a:defRPr sz="1875" b="1" i="0">
                 <a:solidFill>
                   <a:srgbClr val="101820"/>
@@ -7163,6 +7325,7 @@
           <a:lstStyle xmlns:a="http://schemas.openxmlformats.org/drawingml/2006/main"/>
           <a:p xmlns:a="http://schemas.openxmlformats.org/drawingml/2006/main">
             <a:pPr algn="ctr">
+              <a:buNone/>
               <a:defRPr sz="1500" b="0" i="0">
                 <a:solidFill>
                   <a:srgbClr val="101820"/>
@@ -7180,6 +7343,7 @@
           </a:p>
           <a:p xmlns:a="http://schemas.openxmlformats.org/drawingml/2006/main">
             <a:pPr algn="ctr">
+              <a:buNone/>
               <a:defRPr sz="1500" b="0" i="0">
                 <a:solidFill>
                   <a:srgbClr val="101820"/>
@@ -7197,6 +7361,7 @@
           </a:p>
           <a:p xmlns:a="http://schemas.openxmlformats.org/drawingml/2006/main">
             <a:pPr algn="ctr">
+              <a:buNone/>
               <a:defRPr sz="1500" b="0" i="0">
                 <a:solidFill>
                   <a:srgbClr val="101820"/>
@@ -7278,6 +7443,7 @@
           <a:lstStyle xmlns:a="http://schemas.openxmlformats.org/drawingml/2006/main"/>
           <a:p xmlns:a="http://schemas.openxmlformats.org/drawingml/2006/main">
             <a:pPr algn="ctr">
+              <a:buNone/>
               <a:defRPr sz="1200" b="1" i="0">
                 <a:solidFill>
                   <a:srgbClr val="56616F"/>
@@ -7328,6 +7494,7 @@
           <a:lstStyle xmlns:a="http://schemas.openxmlformats.org/drawingml/2006/main"/>
           <a:p xmlns:a="http://schemas.openxmlformats.org/drawingml/2006/main">
             <a:pPr algn="ctr">
+              <a:buNone/>
               <a:defRPr sz="1875" b="1" i="0">
                 <a:solidFill>
                   <a:srgbClr val="101820"/>
@@ -7340,7 +7507,7 @@
                   <a:srgbClr val="101820"/>
                 </a:solidFill>
               </a:rPr>
-              <a:t>Protect liquidity</a:t>
+              <a:t>Activate rapid-run plan</a:t>
             </a:r>
           </a:p>
         </p:txBody>
@@ -7378,6 +7545,7 @@
           <a:lstStyle xmlns:a="http://schemas.openxmlformats.org/drawingml/2006/main"/>
           <a:p xmlns:a="http://schemas.openxmlformats.org/drawingml/2006/main">
             <a:pPr algn="ctr">
+              <a:buNone/>
               <a:defRPr sz="1500" b="0" i="0">
                 <a:solidFill>
                   <a:srgbClr val="101820"/>
@@ -7395,6 +7563,7 @@
           </a:p>
           <a:p xmlns:a="http://schemas.openxmlformats.org/drawingml/2006/main">
             <a:pPr algn="ctr">
+              <a:buNone/>
               <a:defRPr sz="1500" b="0" i="0">
                 <a:solidFill>
                   <a:srgbClr val="101820"/>
@@ -7412,6 +7581,7 @@
           </a:p>
           <a:p xmlns:a="http://schemas.openxmlformats.org/drawingml/2006/main">
             <a:pPr algn="ctr">
+              <a:buNone/>
               <a:defRPr sz="1500" b="0" i="0">
                 <a:solidFill>
                   <a:srgbClr val="101820"/>
@@ -7424,7 +7594,7 @@
                   <a:srgbClr val="101820"/>
                 </a:solidFill>
               </a:rPr>
-              <a:t>Monitor runoff triggers</a:t>
+              <a:t>Rehearse seven-day response</a:t>
             </a:r>
           </a:p>
         </p:txBody>
@@ -7493,6 +7663,7 @@
           <a:lstStyle xmlns:a="http://schemas.openxmlformats.org/drawingml/2006/main"/>
           <a:p xmlns:a="http://schemas.openxmlformats.org/drawingml/2006/main">
             <a:pPr algn="ctr">
+              <a:buNone/>
               <a:defRPr sz="1200" b="1" i="0">
                 <a:solidFill>
                   <a:srgbClr val="56616F"/>
@@ -7543,6 +7714,7 @@
           <a:lstStyle xmlns:a="http://schemas.openxmlformats.org/drawingml/2006/main"/>
           <a:p xmlns:a="http://schemas.openxmlformats.org/drawingml/2006/main">
             <a:pPr algn="ctr">
+              <a:buNone/>
               <a:defRPr sz="1875" b="1" i="0">
                 <a:solidFill>
                   <a:srgbClr val="101820"/>
@@ -7593,6 +7765,7 @@
           <a:lstStyle xmlns:a="http://schemas.openxmlformats.org/drawingml/2006/main"/>
           <a:p xmlns:a="http://schemas.openxmlformats.org/drawingml/2006/main">
             <a:pPr algn="ctr">
+              <a:buNone/>
               <a:defRPr sz="1500" b="0" i="0">
                 <a:solidFill>
                   <a:srgbClr val="101820"/>
@@ -7610,6 +7783,7 @@
           </a:p>
           <a:p xmlns:a="http://schemas.openxmlformats.org/drawingml/2006/main">
             <a:pPr algn="ctr">
+              <a:buNone/>
               <a:defRPr sz="1500" b="0" i="0">
                 <a:solidFill>
                   <a:srgbClr val="101820"/>
@@ -7627,6 +7801,7 @@
           </a:p>
           <a:p xmlns:a="http://schemas.openxmlformats.org/drawingml/2006/main">
             <a:pPr algn="ctr">
+              <a:buNone/>
               <a:defRPr sz="1500" b="0" i="0">
                 <a:solidFill>
                   <a:srgbClr val="101820"/>
@@ -7708,6 +7883,7 @@
           <a:lstStyle xmlns:a="http://schemas.openxmlformats.org/drawingml/2006/main"/>
           <a:p xmlns:a="http://schemas.openxmlformats.org/drawingml/2006/main">
             <a:pPr algn="ctr">
+              <a:buNone/>
               <a:defRPr sz="1800" b="1" i="0">
                 <a:solidFill>
                   <a:srgbClr val="FFFFFF"/>
@@ -7720,7 +7896,7 @@
                   <a:srgbClr val="FFFFFF"/>
                 </a:solidFill>
               </a:rPr>
-              <a:t>DECISION | Approve the sequence, assign accountable owners, and require post-trade EVE, NII, liquidity and FX revalidation.</a:t>
+              <a:t>DECISION | Approve the sequence, assign owners, activate rapid-run readiness and require post-trade risk revalidation.</a:t>
             </a:r>
           </a:p>
         </p:txBody>
@@ -7787,6 +7963,7 @@
           <a:lstStyle xmlns:a="http://schemas.openxmlformats.org/drawingml/2006/main"/>
           <a:p xmlns:a="http://schemas.openxmlformats.org/drawingml/2006/main">
             <a:pPr algn="l">
+              <a:buNone/>
               <a:defRPr sz="975" b="1" i="0">
                 <a:solidFill>
                   <a:srgbClr val="56616F"/>
@@ -7837,6 +8014,7 @@
           <a:lstStyle xmlns:a="http://schemas.openxmlformats.org/drawingml/2006/main"/>
           <a:p xmlns:a="http://schemas.openxmlformats.org/drawingml/2006/main">
             <a:pPr algn="r">
+              <a:buNone/>
               <a:defRPr sz="975" b="1" i="0">
                 <a:solidFill>
                   <a:srgbClr val="56616F"/>
@@ -7918,6 +8096,7 @@
           <a:lstStyle xmlns:a="http://schemas.openxmlformats.org/drawingml/2006/main"/>
           <a:p xmlns:a="http://schemas.openxmlformats.org/drawingml/2006/main">
             <a:pPr algn="l">
+              <a:buNone/>
               <a:defRPr sz="825" b="0" i="0">
                 <a:solidFill>
                   <a:srgbClr val="56616F"/>
@@ -7968,6 +8147,7 @@
           <a:lstStyle xmlns:a="http://schemas.openxmlformats.org/drawingml/2006/main"/>
           <a:p xmlns:a="http://schemas.openxmlformats.org/drawingml/2006/main">
             <a:pPr algn="r">
+              <a:buNone/>
               <a:defRPr sz="825" b="0" i="0">
                 <a:solidFill>
                   <a:srgbClr val="56616F"/>
@@ -8018,6 +8198,7 @@
           <a:lstStyle xmlns:a="http://schemas.openxmlformats.org/drawingml/2006/main"/>
           <a:p xmlns:a="http://schemas.openxmlformats.org/drawingml/2006/main">
             <a:pPr algn="l">
+              <a:buNone/>
               <a:defRPr sz="3000" b="1" i="0">
                 <a:solidFill>
                   <a:srgbClr val="101820"/>
@@ -8030,7 +8211,7 @@
                   <a:srgbClr val="101820"/>
                 </a:solidFill>
               </a:rPr>
-              <a:t>Hedge FX now; protect liquidity next</a:t>
+              <a:t>Hedge FX now; activate rapid-run readiness next</a:t>
             </a:r>
           </a:p>
         </p:txBody>
@@ -8068,6 +8249,7 @@
           <a:lstStyle xmlns:a="http://schemas.openxmlformats.org/drawingml/2006/main"/>
           <a:p xmlns:a="http://schemas.openxmlformats.org/drawingml/2006/main">
             <a:pPr algn="l">
+              <a:buNone/>
               <a:defRPr sz="1350" b="0" i="0">
                 <a:solidFill>
                   <a:srgbClr val="56616F"/>
@@ -8080,7 +8262,7 @@
                   <a:srgbClr val="56616F"/>
                 </a:solidFill>
               </a:rPr>
-              <a:t>The formal breach is actionable, while liquidity requires a management buffer response.</a:t>
+              <a:t>The formal FX breach is actionable; the severe liquidity test demands operational readiness.</a:t>
             </a:r>
           </a:p>
         </p:txBody>
@@ -8149,6 +8331,7 @@
           <a:lstStyle xmlns:a="http://schemas.openxmlformats.org/drawingml/2006/main"/>
           <a:p xmlns:a="http://schemas.openxmlformats.org/drawingml/2006/main">
             <a:pPr algn="l">
+              <a:buNone/>
               <a:defRPr sz="3600" b="1" i="0">
                 <a:solidFill>
                   <a:srgbClr val="F97316"/>
@@ -8199,6 +8382,7 @@
           <a:lstStyle xmlns:a="http://schemas.openxmlformats.org/drawingml/2006/main"/>
           <a:p xmlns:a="http://schemas.openxmlformats.org/drawingml/2006/main">
             <a:pPr algn="l">
+              <a:buNone/>
               <a:defRPr sz="1650" b="1" i="0">
                 <a:solidFill>
                   <a:srgbClr val="101820"/>
@@ -8280,6 +8464,7 @@
           <a:lstStyle xmlns:a="http://schemas.openxmlformats.org/drawingml/2006/main"/>
           <a:p xmlns:a="http://schemas.openxmlformats.org/drawingml/2006/main">
             <a:pPr algn="l">
+              <a:buNone/>
               <a:defRPr sz="1200" b="0" i="0">
                 <a:solidFill>
                   <a:srgbClr val="56616F"/>
@@ -8361,6 +8546,7 @@
           <a:lstStyle xmlns:a="http://schemas.openxmlformats.org/drawingml/2006/main"/>
           <a:p xmlns:a="http://schemas.openxmlformats.org/drawingml/2006/main">
             <a:pPr algn="l">
+              <a:buNone/>
               <a:defRPr sz="3600" b="1" i="0">
                 <a:solidFill>
                   <a:srgbClr val="F97316"/>
@@ -8373,7 +8559,7 @@
                   <a:srgbClr val="F97316"/>
                 </a:solidFill>
               </a:rPr>
-              <a:t>94.8%</a:t>
+              <a:t>78.1%</a:t>
             </a:r>
           </a:p>
         </p:txBody>
@@ -8411,6 +8597,7 @@
           <a:lstStyle xmlns:a="http://schemas.openxmlformats.org/drawingml/2006/main"/>
           <a:p xmlns:a="http://schemas.openxmlformats.org/drawingml/2006/main">
             <a:pPr algn="l">
+              <a:buNone/>
               <a:defRPr sz="1650" b="1" i="0">
                 <a:solidFill>
                   <a:srgbClr val="101820"/>
@@ -8423,7 +8610,7 @@
                   <a:srgbClr val="101820"/>
                 </a:solidFill>
               </a:rPr>
-              <a:t>Combined LCR proxy</a:t>
+              <a:t>Rapid-run LCR proxy</a:t>
             </a:r>
           </a:p>
         </p:txBody>
@@ -8492,6 +8679,7 @@
           <a:lstStyle xmlns:a="http://schemas.openxmlformats.org/drawingml/2006/main"/>
           <a:p xmlns:a="http://schemas.openxmlformats.org/drawingml/2006/main">
             <a:pPr algn="l">
+              <a:buNone/>
               <a:defRPr sz="1200" b="0" i="0">
                 <a:solidFill>
                   <a:srgbClr val="56616F"/>
@@ -8504,7 +8692,7 @@
                   <a:srgbClr val="56616F"/>
                 </a:solidFill>
               </a:rPr>
-              <a:t>Below 100% in combined stress</a:t>
+              <a:t>7-day survival | exploratory</a:t>
             </a:r>
           </a:p>
         </p:txBody>
@@ -8573,6 +8761,7 @@
           <a:lstStyle xmlns:a="http://schemas.openxmlformats.org/drawingml/2006/main"/>
           <a:p xmlns:a="http://schemas.openxmlformats.org/drawingml/2006/main">
             <a:pPr algn="l">
+              <a:buNone/>
               <a:defRPr sz="3600" b="1" i="0">
                 <a:solidFill>
                   <a:srgbClr val="15803D"/>
@@ -8623,6 +8812,7 @@
           <a:lstStyle xmlns:a="http://schemas.openxmlformats.org/drawingml/2006/main"/>
           <a:p xmlns:a="http://schemas.openxmlformats.org/drawingml/2006/main">
             <a:pPr algn="l">
+              <a:buNone/>
               <a:defRPr sz="1650" b="1" i="0">
                 <a:solidFill>
                   <a:srgbClr val="101820"/>
@@ -8704,6 +8894,7 @@
           <a:lstStyle xmlns:a="http://schemas.openxmlformats.org/drawingml/2006/main"/>
           <a:p xmlns:a="http://schemas.openxmlformats.org/drawingml/2006/main">
             <a:pPr algn="l">
+              <a:buNone/>
               <a:defRPr sz="1200" b="0" i="0">
                 <a:solidFill>
                   <a:srgbClr val="56616F"/>
@@ -8754,6 +8945,7 @@
           <a:lstStyle xmlns:a="http://schemas.openxmlformats.org/drawingml/2006/main"/>
           <a:p xmlns:a="http://schemas.openxmlformats.org/drawingml/2006/main">
             <a:pPr algn="l">
+              <a:buNone/>
               <a:defRPr sz="2100" b="1" i="0">
                 <a:solidFill>
                   <a:srgbClr val="101820"/>
@@ -8766,7 +8958,7 @@
                   <a:srgbClr val="101820"/>
                 </a:solidFill>
               </a:rPr>
-              <a:t>Decision ask | Approve the FX remediation target, preserve the liquidity buffer, and authorize validation of TRY IRS sizing before execution.</a:t>
+              <a:t>Decision ask | Approve FX remediation, preserve the liquidity buffer, activate the rapid-run contingency plan, and validate TRY IRS sizing.</a:t>
             </a:r>
           </a:p>
         </p:txBody>
@@ -8804,6 +8996,7 @@
           <a:lstStyle xmlns:a="http://schemas.openxmlformats.org/drawingml/2006/main"/>
           <a:p xmlns:a="http://schemas.openxmlformats.org/drawingml/2006/main">
             <a:pPr algn="l">
+              <a:buNone/>
               <a:defRPr sz="1275" b="0" i="0">
                 <a:solidFill>
                   <a:srgbClr val="56616F"/>
@@ -8883,6 +9076,7 @@
           <a:lstStyle xmlns:a="http://schemas.openxmlformats.org/drawingml/2006/main"/>
           <a:p xmlns:a="http://schemas.openxmlformats.org/drawingml/2006/main">
             <a:pPr algn="l">
+              <a:buNone/>
               <a:defRPr sz="975" b="1" i="0">
                 <a:solidFill>
                   <a:srgbClr val="56616F"/>
@@ -8933,6 +9127,7 @@
           <a:lstStyle xmlns:a="http://schemas.openxmlformats.org/drawingml/2006/main"/>
           <a:p xmlns:a="http://schemas.openxmlformats.org/drawingml/2006/main">
             <a:pPr algn="r">
+              <a:buNone/>
               <a:defRPr sz="975" b="1" i="0">
                 <a:solidFill>
                   <a:srgbClr val="56616F"/>
@@ -9014,6 +9209,7 @@
           <a:lstStyle xmlns:a="http://schemas.openxmlformats.org/drawingml/2006/main"/>
           <a:p xmlns:a="http://schemas.openxmlformats.org/drawingml/2006/main">
             <a:pPr algn="l">
+              <a:buNone/>
               <a:defRPr sz="825" b="0" i="0">
                 <a:solidFill>
                   <a:srgbClr val="56616F"/>
@@ -9064,6 +9260,7 @@
           <a:lstStyle xmlns:a="http://schemas.openxmlformats.org/drawingml/2006/main"/>
           <a:p xmlns:a="http://schemas.openxmlformats.org/drawingml/2006/main">
             <a:pPr algn="r">
+              <a:buNone/>
               <a:defRPr sz="825" b="0" i="0">
                 <a:solidFill>
                   <a:srgbClr val="56616F"/>
@@ -9114,6 +9311,7 @@
           <a:lstStyle xmlns:a="http://schemas.openxmlformats.org/drawingml/2006/main"/>
           <a:p xmlns:a="http://schemas.openxmlformats.org/drawingml/2006/main">
             <a:pPr algn="l">
+              <a:buNone/>
               <a:defRPr sz="3000" b="1" i="0">
                 <a:solidFill>
                   <a:srgbClr val="101820"/>
@@ -9164,6 +9362,7 @@
           <a:lstStyle xmlns:a="http://schemas.openxmlformats.org/drawingml/2006/main"/>
           <a:p xmlns:a="http://schemas.openxmlformats.org/drawingml/2006/main">
             <a:pPr algn="l">
+              <a:buNone/>
               <a:defRPr sz="1350" b="0" i="0">
                 <a:solidFill>
                   <a:srgbClr val="56616F"/>
@@ -9245,6 +9444,7 @@
           <a:lstStyle xmlns:a="http://schemas.openxmlformats.org/drawingml/2006/main"/>
           <a:p xmlns:a="http://schemas.openxmlformats.org/drawingml/2006/main">
             <a:pPr algn="l">
+              <a:buNone/>
               <a:defRPr sz="1350" b="1" i="0">
                 <a:solidFill>
                   <a:srgbClr val="0B3D52"/>
@@ -9326,6 +9526,7 @@
           <a:lstStyle xmlns:a="http://schemas.openxmlformats.org/drawingml/2006/main"/>
           <a:p xmlns:a="http://schemas.openxmlformats.org/drawingml/2006/main">
             <a:pPr algn="l">
+              <a:buNone/>
               <a:defRPr sz="1650" b="0" i="0">
                 <a:solidFill>
                   <a:srgbClr val="101820"/>
@@ -9343,6 +9544,7 @@
           </a:p>
           <a:p xmlns:a="http://schemas.openxmlformats.org/drawingml/2006/main">
             <a:pPr algn="l">
+              <a:buNone/>
               <a:defRPr sz="1650" b="0" i="0">
                 <a:solidFill>
                   <a:srgbClr val="101820"/>
@@ -9360,6 +9562,7 @@
           </a:p>
           <a:p xmlns:a="http://schemas.openxmlformats.org/drawingml/2006/main">
             <a:pPr algn="l">
+              <a:buNone/>
               <a:defRPr sz="1650" b="0" i="0">
                 <a:solidFill>
                   <a:srgbClr val="101820"/>
@@ -9410,6 +9613,7 @@
           <a:lstStyle xmlns:a="http://schemas.openxmlformats.org/drawingml/2006/main"/>
           <a:p xmlns:a="http://schemas.openxmlformats.org/drawingml/2006/main">
             <a:pPr algn="l">
+              <a:buNone/>
               <a:defRPr sz="1125" b="1" i="0">
                 <a:solidFill>
                   <a:srgbClr val="56616F"/>
@@ -9460,6 +9664,7 @@
           <a:lstStyle xmlns:a="http://schemas.openxmlformats.org/drawingml/2006/main"/>
           <a:p xmlns:a="http://schemas.openxmlformats.org/drawingml/2006/main">
             <a:pPr algn="ctr">
+              <a:buNone/>
               <a:defRPr sz="2550" b="1" i="0">
                 <a:solidFill>
                   <a:srgbClr val="167CA5"/>
@@ -9541,6 +9746,7 @@
           <a:lstStyle xmlns:a="http://schemas.openxmlformats.org/drawingml/2006/main"/>
           <a:p xmlns:a="http://schemas.openxmlformats.org/drawingml/2006/main">
             <a:pPr algn="l">
+              <a:buNone/>
               <a:defRPr sz="1350" b="1" i="0">
                 <a:solidFill>
                   <a:srgbClr val="0B3D52"/>
@@ -9622,6 +9828,7 @@
           <a:lstStyle xmlns:a="http://schemas.openxmlformats.org/drawingml/2006/main"/>
           <a:p xmlns:a="http://schemas.openxmlformats.org/drawingml/2006/main">
             <a:pPr algn="l">
+              <a:buNone/>
               <a:defRPr sz="1650" b="0" i="0">
                 <a:solidFill>
                   <a:srgbClr val="101820"/>
@@ -9639,6 +9846,7 @@
           </a:p>
           <a:p xmlns:a="http://schemas.openxmlformats.org/drawingml/2006/main">
             <a:pPr algn="l">
+              <a:buNone/>
               <a:defRPr sz="1650" b="0" i="0">
                 <a:solidFill>
                   <a:srgbClr val="101820"/>
@@ -9656,6 +9864,7 @@
           </a:p>
           <a:p xmlns:a="http://schemas.openxmlformats.org/drawingml/2006/main">
             <a:pPr algn="l">
+              <a:buNone/>
               <a:defRPr sz="1650" b="0" i="0">
                 <a:solidFill>
                   <a:srgbClr val="101820"/>
@@ -9706,6 +9915,7 @@
           <a:lstStyle xmlns:a="http://schemas.openxmlformats.org/drawingml/2006/main"/>
           <a:p xmlns:a="http://schemas.openxmlformats.org/drawingml/2006/main">
             <a:pPr algn="l">
+              <a:buNone/>
               <a:defRPr sz="1125" b="1" i="0">
                 <a:solidFill>
                   <a:srgbClr val="56616F"/>
@@ -9756,6 +9966,7 @@
           <a:lstStyle xmlns:a="http://schemas.openxmlformats.org/drawingml/2006/main"/>
           <a:p xmlns:a="http://schemas.openxmlformats.org/drawingml/2006/main">
             <a:pPr algn="ctr">
+              <a:buNone/>
               <a:defRPr sz="2550" b="1" i="0">
                 <a:solidFill>
                   <a:srgbClr val="167CA5"/>
@@ -9837,6 +10048,7 @@
           <a:lstStyle xmlns:a="http://schemas.openxmlformats.org/drawingml/2006/main"/>
           <a:p xmlns:a="http://schemas.openxmlformats.org/drawingml/2006/main">
             <a:pPr algn="l">
+              <a:buNone/>
               <a:defRPr sz="1350" b="1" i="0">
                 <a:solidFill>
                   <a:srgbClr val="0B3D52"/>
@@ -9918,6 +10130,7 @@
           <a:lstStyle xmlns:a="http://schemas.openxmlformats.org/drawingml/2006/main"/>
           <a:p xmlns:a="http://schemas.openxmlformats.org/drawingml/2006/main">
             <a:pPr algn="l">
+              <a:buNone/>
               <a:defRPr sz="1650" b="0" i="0">
                 <a:solidFill>
                   <a:srgbClr val="101820"/>
@@ -9935,6 +10148,7 @@
           </a:p>
           <a:p xmlns:a="http://schemas.openxmlformats.org/drawingml/2006/main">
             <a:pPr algn="l">
+              <a:buNone/>
               <a:defRPr sz="1650" b="0" i="0">
                 <a:solidFill>
                   <a:srgbClr val="101820"/>
@@ -9952,6 +10166,7 @@
           </a:p>
           <a:p xmlns:a="http://schemas.openxmlformats.org/drawingml/2006/main">
             <a:pPr algn="l">
+              <a:buNone/>
               <a:defRPr sz="1650" b="0" i="0">
                 <a:solidFill>
                   <a:srgbClr val="101820"/>
@@ -10002,6 +10217,7 @@
           <a:lstStyle xmlns:a="http://schemas.openxmlformats.org/drawingml/2006/main"/>
           <a:p xmlns:a="http://schemas.openxmlformats.org/drawingml/2006/main">
             <a:pPr algn="l">
+              <a:buNone/>
               <a:defRPr sz="1125" b="1" i="0">
                 <a:solidFill>
                   <a:srgbClr val="56616F"/>
@@ -10052,6 +10268,7 @@
           <a:lstStyle xmlns:a="http://schemas.openxmlformats.org/drawingml/2006/main"/>
           <a:p xmlns:a="http://schemas.openxmlformats.org/drawingml/2006/main">
             <a:pPr algn="l">
+              <a:buNone/>
               <a:defRPr sz="1650" b="1" i="0">
                 <a:solidFill>
                   <a:srgbClr val="101820"/>
@@ -10131,6 +10348,7 @@
           <a:lstStyle xmlns:a="http://schemas.openxmlformats.org/drawingml/2006/main"/>
           <a:p xmlns:a="http://schemas.openxmlformats.org/drawingml/2006/main">
             <a:pPr algn="l">
+              <a:buNone/>
               <a:defRPr sz="975" b="1" i="0">
                 <a:solidFill>
                   <a:srgbClr val="56616F"/>
@@ -10181,6 +10399,7 @@
           <a:lstStyle xmlns:a="http://schemas.openxmlformats.org/drawingml/2006/main"/>
           <a:p xmlns:a="http://schemas.openxmlformats.org/drawingml/2006/main">
             <a:pPr algn="r">
+              <a:buNone/>
               <a:defRPr sz="975" b="1" i="0">
                 <a:solidFill>
                   <a:srgbClr val="56616F"/>
@@ -10262,6 +10481,7 @@
           <a:lstStyle xmlns:a="http://schemas.openxmlformats.org/drawingml/2006/main"/>
           <a:p xmlns:a="http://schemas.openxmlformats.org/drawingml/2006/main">
             <a:pPr algn="l">
+              <a:buNone/>
               <a:defRPr sz="825" b="0" i="0">
                 <a:solidFill>
                   <a:srgbClr val="56616F"/>
@@ -10312,6 +10532,7 @@
           <a:lstStyle xmlns:a="http://schemas.openxmlformats.org/drawingml/2006/main"/>
           <a:p xmlns:a="http://schemas.openxmlformats.org/drawingml/2006/main">
             <a:pPr algn="r">
+              <a:buNone/>
               <a:defRPr sz="825" b="0" i="0">
                 <a:solidFill>
                   <a:srgbClr val="56616F"/>
@@ -10362,6 +10583,7 @@
           <a:lstStyle xmlns:a="http://schemas.openxmlformats.org/drawingml/2006/main"/>
           <a:p xmlns:a="http://schemas.openxmlformats.org/drawingml/2006/main">
             <a:pPr algn="l">
+              <a:buNone/>
               <a:defRPr sz="3000" b="1" i="0">
                 <a:solidFill>
                   <a:srgbClr val="101820"/>
@@ -10412,6 +10634,7 @@
           <a:lstStyle xmlns:a="http://schemas.openxmlformats.org/drawingml/2006/main"/>
           <a:p xmlns:a="http://schemas.openxmlformats.org/drawingml/2006/main">
             <a:pPr algn="l">
+              <a:buNone/>
               <a:defRPr sz="1350" b="0" i="0">
                 <a:solidFill>
                   <a:srgbClr val="56616F"/>
@@ -10431,7 +10654,7 @@
       </p:sp>
       <p:graphicFrame>
         <p:nvGraphicFramePr>
-          <p:cNvPr id="22" name="Chart"/>
+          <p:cNvPr id="24" name="Chart"/>
           <p:cNvGraphicFramePr/>
           <p:nvPr/>
         </p:nvGraphicFramePr>
@@ -10441,7 +10664,7 @@
         </p:xfrm>
         <a:graphic xmlns:a="http://schemas.openxmlformats.org/drawingml/2006/main">
           <a:graphicData uri="http://schemas.openxmlformats.org/drawingml/2006/chart">
-            <c:chart xmlns:r="http://schemas.openxmlformats.org/officeDocument/2006/relationships" xmlns:c="http://schemas.openxmlformats.org/drawingml/2006/chart" r:id="R5c48f92ac7774c5a"/>
+            <c:chart xmlns:r="http://schemas.openxmlformats.org/officeDocument/2006/relationships" xmlns:c="http://schemas.openxmlformats.org/drawingml/2006/chart" r:id="R19e00ebbc87340f3"/>
           </a:graphicData>
         </a:graphic>
       </p:graphicFrame>
@@ -10509,6 +10732,7 @@
           <a:lstStyle xmlns:a="http://schemas.openxmlformats.org/drawingml/2006/main"/>
           <a:p xmlns:a="http://schemas.openxmlformats.org/drawingml/2006/main">
             <a:pPr algn="l">
+              <a:buNone/>
               <a:defRPr sz="3150" b="1" i="0">
                 <a:solidFill>
                   <a:srgbClr val="101820"/>
@@ -10559,6 +10783,7 @@
           <a:lstStyle xmlns:a="http://schemas.openxmlformats.org/drawingml/2006/main"/>
           <a:p xmlns:a="http://schemas.openxmlformats.org/drawingml/2006/main">
             <a:pPr algn="l">
+              <a:buNone/>
               <a:defRPr sz="1650" b="1" i="0">
                 <a:solidFill>
                   <a:srgbClr val="0B3D52"/>
@@ -10640,6 +10865,7 @@
           <a:lstStyle xmlns:a="http://schemas.openxmlformats.org/drawingml/2006/main"/>
           <a:p xmlns:a="http://schemas.openxmlformats.org/drawingml/2006/main">
             <a:pPr algn="l">
+              <a:buNone/>
               <a:defRPr sz="1725" b="0" i="0">
                 <a:solidFill>
                   <a:srgbClr val="101820"/>
@@ -10657,6 +10883,7 @@
           </a:p>
           <a:p xmlns:a="http://schemas.openxmlformats.org/drawingml/2006/main">
             <a:pPr algn="l">
+              <a:buNone/>
               <a:defRPr sz="1725" b="0" i="0">
                 <a:solidFill>
                   <a:srgbClr val="101820"/>
@@ -10679,6 +10906,7 @@
           </a:p>
           <a:p xmlns:a="http://schemas.openxmlformats.org/drawingml/2006/main">
             <a:pPr algn="l">
+              <a:buNone/>
               <a:defRPr sz="1725" b="0" i="0">
                 <a:solidFill>
                   <a:srgbClr val="101820"/>
@@ -10696,6 +10924,7 @@
           </a:p>
           <a:p xmlns:a="http://schemas.openxmlformats.org/drawingml/2006/main">
             <a:pPr algn="l">
+              <a:buNone/>
               <a:defRPr sz="1725" b="0" i="0">
                 <a:solidFill>
                   <a:srgbClr val="101820"/>
@@ -10746,6 +10975,7 @@
           <a:lstStyle xmlns:a="http://schemas.openxmlformats.org/drawingml/2006/main"/>
           <a:p xmlns:a="http://schemas.openxmlformats.org/drawingml/2006/main">
             <a:pPr algn="l">
+              <a:buNone/>
               <a:defRPr sz="1500" b="1" i="0">
                 <a:solidFill>
                   <a:srgbClr val="101820"/>
@@ -10825,6 +11055,7 @@
           <a:lstStyle xmlns:a="http://schemas.openxmlformats.org/drawingml/2006/main"/>
           <a:p xmlns:a="http://schemas.openxmlformats.org/drawingml/2006/main">
             <a:pPr algn="l">
+              <a:buNone/>
               <a:defRPr sz="975" b="1" i="0">
                 <a:solidFill>
                   <a:srgbClr val="56616F"/>
@@ -10875,6 +11106,7 @@
           <a:lstStyle xmlns:a="http://schemas.openxmlformats.org/drawingml/2006/main"/>
           <a:p xmlns:a="http://schemas.openxmlformats.org/drawingml/2006/main">
             <a:pPr algn="r">
+              <a:buNone/>
               <a:defRPr sz="975" b="1" i="0">
                 <a:solidFill>
                   <a:srgbClr val="56616F"/>
@@ -10956,6 +11188,7 @@
           <a:lstStyle xmlns:a="http://schemas.openxmlformats.org/drawingml/2006/main"/>
           <a:p xmlns:a="http://schemas.openxmlformats.org/drawingml/2006/main">
             <a:pPr algn="l">
+              <a:buNone/>
               <a:defRPr sz="825" b="0" i="0">
                 <a:solidFill>
                   <a:srgbClr val="56616F"/>
@@ -11006,6 +11239,7 @@
           <a:lstStyle xmlns:a="http://schemas.openxmlformats.org/drawingml/2006/main"/>
           <a:p xmlns:a="http://schemas.openxmlformats.org/drawingml/2006/main">
             <a:pPr algn="r">
+              <a:buNone/>
               <a:defRPr sz="825" b="0" i="0">
                 <a:solidFill>
                   <a:srgbClr val="56616F"/>
@@ -11056,6 +11290,7 @@
           <a:lstStyle xmlns:a="http://schemas.openxmlformats.org/drawingml/2006/main"/>
           <a:p xmlns:a="http://schemas.openxmlformats.org/drawingml/2006/main">
             <a:pPr algn="l">
+              <a:buNone/>
               <a:defRPr sz="3000" b="1" i="0">
                 <a:solidFill>
                   <a:srgbClr val="101820"/>
@@ -11106,6 +11341,7 @@
           <a:lstStyle xmlns:a="http://schemas.openxmlformats.org/drawingml/2006/main"/>
           <a:p xmlns:a="http://schemas.openxmlformats.org/drawingml/2006/main">
             <a:pPr algn="l">
+              <a:buNone/>
               <a:defRPr sz="1350" b="0" i="0">
                 <a:solidFill>
                   <a:srgbClr val="56616F"/>
@@ -11125,7 +11361,7 @@
       </p:sp>
       <p:graphicFrame>
         <p:nvGraphicFramePr>
-          <p:cNvPr id="21" name="Chart"/>
+          <p:cNvPr id="23" name="Chart"/>
           <p:cNvGraphicFramePr/>
           <p:nvPr/>
         </p:nvGraphicFramePr>
@@ -11135,7 +11371,7 @@
         </p:xfrm>
         <a:graphic xmlns:a="http://schemas.openxmlformats.org/drawingml/2006/main">
           <a:graphicData uri="http://schemas.openxmlformats.org/drawingml/2006/chart">
-            <c:chart xmlns:r="http://schemas.openxmlformats.org/officeDocument/2006/relationships" xmlns:c="http://schemas.openxmlformats.org/drawingml/2006/chart" r:id="R749e7649d16a4b78"/>
+            <c:chart xmlns:r="http://schemas.openxmlformats.org/officeDocument/2006/relationships" xmlns:c="http://schemas.openxmlformats.org/drawingml/2006/chart" r:id="R9a1f61d49045497d"/>
           </a:graphicData>
         </a:graphic>
       </p:graphicFrame>
@@ -11203,6 +11439,7 @@
           <a:lstStyle xmlns:a="http://schemas.openxmlformats.org/drawingml/2006/main"/>
           <a:p xmlns:a="http://schemas.openxmlformats.org/drawingml/2006/main">
             <a:pPr algn="l">
+              <a:buNone/>
               <a:defRPr sz="1200" b="1" i="0">
                 <a:solidFill>
                   <a:srgbClr val="0B3D52"/>
@@ -11253,6 +11490,7 @@
           <a:lstStyle xmlns:a="http://schemas.openxmlformats.org/drawingml/2006/main"/>
           <a:p xmlns:a="http://schemas.openxmlformats.org/drawingml/2006/main">
             <a:pPr algn="l">
+              <a:buNone/>
               <a:defRPr sz="1650" b="1" i="0">
                 <a:solidFill>
                   <a:srgbClr val="101820"/>
@@ -11334,6 +11572,7 @@
           <a:lstStyle xmlns:a="http://schemas.openxmlformats.org/drawingml/2006/main"/>
           <a:p xmlns:a="http://schemas.openxmlformats.org/drawingml/2006/main">
             <a:pPr algn="l">
+              <a:buNone/>
               <a:defRPr sz="1350" b="0" i="0">
                 <a:solidFill>
                   <a:srgbClr val="56616F"/>
@@ -11351,6 +11590,7 @@
           </a:p>
           <a:p xmlns:a="http://schemas.openxmlformats.org/drawingml/2006/main">
             <a:pPr algn="l">
+              <a:buNone/>
               <a:defRPr sz="1350" b="0" i="0">
                 <a:solidFill>
                   <a:srgbClr val="56616F"/>
@@ -11430,6 +11670,7 @@
           <a:lstStyle xmlns:a="http://schemas.openxmlformats.org/drawingml/2006/main"/>
           <a:p xmlns:a="http://schemas.openxmlformats.org/drawingml/2006/main">
             <a:pPr algn="l">
+              <a:buNone/>
               <a:defRPr sz="975" b="1" i="0">
                 <a:solidFill>
                   <a:srgbClr val="56616F"/>
@@ -11480,6 +11721,7 @@
           <a:lstStyle xmlns:a="http://schemas.openxmlformats.org/drawingml/2006/main"/>
           <a:p xmlns:a="http://schemas.openxmlformats.org/drawingml/2006/main">
             <a:pPr algn="r">
+              <a:buNone/>
               <a:defRPr sz="975" b="1" i="0">
                 <a:solidFill>
                   <a:srgbClr val="56616F"/>
@@ -11561,6 +11803,7 @@
           <a:lstStyle xmlns:a="http://schemas.openxmlformats.org/drawingml/2006/main"/>
           <a:p xmlns:a="http://schemas.openxmlformats.org/drawingml/2006/main">
             <a:pPr algn="l">
+              <a:buNone/>
               <a:defRPr sz="825" b="0" i="0">
                 <a:solidFill>
                   <a:srgbClr val="56616F"/>
@@ -11611,6 +11854,7 @@
           <a:lstStyle xmlns:a="http://schemas.openxmlformats.org/drawingml/2006/main"/>
           <a:p xmlns:a="http://schemas.openxmlformats.org/drawingml/2006/main">
             <a:pPr algn="r">
+              <a:buNone/>
               <a:defRPr sz="825" b="0" i="0">
                 <a:solidFill>
                   <a:srgbClr val="56616F"/>
@@ -11661,6 +11905,7 @@
           <a:lstStyle xmlns:a="http://schemas.openxmlformats.org/drawingml/2006/main"/>
           <a:p xmlns:a="http://schemas.openxmlformats.org/drawingml/2006/main">
             <a:pPr algn="l">
+              <a:buNone/>
               <a:defRPr sz="3000" b="1" i="0">
                 <a:solidFill>
                   <a:srgbClr val="101820"/>
@@ -11711,6 +11956,7 @@
           <a:lstStyle xmlns:a="http://schemas.openxmlformats.org/drawingml/2006/main"/>
           <a:p xmlns:a="http://schemas.openxmlformats.org/drawingml/2006/main">
             <a:pPr algn="l">
+              <a:buNone/>
               <a:defRPr sz="1350" b="0" i="0">
                 <a:solidFill>
                   <a:srgbClr val="56616F"/>
@@ -11730,7 +11976,7 @@
       </p:sp>
       <p:graphicFrame>
         <p:nvGraphicFramePr>
-          <p:cNvPr id="22" name="Chart"/>
+          <p:cNvPr id="24" name="Chart"/>
           <p:cNvGraphicFramePr/>
           <p:nvPr/>
         </p:nvGraphicFramePr>
@@ -11740,7 +11986,7 @@
         </p:xfrm>
         <a:graphic xmlns:a="http://schemas.openxmlformats.org/drawingml/2006/main">
           <a:graphicData uri="http://schemas.openxmlformats.org/drawingml/2006/chart">
-            <c:chart xmlns:r="http://schemas.openxmlformats.org/officeDocument/2006/relationships" xmlns:c="http://schemas.openxmlformats.org/drawingml/2006/chart" r:id="R9aaec2a0c7d04ecb"/>
+            <c:chart xmlns:r="http://schemas.openxmlformats.org/officeDocument/2006/relationships" xmlns:c="http://schemas.openxmlformats.org/drawingml/2006/chart" r:id="Rd7e966b4c72a4c79"/>
           </a:graphicData>
         </a:graphic>
       </p:graphicFrame>
@@ -11808,6 +12054,7 @@
           <a:lstStyle xmlns:a="http://schemas.openxmlformats.org/drawingml/2006/main"/>
           <a:p xmlns:a="http://schemas.openxmlformats.org/drawingml/2006/main">
             <a:pPr algn="l">
+              <a:buNone/>
               <a:defRPr sz="3450" b="1" i="0">
                 <a:solidFill>
                   <a:srgbClr val="F97316"/>
@@ -11858,6 +12105,7 @@
           <a:lstStyle xmlns:a="http://schemas.openxmlformats.org/drawingml/2006/main"/>
           <a:p xmlns:a="http://schemas.openxmlformats.org/drawingml/2006/main">
             <a:pPr algn="l">
+              <a:buNone/>
               <a:defRPr sz="1425" b="1" i="0">
                 <a:solidFill>
                   <a:srgbClr val="101820"/>
@@ -11875,6 +12123,7 @@
           </a:p>
           <a:p xmlns:a="http://schemas.openxmlformats.org/drawingml/2006/main">
             <a:pPr algn="l">
+              <a:buNone/>
               <a:defRPr sz="1425" b="1" i="0">
                 <a:solidFill>
                   <a:srgbClr val="101820"/>
@@ -11956,6 +12205,7 @@
           <a:lstStyle xmlns:a="http://schemas.openxmlformats.org/drawingml/2006/main"/>
           <a:p xmlns:a="http://schemas.openxmlformats.org/drawingml/2006/main">
             <a:pPr algn="l">
+              <a:buNone/>
               <a:defRPr sz="2550" b="1" i="0">
                 <a:solidFill>
                   <a:srgbClr val="101820"/>
@@ -12006,6 +12256,7 @@
           <a:lstStyle xmlns:a="http://schemas.openxmlformats.org/drawingml/2006/main"/>
           <a:p xmlns:a="http://schemas.openxmlformats.org/drawingml/2006/main">
             <a:pPr algn="l">
+              <a:buNone/>
               <a:defRPr sz="1350" b="0" i="0">
                 <a:solidFill>
                   <a:srgbClr val="56616F"/>
@@ -12023,6 +12274,7 @@
           </a:p>
           <a:p xmlns:a="http://schemas.openxmlformats.org/drawingml/2006/main">
             <a:pPr algn="l">
+              <a:buNone/>
               <a:defRPr sz="1350" b="0" i="0">
                 <a:solidFill>
                   <a:srgbClr val="56616F"/>
@@ -12102,6 +12354,7 @@
           <a:lstStyle xmlns:a="http://schemas.openxmlformats.org/drawingml/2006/main"/>
           <a:p xmlns:a="http://schemas.openxmlformats.org/drawingml/2006/main">
             <a:pPr algn="l">
+              <a:buNone/>
               <a:defRPr sz="975" b="1" i="0">
                 <a:solidFill>
                   <a:srgbClr val="56616F"/>
@@ -12152,6 +12405,7 @@
           <a:lstStyle xmlns:a="http://schemas.openxmlformats.org/drawingml/2006/main"/>
           <a:p xmlns:a="http://schemas.openxmlformats.org/drawingml/2006/main">
             <a:pPr algn="r">
+              <a:buNone/>
               <a:defRPr sz="975" b="1" i="0">
                 <a:solidFill>
                   <a:srgbClr val="56616F"/>
@@ -12233,6 +12487,7 @@
           <a:lstStyle xmlns:a="http://schemas.openxmlformats.org/drawingml/2006/main"/>
           <a:p xmlns:a="http://schemas.openxmlformats.org/drawingml/2006/main">
             <a:pPr algn="l">
+              <a:buNone/>
               <a:defRPr sz="825" b="0" i="0">
                 <a:solidFill>
                   <a:srgbClr val="56616F"/>
@@ -12283,6 +12538,7 @@
           <a:lstStyle xmlns:a="http://schemas.openxmlformats.org/drawingml/2006/main"/>
           <a:p xmlns:a="http://schemas.openxmlformats.org/drawingml/2006/main">
             <a:pPr algn="r">
+              <a:buNone/>
               <a:defRPr sz="825" b="0" i="0">
                 <a:solidFill>
                   <a:srgbClr val="56616F"/>
@@ -12333,6 +12589,7 @@
           <a:lstStyle xmlns:a="http://schemas.openxmlformats.org/drawingml/2006/main"/>
           <a:p xmlns:a="http://schemas.openxmlformats.org/drawingml/2006/main">
             <a:pPr algn="l">
+              <a:buNone/>
               <a:defRPr sz="3000" b="1" i="0">
                 <a:solidFill>
                   <a:srgbClr val="101820"/>
@@ -12383,6 +12640,7 @@
           <a:lstStyle xmlns:a="http://schemas.openxmlformats.org/drawingml/2006/main"/>
           <a:p xmlns:a="http://schemas.openxmlformats.org/drawingml/2006/main">
             <a:pPr algn="l">
+              <a:buNone/>
               <a:defRPr sz="1350" b="0" i="0">
                 <a:solidFill>
                   <a:srgbClr val="56616F"/>
@@ -12402,7 +12660,7 @@
       </p:sp>
       <p:graphicFrame>
         <p:nvGraphicFramePr>
-          <p:cNvPr id="20" name="Chart"/>
+          <p:cNvPr id="22" name="Chart"/>
           <p:cNvGraphicFramePr/>
           <p:nvPr/>
         </p:nvGraphicFramePr>
@@ -12412,7 +12670,7 @@
         </p:xfrm>
         <a:graphic xmlns:a="http://schemas.openxmlformats.org/drawingml/2006/main">
           <a:graphicData uri="http://schemas.openxmlformats.org/drawingml/2006/chart">
-            <c:chart xmlns:r="http://schemas.openxmlformats.org/officeDocument/2006/relationships" xmlns:c="http://schemas.openxmlformats.org/drawingml/2006/chart" r:id="R03986feacf5b438c"/>
+            <c:chart xmlns:r="http://schemas.openxmlformats.org/officeDocument/2006/relationships" xmlns:c="http://schemas.openxmlformats.org/drawingml/2006/chart" r:id="R44f6d60ee55c4309"/>
           </a:graphicData>
         </a:graphic>
       </p:graphicFrame>
@@ -12449,6 +12707,7 @@
           <a:lstStyle xmlns:a="http://schemas.openxmlformats.org/drawingml/2006/main"/>
           <a:p xmlns:a="http://schemas.openxmlformats.org/drawingml/2006/main">
             <a:pPr algn="l">
+              <a:buNone/>
               <a:defRPr sz="2100" b="1" i="0">
                 <a:solidFill>
                   <a:srgbClr val="101820"/>
@@ -12530,6 +12789,7 @@
           <a:lstStyle xmlns:a="http://schemas.openxmlformats.org/drawingml/2006/main"/>
           <a:p xmlns:a="http://schemas.openxmlformats.org/drawingml/2006/main">
             <a:pPr algn="l">
+              <a:buNone/>
               <a:defRPr sz="1650" b="0" i="0">
                 <a:solidFill>
                   <a:srgbClr val="101820"/>
@@ -12552,6 +12812,7 @@
           </a:p>
           <a:p xmlns:a="http://schemas.openxmlformats.org/drawingml/2006/main">
             <a:pPr algn="l">
+              <a:buNone/>
               <a:defRPr sz="1650" b="0" i="0">
                 <a:solidFill>
                   <a:srgbClr val="101820"/>
@@ -12569,6 +12830,7 @@
           </a:p>
           <a:p xmlns:a="http://schemas.openxmlformats.org/drawingml/2006/main">
             <a:pPr algn="l">
+              <a:buNone/>
               <a:defRPr sz="1650" b="0" i="0">
                 <a:solidFill>
                   <a:srgbClr val="101820"/>
@@ -12586,6 +12848,7 @@
           </a:p>
           <a:p xmlns:a="http://schemas.openxmlformats.org/drawingml/2006/main">
             <a:pPr algn="l">
+              <a:buNone/>
               <a:defRPr sz="1650" b="0" i="0">
                 <a:solidFill>
                   <a:srgbClr val="101820"/>
@@ -12603,6 +12866,7 @@
           </a:p>
           <a:p xmlns:a="http://schemas.openxmlformats.org/drawingml/2006/main">
             <a:pPr algn="l">
+              <a:buNone/>
               <a:defRPr sz="1650" b="0" i="0">
                 <a:solidFill>
                   <a:srgbClr val="101820"/>
@@ -12653,6 +12917,7 @@
           <a:lstStyle xmlns:a="http://schemas.openxmlformats.org/drawingml/2006/main"/>
           <a:p xmlns:a="http://schemas.openxmlformats.org/drawingml/2006/main">
             <a:pPr algn="l">
+              <a:buNone/>
               <a:defRPr sz="1350" b="1" i="0">
                 <a:solidFill>
                   <a:srgbClr val="0B3D52"/>
@@ -12732,6 +12997,7 @@
           <a:lstStyle xmlns:a="http://schemas.openxmlformats.org/drawingml/2006/main"/>
           <a:p xmlns:a="http://schemas.openxmlformats.org/drawingml/2006/main">
             <a:pPr algn="l">
+              <a:buNone/>
               <a:defRPr sz="975" b="1" i="0">
                 <a:solidFill>
                   <a:srgbClr val="56616F"/>
@@ -12782,6 +13048,7 @@
           <a:lstStyle xmlns:a="http://schemas.openxmlformats.org/drawingml/2006/main"/>
           <a:p xmlns:a="http://schemas.openxmlformats.org/drawingml/2006/main">
             <a:pPr algn="r">
+              <a:buNone/>
               <a:defRPr sz="975" b="1" i="0">
                 <a:solidFill>
                   <a:srgbClr val="56616F"/>
@@ -12863,6 +13130,7 @@
           <a:lstStyle xmlns:a="http://schemas.openxmlformats.org/drawingml/2006/main"/>
           <a:p xmlns:a="http://schemas.openxmlformats.org/drawingml/2006/main">
             <a:pPr algn="l">
+              <a:buNone/>
               <a:defRPr sz="825" b="0" i="0">
                 <a:solidFill>
                   <a:srgbClr val="56616F"/>
@@ -12913,6 +13181,7 @@
           <a:lstStyle xmlns:a="http://schemas.openxmlformats.org/drawingml/2006/main"/>
           <a:p xmlns:a="http://schemas.openxmlformats.org/drawingml/2006/main">
             <a:pPr algn="r">
+              <a:buNone/>
               <a:defRPr sz="825" b="0" i="0">
                 <a:solidFill>
                   <a:srgbClr val="56616F"/>
@@ -12963,6 +13232,7 @@
           <a:lstStyle xmlns:a="http://schemas.openxmlformats.org/drawingml/2006/main"/>
           <a:p xmlns:a="http://schemas.openxmlformats.org/drawingml/2006/main">
             <a:pPr algn="l">
+              <a:buNone/>
               <a:defRPr sz="3000" b="1" i="0">
                 <a:solidFill>
                   <a:srgbClr val="101820"/>
@@ -12975,7 +13245,7 @@
                   <a:srgbClr val="101820"/>
                 </a:solidFill>
               </a:rPr>
-              <a:t>Combined stress exhausts LCR proxy headroom</a:t>
+              <a:t>Rapid digital run exposes a seven-day survival horizon</a:t>
             </a:r>
           </a:p>
         </p:txBody>
@@ -13013,6 +13283,7 @@
           <a:lstStyle xmlns:a="http://schemas.openxmlformats.org/drawingml/2006/main"/>
           <a:p xmlns:a="http://schemas.openxmlformats.org/drawingml/2006/main">
             <a:pPr algn="l">
+              <a:buNone/>
               <a:defRPr sz="1350" b="0" i="0">
                 <a:solidFill>
                   <a:srgbClr val="56616F"/>
@@ -13025,14 +13296,14 @@
                   <a:srgbClr val="56616F"/>
                 </a:solidFill>
               </a:rPr>
-              <a:t>The proxy falls from 158.7% to 94.8%, while the survival horizon reaches the 30-day floor.</a:t>
+              <a:t>Front-loaded outflows and HQLA stress drive the proxy to 78.1% and exhaust the buffer inside one week.</a:t>
             </a:r>
           </a:p>
         </p:txBody>
       </p:sp>
       <p:graphicFrame>
         <p:nvGraphicFramePr>
-          <p:cNvPr id="23" name="Chart"/>
+          <p:cNvPr id="25" name="Chart"/>
           <p:cNvGraphicFramePr/>
           <p:nvPr/>
         </p:nvGraphicFramePr>
@@ -13042,7 +13313,7 @@
         </p:xfrm>
         <a:graphic xmlns:a="http://schemas.openxmlformats.org/drawingml/2006/main">
           <a:graphicData uri="http://schemas.openxmlformats.org/drawingml/2006/chart">
-            <c:chart xmlns:r="http://schemas.openxmlformats.org/officeDocument/2006/relationships" xmlns:c="http://schemas.openxmlformats.org/drawingml/2006/chart" r:id="Re15898ed86ca464c"/>
+            <c:chart xmlns:r="http://schemas.openxmlformats.org/officeDocument/2006/relationships" xmlns:c="http://schemas.openxmlformats.org/drawingml/2006/chart" r:id="R7de4425024ca440b"/>
           </a:graphicData>
         </a:graphic>
       </p:graphicFrame>
@@ -13110,6 +13381,7 @@
           <a:lstStyle xmlns:a="http://schemas.openxmlformats.org/drawingml/2006/main"/>
           <a:p xmlns:a="http://schemas.openxmlformats.org/drawingml/2006/main">
             <a:pPr algn="l">
+              <a:buNone/>
               <a:defRPr sz="3450" b="1" i="0">
                 <a:solidFill>
                   <a:srgbClr val="F97316"/>
@@ -13122,7 +13394,7 @@
                   <a:srgbClr val="F97316"/>
                 </a:solidFill>
               </a:rPr>
-              <a:t>94.8%</a:t>
+              <a:t>78.1%</a:t>
             </a:r>
           </a:p>
         </p:txBody>
@@ -13160,6 +13432,7 @@
           <a:lstStyle xmlns:a="http://schemas.openxmlformats.org/drawingml/2006/main"/>
           <a:p xmlns:a="http://schemas.openxmlformats.org/drawingml/2006/main">
             <a:pPr algn="l">
+              <a:buNone/>
               <a:defRPr sz="1500" b="1" i="0">
                 <a:solidFill>
                   <a:srgbClr val="101820"/>
@@ -13172,7 +13445,7 @@
                   <a:srgbClr val="101820"/>
                 </a:solidFill>
               </a:rPr>
-              <a:t>combined LCR proxy</a:t>
+              <a:t>rapid-run LCR proxy</a:t>
             </a:r>
           </a:p>
         </p:txBody>
@@ -13241,6 +13514,7 @@
           <a:lstStyle xmlns:a="http://schemas.openxmlformats.org/drawingml/2006/main"/>
           <a:p xmlns:a="http://schemas.openxmlformats.org/drawingml/2006/main">
             <a:pPr algn="l">
+              <a:buNone/>
               <a:defRPr sz="3000" b="1" i="0">
                 <a:solidFill>
                   <a:srgbClr val="101820"/>
@@ -13253,7 +13527,7 @@
                   <a:srgbClr val="101820"/>
                 </a:solidFill>
               </a:rPr>
-              <a:t>30 days</a:t>
+              <a:t>7 days</a:t>
             </a:r>
           </a:p>
         </p:txBody>
@@ -13291,6 +13565,7 @@
           <a:lstStyle xmlns:a="http://schemas.openxmlformats.org/drawingml/2006/main"/>
           <a:p xmlns:a="http://schemas.openxmlformats.org/drawingml/2006/main">
             <a:pPr algn="l">
+              <a:buNone/>
               <a:defRPr sz="1425" b="0" i="0">
                 <a:solidFill>
                   <a:srgbClr val="56616F"/>
@@ -13303,11 +13578,12 @@
                   <a:srgbClr val="56616F"/>
                 </a:solidFill>
               </a:rPr>
-              <a:t>combined survival horizon</a:t>
+              <a:t>rapid-run survival horizon</a:t>
             </a:r>
           </a:p>
           <a:p xmlns:a="http://schemas.openxmlformats.org/drawingml/2006/main">
             <a:pPr algn="l">
+              <a:buNone/>
               <a:defRPr sz="1425" b="0" i="0">
                 <a:solidFill>
                   <a:srgbClr val="56616F"/>
@@ -13320,7 +13596,7 @@
                   <a:srgbClr val="56616F"/>
                 </a:solidFill>
               </a:rPr>
-              <a:t>NSFR proxy: 143.4%</a:t>
+              <a:t>HQLA loss: TRY 1.46bn</a:t>
             </a:r>
           </a:p>
         </p:txBody>
@@ -13358,6 +13634,7 @@
           <a:lstStyle xmlns:a="http://schemas.openxmlformats.org/drawingml/2006/main"/>
           <a:p xmlns:a="http://schemas.openxmlformats.org/drawingml/2006/main">
             <a:pPr algn="l">
+              <a:buNone/>
               <a:defRPr sz="1500" b="1" i="0">
                 <a:solidFill>
                   <a:srgbClr val="101820"/>
@@ -13370,7 +13647,7 @@
                   <a:srgbClr val="101820"/>
                 </a:solidFill>
               </a:rPr>
-              <a:t>Management action | retain HQLA, pre-position contingent funding and monitor deposit runoff triggers daily.</a:t>
+              <a:t>Management action | pre-position funding, protect unencumbered HQLA and rehearse a seven-day contingency response.</a:t>
             </a:r>
           </a:p>
         </p:txBody>
@@ -13437,6 +13714,7 @@
           <a:lstStyle xmlns:a="http://schemas.openxmlformats.org/drawingml/2006/main"/>
           <a:p xmlns:a="http://schemas.openxmlformats.org/drawingml/2006/main">
             <a:pPr algn="l">
+              <a:buNone/>
               <a:defRPr sz="975" b="1" i="0">
                 <a:solidFill>
                   <a:srgbClr val="56616F"/>
@@ -13487,6 +13765,7 @@
           <a:lstStyle xmlns:a="http://schemas.openxmlformats.org/drawingml/2006/main"/>
           <a:p xmlns:a="http://schemas.openxmlformats.org/drawingml/2006/main">
             <a:pPr algn="r">
+              <a:buNone/>
               <a:defRPr sz="975" b="1" i="0">
                 <a:solidFill>
                   <a:srgbClr val="56616F"/>
@@ -13568,6 +13847,7 @@
           <a:lstStyle xmlns:a="http://schemas.openxmlformats.org/drawingml/2006/main"/>
           <a:p xmlns:a="http://schemas.openxmlformats.org/drawingml/2006/main">
             <a:pPr algn="l">
+              <a:buNone/>
               <a:defRPr sz="825" b="0" i="0">
                 <a:solidFill>
                   <a:srgbClr val="56616F"/>
@@ -13618,6 +13898,7 @@
           <a:lstStyle xmlns:a="http://schemas.openxmlformats.org/drawingml/2006/main"/>
           <a:p xmlns:a="http://schemas.openxmlformats.org/drawingml/2006/main">
             <a:pPr algn="r">
+              <a:buNone/>
               <a:defRPr sz="825" b="0" i="0">
                 <a:solidFill>
                   <a:srgbClr val="56616F"/>
@@ -13668,6 +13949,7 @@
           <a:lstStyle xmlns:a="http://schemas.openxmlformats.org/drawingml/2006/main"/>
           <a:p xmlns:a="http://schemas.openxmlformats.org/drawingml/2006/main">
             <a:pPr algn="l">
+              <a:buNone/>
               <a:defRPr sz="3000" b="1" i="0">
                 <a:solidFill>
                   <a:srgbClr val="101820"/>
@@ -13718,6 +14000,7 @@
           <a:lstStyle xmlns:a="http://schemas.openxmlformats.org/drawingml/2006/main"/>
           <a:p xmlns:a="http://schemas.openxmlformats.org/drawingml/2006/main">
             <a:pPr algn="l">
+              <a:buNone/>
               <a:defRPr sz="1350" b="0" i="0">
                 <a:solidFill>
                   <a:srgbClr val="56616F"/>
@@ -13737,7 +14020,7 @@
       </p:sp>
       <p:graphicFrame>
         <p:nvGraphicFramePr>
-          <p:cNvPr id="22" name="Chart"/>
+          <p:cNvPr id="24" name="Chart"/>
           <p:cNvGraphicFramePr/>
           <p:nvPr/>
         </p:nvGraphicFramePr>
@@ -13747,7 +14030,7 @@
         </p:xfrm>
         <a:graphic xmlns:a="http://schemas.openxmlformats.org/drawingml/2006/main">
           <a:graphicData uri="http://schemas.openxmlformats.org/drawingml/2006/chart">
-            <c:chart xmlns:r="http://schemas.openxmlformats.org/officeDocument/2006/relationships" xmlns:c="http://schemas.openxmlformats.org/drawingml/2006/chart" r:id="R8f8daeba432e4b19"/>
+            <c:chart xmlns:r="http://schemas.openxmlformats.org/officeDocument/2006/relationships" xmlns:c="http://schemas.openxmlformats.org/drawingml/2006/chart" r:id="Rccc0a2d8be1d4631"/>
           </a:graphicData>
         </a:graphic>
       </p:graphicFrame>
@@ -13815,6 +14098,7 @@
           <a:lstStyle xmlns:a="http://schemas.openxmlformats.org/drawingml/2006/main"/>
           <a:p xmlns:a="http://schemas.openxmlformats.org/drawingml/2006/main">
             <a:pPr algn="l">
+              <a:buNone/>
               <a:defRPr sz="3000" b="1" i="0">
                 <a:solidFill>
                   <a:srgbClr val="F97316"/>
@@ -13865,6 +14149,7 @@
           <a:lstStyle xmlns:a="http://schemas.openxmlformats.org/drawingml/2006/main"/>
           <a:p xmlns:a="http://schemas.openxmlformats.org/drawingml/2006/main">
             <a:pPr algn="l">
+              <a:buNone/>
               <a:defRPr sz="1725" b="1" i="0">
                 <a:solidFill>
                   <a:srgbClr val="101820"/>
@@ -13946,6 +14231,7 @@
           <a:lstStyle xmlns:a="http://schemas.openxmlformats.org/drawingml/2006/main"/>
           <a:p xmlns:a="http://schemas.openxmlformats.org/drawingml/2006/main">
             <a:pPr algn="l">
+              <a:buNone/>
               <a:defRPr sz="1650" b="0" i="0">
                 <a:solidFill>
                   <a:srgbClr val="101820"/>
@@ -13963,6 +14249,7 @@
           </a:p>
           <a:p xmlns:a="http://schemas.openxmlformats.org/drawingml/2006/main">
             <a:pPr algn="l">
+              <a:buNone/>
               <a:defRPr sz="1650" b="0" i="0">
                 <a:solidFill>
                   <a:srgbClr val="101820"/>
@@ -13980,6 +14267,7 @@
           </a:p>
           <a:p xmlns:a="http://schemas.openxmlformats.org/drawingml/2006/main">
             <a:pPr algn="l">
+              <a:buNone/>
               <a:defRPr sz="1650" b="0" i="0">
                 <a:solidFill>
                   <a:srgbClr val="101820"/>
@@ -14030,6 +14318,7 @@
           <a:lstStyle xmlns:a="http://schemas.openxmlformats.org/drawingml/2006/main"/>
           <a:p xmlns:a="http://schemas.openxmlformats.org/drawingml/2006/main">
             <a:pPr algn="l">
+              <a:buNone/>
               <a:defRPr sz="1950" b="1" i="0">
                 <a:solidFill>
                   <a:srgbClr val="101820"/>

</xml_diff>

<commit_message>
feat: add rapid digital-run liquidity stress scenario (#2)
Add a severe exploratory deposit-run scenario with front-loaded outflows, scenario-specific HQLA market-value shocks, a seven-day survival horizon, expanded validation, and refreshed ALCO deliverables.
</commit_message>
<xml_diff>
--- a/presentation/Aurelia_Bank_ALM_Executive_Deck_EN.pptx
+++ b/presentation/Aurelia_Bank_ALM_Executive_Deck_EN.pptx
@@ -2,24 +2,24 @@
 <file path=ppt/presentation.xml><?xml version="1.0" encoding="utf-8"?>
 <p:presentation xmlns:p="http://schemas.openxmlformats.org/presentationml/2006/main">
   <p:sldMasterIdLst>
-    <p:sldMasterId xmlns:r="http://schemas.openxmlformats.org/officeDocument/2006/relationships" id="2147483648" r:id="R62bf010aeee04786"/>
+    <p:sldMasterId xmlns:r="http://schemas.openxmlformats.org/officeDocument/2006/relationships" id="2147483648" r:id="Rbfc5fa283ecb4372"/>
   </p:sldMasterIdLst>
   <p:notesMasterIdLst>
-    <p:notesMasterId xmlns:r="http://schemas.openxmlformats.org/officeDocument/2006/relationships" r:id="Rf65c5ba3d62f42aa"/>
+    <p:notesMasterId xmlns:r="http://schemas.openxmlformats.org/officeDocument/2006/relationships" r:id="Rd033183a6f3f4f7c"/>
   </p:notesMasterIdLst>
   <p:sldIdLst>
-    <p:sldId xmlns:r="http://schemas.openxmlformats.org/officeDocument/2006/relationships" id="256" r:id="Rfff94b1676394775"/>
-    <p:sldId xmlns:r="http://schemas.openxmlformats.org/officeDocument/2006/relationships" id="257" r:id="R1c7041bea51343ac"/>
-    <p:sldId xmlns:r="http://schemas.openxmlformats.org/officeDocument/2006/relationships" id="258" r:id="R76b489be907d4585"/>
-    <p:sldId xmlns:r="http://schemas.openxmlformats.org/officeDocument/2006/relationships" id="259" r:id="Rea645cfbc4b2446b"/>
-    <p:sldId xmlns:r="http://schemas.openxmlformats.org/officeDocument/2006/relationships" id="260" r:id="Rf82b9bac9b614900"/>
-    <p:sldId xmlns:r="http://schemas.openxmlformats.org/officeDocument/2006/relationships" id="261" r:id="R0ad7e86bd09d4bdc"/>
-    <p:sldId xmlns:r="http://schemas.openxmlformats.org/officeDocument/2006/relationships" id="262" r:id="R5af340d451e9467e"/>
-    <p:sldId xmlns:r="http://schemas.openxmlformats.org/officeDocument/2006/relationships" id="263" r:id="R6630b06da5764727"/>
-    <p:sldId xmlns:r="http://schemas.openxmlformats.org/officeDocument/2006/relationships" id="264" r:id="Rafcf3656c79148cd"/>
-    <p:sldId xmlns:r="http://schemas.openxmlformats.org/officeDocument/2006/relationships" id="265" r:id="R85e2eb2553264485"/>
-    <p:sldId xmlns:r="http://schemas.openxmlformats.org/officeDocument/2006/relationships" id="266" r:id="R961f9fa1333649f0"/>
-    <p:sldId xmlns:r="http://schemas.openxmlformats.org/officeDocument/2006/relationships" id="267" r:id="R2b94ee4ce58547ea"/>
+    <p:sldId xmlns:r="http://schemas.openxmlformats.org/officeDocument/2006/relationships" id="256" r:id="Rb7d663c555884971"/>
+    <p:sldId xmlns:r="http://schemas.openxmlformats.org/officeDocument/2006/relationships" id="257" r:id="R8023b39412bd4b41"/>
+    <p:sldId xmlns:r="http://schemas.openxmlformats.org/officeDocument/2006/relationships" id="258" r:id="Rc2f4dc4ef5e44ffd"/>
+    <p:sldId xmlns:r="http://schemas.openxmlformats.org/officeDocument/2006/relationships" id="259" r:id="Raa20ae3cae1f42b4"/>
+    <p:sldId xmlns:r="http://schemas.openxmlformats.org/officeDocument/2006/relationships" id="260" r:id="R544e7b40912649eb"/>
+    <p:sldId xmlns:r="http://schemas.openxmlformats.org/officeDocument/2006/relationships" id="261" r:id="Rd3c687e7e20b44b7"/>
+    <p:sldId xmlns:r="http://schemas.openxmlformats.org/officeDocument/2006/relationships" id="262" r:id="R92ad7e2ea79b4632"/>
+    <p:sldId xmlns:r="http://schemas.openxmlformats.org/officeDocument/2006/relationships" id="263" r:id="R6dca238ad31248ee"/>
+    <p:sldId xmlns:r="http://schemas.openxmlformats.org/officeDocument/2006/relationships" id="264" r:id="Rd459189973df4402"/>
+    <p:sldId xmlns:r="http://schemas.openxmlformats.org/officeDocument/2006/relationships" id="265" r:id="R541b456075154eb5"/>
+    <p:sldId xmlns:r="http://schemas.openxmlformats.org/officeDocument/2006/relationships" id="266" r:id="R1a1593e3b29f4a4f"/>
+    <p:sldId xmlns:r="http://schemas.openxmlformats.org/officeDocument/2006/relationships" id="267" r:id="Rc89af6a95e134ae6"/>
   </p:sldIdLst>
   <p:sldSz cx="12192000" cy="6858000"/>
   <p:notesSz cx="6858000" cy="9144000"/>
@@ -618,7 +618,32 @@
           <a:lstStyle xmlns:a="http://schemas.openxmlformats.org/drawingml/2006/main"/>
           <a:p xmlns:a="http://schemas.openxmlformats.org/drawingml/2006/main">
             <a:r>
-              <a:t>Separate model validity from business-risk status. The accounting identity, data controls and test suite pass; the FX risk breach remains deliberately visible.</a:t>
+              <a:t>Separate model validity from business-risk status. All 46 automated tests pass, line coverage is 93.88%, and the formal FX risk breach remains deliberately visible.</a:t>
+            </a:r>
+          </a:p>
+          <a:p xmlns:a="http://schemas.openxmlformats.org/drawingml/2006/main">
+            <a:r>
+              <a:t/>
+            </a:r>
+          </a:p>
+          <a:p xmlns:a="http://schemas.openxmlformats.org/drawingml/2006/main">
+            <a:r>
+              <a:t>[Sources]</a:t>
+            </a:r>
+          </a:p>
+          <a:p xmlns:a="http://schemas.openxmlformats.org/drawingml/2006/main">
+            <a:r>
+              <a:t>tests/</a:t>
+            </a:r>
+          </a:p>
+          <a:p xmlns:a="http://schemas.openxmlformats.org/drawingml/2006/main">
+            <a:r>
+              <a:t>docs/validation_report.md</a:t>
+            </a:r>
+          </a:p>
+          <a:p xmlns:a="http://schemas.openxmlformats.org/drawingml/2006/main">
+            <a:r>
+              <a:t>.github/workflows/ci.yml</a:t>
             </a:r>
           </a:p>
         </p:txBody>
@@ -688,7 +713,27 @@
           <a:lstStyle xmlns:a="http://schemas.openxmlformats.org/drawingml/2006/main"/>
           <a:p xmlns:a="http://schemas.openxmlformats.org/drawingml/2006/main">
             <a:r>
-              <a:t>Close on the explicit decision. Ask ALCO to approve the sequence and assign Treasury, ALM, Market Risk and Finance owners. Require a documented post-trade rerun before the action is considered complete.</a:t>
+              <a:t>Close on the explicit decision. Ask ALCO to approve the sequence, activate the rapid-run contingency workstream, assign Treasury, ALM, Market Risk and Finance owners, and require a documented post-trade rerun.</a:t>
+            </a:r>
+          </a:p>
+          <a:p xmlns:a="http://schemas.openxmlformats.org/drawingml/2006/main">
+            <a:r>
+              <a:t/>
+            </a:r>
+          </a:p>
+          <a:p xmlns:a="http://schemas.openxmlformats.org/drawingml/2006/main">
+            <a:r>
+              <a:t>[Sources]</a:t>
+            </a:r>
+          </a:p>
+          <a:p xmlns:a="http://schemas.openxmlformats.org/drawingml/2006/main">
+            <a:r>
+              <a:t>docs/alco_playbook.md</a:t>
+            </a:r>
+          </a:p>
+          <a:p xmlns:a="http://schemas.openxmlformats.org/drawingml/2006/main">
+            <a:r>
+              <a:t>docs/rapid_digital_run_scenario.md</a:t>
             </a:r>
           </a:p>
         </p:txBody>
@@ -758,7 +803,27 @@
           <a:lstStyle xmlns:a="http://schemas.openxmlformats.org/drawingml/2006/main"/>
           <a:p xmlns:a="http://schemas.openxmlformats.org/drawingml/2006/main">
             <a:r>
-              <a:t>Lead with the two decisions. Clarify that combined-stress LCR is a management warning, while the formal limit breach is the aggregate FX open position.</a:t>
+              <a:t>Lead with the formal FX breach, then the severe exploratory liquidity result. The rapid-run scenario is a management vulnerability test, not a Basel-prescribed regulatory scenario.</a:t>
+            </a:r>
+          </a:p>
+          <a:p xmlns:a="http://schemas.openxmlformats.org/drawingml/2006/main">
+            <a:r>
+              <a:t/>
+            </a:r>
+          </a:p>
+          <a:p xmlns:a="http://schemas.openxmlformats.org/drawingml/2006/main">
+            <a:r>
+              <a:t>[Sources]</a:t>
+            </a:r>
+          </a:p>
+          <a:p xmlns:a="http://schemas.openxmlformats.org/drawingml/2006/main">
+            <a:r>
+              <a:t>artifacts/results/executive_summary.json</a:t>
+            </a:r>
+          </a:p>
+          <a:p xmlns:a="http://schemas.openxmlformats.org/drawingml/2006/main">
+            <a:r>
+              <a:t>docs/rapid_digital_run_scenario.md</a:t>
             </a:r>
           </a:p>
         </p:txBody>
@@ -1218,7 +1283,7 @@
           <a:lstStyle xmlns:a="http://schemas.openxmlformats.org/drawingml/2006/main"/>
           <a:p xmlns:a="http://schemas.openxmlformats.org/drawingml/2006/main">
             <a:r>
-              <a:t>State explicitly that the output is a proxy for portfolio analytics, not a regulatory return. The combined scenario triggers a management warning because the proxy is below 100% and survival is exactly at the floor.</a:t>
+              <a:t>State explicitly that the outputs are transparent management proxies, not regulatory returns. Under the severe exploratory rapid-run scenario, 55% of 30-day outflows arrive on day 1, 85% by day 7, stressed HQLA loses TRY 1.46bn, the LCR proxy falls to 78.1% and survival reaches seven days.</a:t>
             </a:r>
           </a:p>
           <a:p xmlns:a="http://schemas.openxmlformats.org/drawingml/2006/main">
@@ -1239,6 +1304,16 @@
           <a:p xmlns:a="http://schemas.openxmlformats.org/drawingml/2006/main">
             <a:r>
               <a:t>https://www.bis.org/basel_framework/chapter/NSF/20.htm</a:t>
+            </a:r>
+          </a:p>
+          <a:p xmlns:a="http://schemas.openxmlformats.org/drawingml/2006/main">
+            <a:r>
+              <a:t>artifacts/results/liquidity.csv</a:t>
+            </a:r>
+          </a:p>
+          <a:p xmlns:a="http://schemas.openxmlformats.org/drawingml/2006/main">
+            <a:r>
+              <a:t>docs/rapid_digital_run_scenario.md</a:t>
             </a:r>
           </a:p>
         </p:txBody>
@@ -1376,7 +1451,7 @@
   </p:cSld>
   <p:clrMap bg1="lt1" tx1="dk1" bg2="lt2" tx2="dk2" accent1="accent1" accent2="accent2" accent3="accent3" accent4="accent4" accent5="accent5" accent6="accent6" hlink="hlink" folHlink="folHlink"/>
   <p:sldLayoutIdLst>
-    <p:sldLayoutId xmlns:r="http://schemas.openxmlformats.org/officeDocument/2006/relationships" id="2147483649" r:id="R548b92fb6a564e97"/>
+    <p:sldLayoutId xmlns:r="http://schemas.openxmlformats.org/officeDocument/2006/relationships" id="2147483649" r:id="R00e18b07ada74c11"/>
   </p:sldLayoutIdLst>
   <p:txStyles>
     <p:titleStyle>
@@ -2905,9 +2980,18 @@
               </a:solidFill>
             </c:spPr>
           </c:dPt>
+          <c:dPt>
+            <c:idx val="4"/>
+            <c:invertIfNegative val="0"/>
+            <c:spPr>
+              <a:solidFill xmlns:a="http://schemas.openxmlformats.org/drawingml/2006/main">
+                <a:srgbClr val="7F1D1D"/>
+              </a:solidFill>
+            </c:spPr>
+          </c:dPt>
           <c:cat>
             <c:strLit>
-              <c:ptCount val="4"/>
+              <c:ptCount val="5"/>
               <c:pt idx="0">
                 <c:v>base</c:v>
               </c:pt>
@@ -2920,12 +3004,15 @@
               <c:pt idx="3">
                 <c:v>combined</c:v>
               </c:pt>
+              <c:pt idx="4">
+                <c:v>rapid run</c:v>
+              </c:pt>
             </c:strLit>
           </c:cat>
           <c:val>
             <c:numLit>
               <c:formatCode>0.0</c:formatCode>
-              <c:ptCount val="4"/>
+              <c:ptCount val="5"/>
               <c:pt idx="0">
                 <c:v>158.721676</c:v>
               </c:pt>
@@ -2937,6 +3024,9 @@
               </c:pt>
               <c:pt idx="3">
                 <c:v>94.833642</c:v>
+              </c:pt>
+              <c:pt idx="4">
+                <c:v>78.091516</c:v>
               </c:pt>
             </c:numLit>
           </c:val>
@@ -3344,6 +3434,7 @@
           <a:lstStyle xmlns:a="http://schemas.openxmlformats.org/drawingml/2006/main"/>
           <a:p xmlns:a="http://schemas.openxmlformats.org/drawingml/2006/main">
             <a:pPr algn="l">
+              <a:buNone/>
               <a:defRPr sz="1125" b="1" i="0">
                 <a:solidFill>
                   <a:srgbClr val="167CA5"/>
@@ -3425,6 +3516,7 @@
           <a:lstStyle xmlns:a="http://schemas.openxmlformats.org/drawingml/2006/main"/>
           <a:p xmlns:a="http://schemas.openxmlformats.org/drawingml/2006/main">
             <a:pPr algn="l">
+              <a:buNone/>
               <a:defRPr sz="4950" b="1" i="0">
                 <a:solidFill>
                   <a:srgbClr val="101820"/>
@@ -3442,6 +3534,7 @@
           </a:p>
           <a:p xmlns:a="http://schemas.openxmlformats.org/drawingml/2006/main">
             <a:pPr algn="l">
+              <a:buNone/>
               <a:defRPr sz="4950" b="1" i="0">
                 <a:solidFill>
                   <a:srgbClr val="101820"/>
@@ -3492,6 +3585,7 @@
           <a:lstStyle xmlns:a="http://schemas.openxmlformats.org/drawingml/2006/main"/>
           <a:p xmlns:a="http://schemas.openxmlformats.org/drawingml/2006/main">
             <a:pPr algn="l">
+              <a:buNone/>
               <a:defRPr sz="1950" b="0" i="0">
                 <a:solidFill>
                   <a:srgbClr val="56616F"/>
@@ -3604,6 +3698,7 @@
           <a:lstStyle xmlns:a="http://schemas.openxmlformats.org/drawingml/2006/main"/>
           <a:p xmlns:a="http://schemas.openxmlformats.org/drawingml/2006/main">
             <a:pPr algn="l">
+              <a:buNone/>
               <a:defRPr sz="2550" b="1" i="0">
                 <a:solidFill>
                   <a:srgbClr val="101820"/>
@@ -3654,6 +3749,7 @@
           <a:lstStyle xmlns:a="http://schemas.openxmlformats.org/drawingml/2006/main"/>
           <a:p xmlns:a="http://schemas.openxmlformats.org/drawingml/2006/main">
             <a:pPr algn="l">
+              <a:buNone/>
               <a:defRPr sz="1275" b="0" i="0">
                 <a:solidFill>
                   <a:srgbClr val="56616F"/>
@@ -3676,6 +3772,7 @@
           </a:p>
           <a:p xmlns:a="http://schemas.openxmlformats.org/drawingml/2006/main">
             <a:pPr algn="l">
+              <a:buNone/>
               <a:defRPr sz="1275" b="0" i="0">
                 <a:solidFill>
                   <a:srgbClr val="56616F"/>
@@ -3698,6 +3795,7 @@
           </a:p>
           <a:p xmlns:a="http://schemas.openxmlformats.org/drawingml/2006/main">
             <a:pPr algn="l">
+              <a:buNone/>
               <a:defRPr sz="1275" b="0" i="0">
                 <a:solidFill>
                   <a:srgbClr val="56616F"/>
@@ -3748,6 +3846,7 @@
           <a:lstStyle xmlns:a="http://schemas.openxmlformats.org/drawingml/2006/main"/>
           <a:p xmlns:a="http://schemas.openxmlformats.org/drawingml/2006/main">
             <a:pPr algn="l">
+              <a:buNone/>
               <a:defRPr sz="1200" b="0" i="0">
                 <a:solidFill>
                   <a:srgbClr val="56616F"/>
@@ -3798,6 +3897,7 @@
           <a:lstStyle xmlns:a="http://schemas.openxmlformats.org/drawingml/2006/main"/>
           <a:p xmlns:a="http://schemas.openxmlformats.org/drawingml/2006/main">
             <a:pPr algn="r">
+              <a:buNone/>
               <a:defRPr sz="1200" b="1" i="0">
                 <a:solidFill>
                   <a:srgbClr val="101820"/>
@@ -3877,6 +3977,7 @@
           <a:lstStyle xmlns:a="http://schemas.openxmlformats.org/drawingml/2006/main"/>
           <a:p xmlns:a="http://schemas.openxmlformats.org/drawingml/2006/main">
             <a:pPr algn="l">
+              <a:buNone/>
               <a:defRPr sz="975" b="1" i="0">
                 <a:solidFill>
                   <a:srgbClr val="56616F"/>
@@ -3927,6 +4028,7 @@
           <a:lstStyle xmlns:a="http://schemas.openxmlformats.org/drawingml/2006/main"/>
           <a:p xmlns:a="http://schemas.openxmlformats.org/drawingml/2006/main">
             <a:pPr algn="r">
+              <a:buNone/>
               <a:defRPr sz="975" b="1" i="0">
                 <a:solidFill>
                   <a:srgbClr val="56616F"/>
@@ -4008,6 +4110,7 @@
           <a:lstStyle xmlns:a="http://schemas.openxmlformats.org/drawingml/2006/main"/>
           <a:p xmlns:a="http://schemas.openxmlformats.org/drawingml/2006/main">
             <a:pPr algn="l">
+              <a:buNone/>
               <a:defRPr sz="825" b="0" i="0">
                 <a:solidFill>
                   <a:srgbClr val="56616F"/>
@@ -4058,6 +4161,7 @@
           <a:lstStyle xmlns:a="http://schemas.openxmlformats.org/drawingml/2006/main"/>
           <a:p xmlns:a="http://schemas.openxmlformats.org/drawingml/2006/main">
             <a:pPr algn="r">
+              <a:buNone/>
               <a:defRPr sz="825" b="0" i="0">
                 <a:solidFill>
                   <a:srgbClr val="56616F"/>
@@ -4108,6 +4212,7 @@
           <a:lstStyle xmlns:a="http://schemas.openxmlformats.org/drawingml/2006/main"/>
           <a:p xmlns:a="http://schemas.openxmlformats.org/drawingml/2006/main">
             <a:pPr algn="l">
+              <a:buNone/>
               <a:defRPr sz="3000" b="1" i="0">
                 <a:solidFill>
                   <a:srgbClr val="101820"/>
@@ -4158,6 +4263,7 @@
           <a:lstStyle xmlns:a="http://schemas.openxmlformats.org/drawingml/2006/main"/>
           <a:p xmlns:a="http://schemas.openxmlformats.org/drawingml/2006/main">
             <a:pPr algn="l">
+              <a:buNone/>
               <a:defRPr sz="1350" b="0" i="0">
                 <a:solidFill>
                   <a:srgbClr val="56616F"/>
@@ -4208,6 +4314,7 @@
           <a:lstStyle xmlns:a="http://schemas.openxmlformats.org/drawingml/2006/main"/>
           <a:p xmlns:a="http://schemas.openxmlformats.org/drawingml/2006/main">
             <a:pPr algn="l">
+              <a:buNone/>
               <a:defRPr sz="1350" b="1" i="0">
                 <a:solidFill>
                   <a:srgbClr val="0B3D52"/>
@@ -4289,6 +4396,7 @@
           <a:lstStyle xmlns:a="http://schemas.openxmlformats.org/drawingml/2006/main"/>
           <a:p xmlns:a="http://schemas.openxmlformats.org/drawingml/2006/main">
             <a:pPr algn="l">
+              <a:buNone/>
               <a:defRPr sz="2550" b="1" i="0">
                 <a:solidFill>
                   <a:srgbClr val="F97316"/>
@@ -4339,6 +4447,7 @@
           <a:lstStyle xmlns:a="http://schemas.openxmlformats.org/drawingml/2006/main"/>
           <a:p xmlns:a="http://schemas.openxmlformats.org/drawingml/2006/main">
             <a:pPr algn="l">
+              <a:buNone/>
               <a:defRPr sz="1200" b="0" i="0">
                 <a:solidFill>
                   <a:srgbClr val="56616F"/>
@@ -4389,6 +4498,7 @@
           <a:lstStyle xmlns:a="http://schemas.openxmlformats.org/drawingml/2006/main"/>
           <a:p xmlns:a="http://schemas.openxmlformats.org/drawingml/2006/main">
             <a:pPr algn="ctr">
+              <a:buNone/>
               <a:defRPr sz="2550" b="1" i="0">
                 <a:solidFill>
                   <a:srgbClr val="167CA5"/>
@@ -4439,6 +4549,7 @@
           <a:lstStyle xmlns:a="http://schemas.openxmlformats.org/drawingml/2006/main"/>
           <a:p xmlns:a="http://schemas.openxmlformats.org/drawingml/2006/main">
             <a:pPr algn="l">
+              <a:buNone/>
               <a:defRPr sz="2550" b="1" i="0">
                 <a:solidFill>
                   <a:srgbClr val="101820"/>
@@ -4489,6 +4600,7 @@
           <a:lstStyle xmlns:a="http://schemas.openxmlformats.org/drawingml/2006/main"/>
           <a:p xmlns:a="http://schemas.openxmlformats.org/drawingml/2006/main">
             <a:pPr algn="l">
+              <a:buNone/>
               <a:defRPr sz="1200" b="0" i="0">
                 <a:solidFill>
                   <a:srgbClr val="56616F"/>
@@ -4539,6 +4651,7 @@
           <a:lstStyle xmlns:a="http://schemas.openxmlformats.org/drawingml/2006/main"/>
           <a:p xmlns:a="http://schemas.openxmlformats.org/drawingml/2006/main">
             <a:pPr algn="l">
+              <a:buNone/>
               <a:defRPr sz="1500" b="0" i="0">
                 <a:solidFill>
                   <a:srgbClr val="101820"/>
@@ -4556,6 +4669,7 @@
           </a:p>
           <a:p xmlns:a="http://schemas.openxmlformats.org/drawingml/2006/main">
             <a:pPr algn="l">
+              <a:buNone/>
               <a:defRPr sz="1500" b="0" i="0">
                 <a:solidFill>
                   <a:srgbClr val="101820"/>
@@ -4573,6 +4687,7 @@
           </a:p>
           <a:p xmlns:a="http://schemas.openxmlformats.org/drawingml/2006/main">
             <a:pPr algn="l">
+              <a:buNone/>
               <a:defRPr sz="1500" b="0" i="0">
                 <a:solidFill>
                   <a:srgbClr val="101820"/>
@@ -4623,6 +4738,7 @@
           <a:lstStyle xmlns:a="http://schemas.openxmlformats.org/drawingml/2006/main"/>
           <a:p xmlns:a="http://schemas.openxmlformats.org/drawingml/2006/main">
             <a:pPr algn="l">
+              <a:buNone/>
               <a:defRPr sz="1350" b="1" i="0">
                 <a:solidFill>
                   <a:srgbClr val="0B3D52"/>
@@ -4704,6 +4820,7 @@
           <a:lstStyle xmlns:a="http://schemas.openxmlformats.org/drawingml/2006/main"/>
           <a:p xmlns:a="http://schemas.openxmlformats.org/drawingml/2006/main">
             <a:pPr algn="l">
+              <a:buNone/>
               <a:defRPr sz="2550" b="1" i="0">
                 <a:solidFill>
                   <a:srgbClr val="F97316"/>
@@ -4754,6 +4871,7 @@
           <a:lstStyle xmlns:a="http://schemas.openxmlformats.org/drawingml/2006/main"/>
           <a:p xmlns:a="http://schemas.openxmlformats.org/drawingml/2006/main">
             <a:pPr algn="l">
+              <a:buNone/>
               <a:defRPr sz="1200" b="0" i="0">
                 <a:solidFill>
                   <a:srgbClr val="56616F"/>
@@ -4804,6 +4922,7 @@
           <a:lstStyle xmlns:a="http://schemas.openxmlformats.org/drawingml/2006/main"/>
           <a:p xmlns:a="http://schemas.openxmlformats.org/drawingml/2006/main">
             <a:pPr algn="ctr">
+              <a:buNone/>
               <a:defRPr sz="2550" b="1" i="0">
                 <a:solidFill>
                   <a:srgbClr val="167CA5"/>
@@ -4854,6 +4973,7 @@
           <a:lstStyle xmlns:a="http://schemas.openxmlformats.org/drawingml/2006/main"/>
           <a:p xmlns:a="http://schemas.openxmlformats.org/drawingml/2006/main">
             <a:pPr algn="l">
+              <a:buNone/>
               <a:defRPr sz="2550" b="1" i="0">
                 <a:solidFill>
                   <a:srgbClr val="101820"/>
@@ -4904,6 +5024,7 @@
           <a:lstStyle xmlns:a="http://schemas.openxmlformats.org/drawingml/2006/main"/>
           <a:p xmlns:a="http://schemas.openxmlformats.org/drawingml/2006/main">
             <a:pPr algn="l">
+              <a:buNone/>
               <a:defRPr sz="1200" b="0" i="0">
                 <a:solidFill>
                   <a:srgbClr val="56616F"/>
@@ -4954,6 +5075,7 @@
           <a:lstStyle xmlns:a="http://schemas.openxmlformats.org/drawingml/2006/main"/>
           <a:p xmlns:a="http://schemas.openxmlformats.org/drawingml/2006/main">
             <a:pPr algn="l">
+              <a:buNone/>
               <a:defRPr sz="1500" b="0" i="0">
                 <a:solidFill>
                   <a:srgbClr val="101820"/>
@@ -4971,6 +5093,7 @@
           </a:p>
           <a:p xmlns:a="http://schemas.openxmlformats.org/drawingml/2006/main">
             <a:pPr algn="l">
+              <a:buNone/>
               <a:defRPr sz="1500" b="0" i="0">
                 <a:solidFill>
                   <a:srgbClr val="101820"/>
@@ -4988,6 +5111,7 @@
           </a:p>
           <a:p xmlns:a="http://schemas.openxmlformats.org/drawingml/2006/main">
             <a:pPr algn="l">
+              <a:buNone/>
               <a:defRPr sz="1500" b="0" i="0">
                 <a:solidFill>
                   <a:srgbClr val="101820"/>
@@ -5069,6 +5193,7 @@
           <a:lstStyle xmlns:a="http://schemas.openxmlformats.org/drawingml/2006/main"/>
           <a:p xmlns:a="http://schemas.openxmlformats.org/drawingml/2006/main">
             <a:pPr algn="l">
+              <a:buNone/>
               <a:defRPr sz="1725" b="1" i="0">
                 <a:solidFill>
                   <a:srgbClr val="101820"/>
@@ -5148,6 +5273,7 @@
           <a:lstStyle xmlns:a="http://schemas.openxmlformats.org/drawingml/2006/main"/>
           <a:p xmlns:a="http://schemas.openxmlformats.org/drawingml/2006/main">
             <a:pPr algn="l">
+              <a:buNone/>
               <a:defRPr sz="975" b="1" i="0">
                 <a:solidFill>
                   <a:srgbClr val="56616F"/>
@@ -5198,6 +5324,7 @@
           <a:lstStyle xmlns:a="http://schemas.openxmlformats.org/drawingml/2006/main"/>
           <a:p xmlns:a="http://schemas.openxmlformats.org/drawingml/2006/main">
             <a:pPr algn="r">
+              <a:buNone/>
               <a:defRPr sz="975" b="1" i="0">
                 <a:solidFill>
                   <a:srgbClr val="56616F"/>
@@ -5279,6 +5406,7 @@
           <a:lstStyle xmlns:a="http://schemas.openxmlformats.org/drawingml/2006/main"/>
           <a:p xmlns:a="http://schemas.openxmlformats.org/drawingml/2006/main">
             <a:pPr algn="l">
+              <a:buNone/>
               <a:defRPr sz="825" b="0" i="0">
                 <a:solidFill>
                   <a:srgbClr val="56616F"/>
@@ -5329,6 +5457,7 @@
           <a:lstStyle xmlns:a="http://schemas.openxmlformats.org/drawingml/2006/main"/>
           <a:p xmlns:a="http://schemas.openxmlformats.org/drawingml/2006/main">
             <a:pPr algn="r">
+              <a:buNone/>
               <a:defRPr sz="825" b="0" i="0">
                 <a:solidFill>
                   <a:srgbClr val="56616F"/>
@@ -5379,6 +5508,7 @@
           <a:lstStyle xmlns:a="http://schemas.openxmlformats.org/drawingml/2006/main"/>
           <a:p xmlns:a="http://schemas.openxmlformats.org/drawingml/2006/main">
             <a:pPr algn="l">
+              <a:buNone/>
               <a:defRPr sz="3000" b="1" i="0">
                 <a:solidFill>
                   <a:srgbClr val="101820"/>
@@ -5429,6 +5559,7 @@
           <a:lstStyle xmlns:a="http://schemas.openxmlformats.org/drawingml/2006/main"/>
           <a:p xmlns:a="http://schemas.openxmlformats.org/drawingml/2006/main">
             <a:pPr algn="l">
+              <a:buNone/>
               <a:defRPr sz="1350" b="0" i="0">
                 <a:solidFill>
                   <a:srgbClr val="56616F"/>
@@ -5479,6 +5610,7 @@
           <a:lstStyle xmlns:a="http://schemas.openxmlformats.org/drawingml/2006/main"/>
           <a:p xmlns:a="http://schemas.openxmlformats.org/drawingml/2006/main">
             <a:pPr algn="l">
+              <a:buNone/>
               <a:defRPr sz="1350" b="1" i="0">
                 <a:solidFill>
                   <a:srgbClr val="0B3D52"/>
@@ -5560,6 +5692,7 @@
           <a:lstStyle xmlns:a="http://schemas.openxmlformats.org/drawingml/2006/main"/>
           <a:p xmlns:a="http://schemas.openxmlformats.org/drawingml/2006/main">
             <a:pPr algn="l">
+              <a:buNone/>
               <a:defRPr sz="1425" b="1" i="0">
                 <a:solidFill>
                   <a:srgbClr val="101820"/>
@@ -5610,6 +5743,7 @@
           <a:lstStyle xmlns:a="http://schemas.openxmlformats.org/drawingml/2006/main"/>
           <a:p xmlns:a="http://schemas.openxmlformats.org/drawingml/2006/main">
             <a:pPr algn="r">
+              <a:buNone/>
               <a:defRPr sz="1500" b="1" i="0">
                 <a:solidFill>
                   <a:srgbClr val="101820"/>
@@ -5660,6 +5794,7 @@
           <a:lstStyle xmlns:a="http://schemas.openxmlformats.org/drawingml/2006/main"/>
           <a:p xmlns:a="http://schemas.openxmlformats.org/drawingml/2006/main">
             <a:pPr algn="r">
+              <a:buNone/>
               <a:defRPr sz="1200" b="1" i="0">
                 <a:solidFill>
                   <a:srgbClr val="15803D"/>
@@ -5710,6 +5845,7 @@
           <a:lstStyle xmlns:a="http://schemas.openxmlformats.org/drawingml/2006/main"/>
           <a:p xmlns:a="http://schemas.openxmlformats.org/drawingml/2006/main">
             <a:pPr algn="l">
+              <a:buNone/>
               <a:defRPr sz="1425" b="1" i="0">
                 <a:solidFill>
                   <a:srgbClr val="101820"/>
@@ -5760,6 +5896,7 @@
           <a:lstStyle xmlns:a="http://schemas.openxmlformats.org/drawingml/2006/main"/>
           <a:p xmlns:a="http://schemas.openxmlformats.org/drawingml/2006/main">
             <a:pPr algn="r">
+              <a:buNone/>
               <a:defRPr sz="1500" b="1" i="0">
                 <a:solidFill>
                   <a:srgbClr val="101820"/>
@@ -5810,6 +5947,7 @@
           <a:lstStyle xmlns:a="http://schemas.openxmlformats.org/drawingml/2006/main"/>
           <a:p xmlns:a="http://schemas.openxmlformats.org/drawingml/2006/main">
             <a:pPr algn="r">
+              <a:buNone/>
               <a:defRPr sz="1200" b="1" i="0">
                 <a:solidFill>
                   <a:srgbClr val="15803D"/>
@@ -5891,6 +6029,7 @@
           <a:lstStyle xmlns:a="http://schemas.openxmlformats.org/drawingml/2006/main"/>
           <a:p xmlns:a="http://schemas.openxmlformats.org/drawingml/2006/main">
             <a:pPr algn="l">
+              <a:buNone/>
               <a:defRPr sz="1425" b="1" i="0">
                 <a:solidFill>
                   <a:srgbClr val="101820"/>
@@ -5941,6 +6080,7 @@
           <a:lstStyle xmlns:a="http://schemas.openxmlformats.org/drawingml/2006/main"/>
           <a:p xmlns:a="http://schemas.openxmlformats.org/drawingml/2006/main">
             <a:pPr algn="r">
+              <a:buNone/>
               <a:defRPr sz="1500" b="1" i="0">
                 <a:solidFill>
                   <a:srgbClr val="101820"/>
@@ -5991,6 +6131,7 @@
           <a:lstStyle xmlns:a="http://schemas.openxmlformats.org/drawingml/2006/main"/>
           <a:p xmlns:a="http://schemas.openxmlformats.org/drawingml/2006/main">
             <a:pPr algn="r">
+              <a:buNone/>
               <a:defRPr sz="1200" b="1" i="0">
                 <a:solidFill>
                   <a:srgbClr val="F97316"/>
@@ -6041,6 +6182,7 @@
           <a:lstStyle xmlns:a="http://schemas.openxmlformats.org/drawingml/2006/main"/>
           <a:p xmlns:a="http://schemas.openxmlformats.org/drawingml/2006/main">
             <a:pPr algn="l">
+              <a:buNone/>
               <a:defRPr sz="1425" b="1" i="0">
                 <a:solidFill>
                   <a:srgbClr val="101820"/>
@@ -6091,6 +6233,7 @@
           <a:lstStyle xmlns:a="http://schemas.openxmlformats.org/drawingml/2006/main"/>
           <a:p xmlns:a="http://schemas.openxmlformats.org/drawingml/2006/main">
             <a:pPr algn="r">
+              <a:buNone/>
               <a:defRPr sz="1500" b="1" i="0">
                 <a:solidFill>
                   <a:srgbClr val="101820"/>
@@ -6103,7 +6246,7 @@
                   <a:srgbClr val="101820"/>
                 </a:solidFill>
               </a:rPr>
-              <a:t>43</a:t>
+              <a:t>46</a:t>
             </a:r>
           </a:p>
         </p:txBody>
@@ -6141,6 +6284,7 @@
           <a:lstStyle xmlns:a="http://schemas.openxmlformats.org/drawingml/2006/main"/>
           <a:p xmlns:a="http://schemas.openxmlformats.org/drawingml/2006/main">
             <a:pPr algn="r">
+              <a:buNone/>
               <a:defRPr sz="1200" b="1" i="0">
                 <a:solidFill>
                   <a:srgbClr val="15803D"/>
@@ -6222,6 +6366,7 @@
           <a:lstStyle xmlns:a="http://schemas.openxmlformats.org/drawingml/2006/main"/>
           <a:p xmlns:a="http://schemas.openxmlformats.org/drawingml/2006/main">
             <a:pPr algn="l">
+              <a:buNone/>
               <a:defRPr sz="1425" b="1" i="0">
                 <a:solidFill>
                   <a:srgbClr val="101820"/>
@@ -6272,6 +6417,7 @@
           <a:lstStyle xmlns:a="http://schemas.openxmlformats.org/drawingml/2006/main"/>
           <a:p xmlns:a="http://schemas.openxmlformats.org/drawingml/2006/main">
             <a:pPr algn="r">
+              <a:buNone/>
               <a:defRPr sz="1500" b="1" i="0">
                 <a:solidFill>
                   <a:srgbClr val="101820"/>
@@ -6284,7 +6430,7 @@
                   <a:srgbClr val="101820"/>
                 </a:solidFill>
               </a:rPr>
-              <a:t>94.88%</a:t>
+              <a:t>93.88%</a:t>
             </a:r>
           </a:p>
         </p:txBody>
@@ -6322,6 +6468,7 @@
           <a:lstStyle xmlns:a="http://schemas.openxmlformats.org/drawingml/2006/main"/>
           <a:p xmlns:a="http://schemas.openxmlformats.org/drawingml/2006/main">
             <a:pPr algn="r">
+              <a:buNone/>
               <a:defRPr sz="1200" b="1" i="0">
                 <a:solidFill>
                   <a:srgbClr val="15803D"/>
@@ -6403,6 +6550,7 @@
           <a:lstStyle xmlns:a="http://schemas.openxmlformats.org/drawingml/2006/main"/>
           <a:p xmlns:a="http://schemas.openxmlformats.org/drawingml/2006/main">
             <a:pPr algn="l">
+              <a:buNone/>
               <a:defRPr sz="1350" b="1" i="0">
                 <a:solidFill>
                   <a:srgbClr val="0B3D52"/>
@@ -6453,6 +6601,7 @@
           <a:lstStyle xmlns:a="http://schemas.openxmlformats.org/drawingml/2006/main"/>
           <a:p xmlns:a="http://schemas.openxmlformats.org/drawingml/2006/main">
             <a:pPr algn="l">
+              <a:buNone/>
               <a:defRPr sz="1650" b="0" i="0">
                 <a:solidFill>
                   <a:srgbClr val="101820"/>
@@ -6475,6 +6624,7 @@
           </a:p>
           <a:p xmlns:a="http://schemas.openxmlformats.org/drawingml/2006/main">
             <a:pPr algn="l">
+              <a:buNone/>
               <a:defRPr sz="1650" b="0" i="0">
                 <a:solidFill>
                   <a:srgbClr val="101820"/>
@@ -6497,6 +6647,7 @@
           </a:p>
           <a:p xmlns:a="http://schemas.openxmlformats.org/drawingml/2006/main">
             <a:pPr algn="l">
+              <a:buNone/>
               <a:defRPr sz="1650" b="0" i="0">
                 <a:solidFill>
                   <a:srgbClr val="101820"/>
@@ -6519,6 +6670,7 @@
           </a:p>
           <a:p xmlns:a="http://schemas.openxmlformats.org/drawingml/2006/main">
             <a:pPr algn="l">
+              <a:buNone/>
               <a:defRPr sz="1650" b="0" i="0">
                 <a:solidFill>
                   <a:srgbClr val="101820"/>
@@ -6541,6 +6693,7 @@
           </a:p>
           <a:p xmlns:a="http://schemas.openxmlformats.org/drawingml/2006/main">
             <a:pPr algn="l">
+              <a:buNone/>
               <a:defRPr sz="1650" b="0" i="0">
                 <a:solidFill>
                   <a:srgbClr val="101820"/>
@@ -6591,6 +6744,7 @@
           <a:lstStyle xmlns:a="http://schemas.openxmlformats.org/drawingml/2006/main"/>
           <a:p xmlns:a="http://schemas.openxmlformats.org/drawingml/2006/main">
             <a:pPr algn="l">
+              <a:buNone/>
               <a:defRPr sz="1500" b="1" i="0">
                 <a:solidFill>
                   <a:srgbClr val="101820"/>
@@ -6670,6 +6824,7 @@
           <a:lstStyle xmlns:a="http://schemas.openxmlformats.org/drawingml/2006/main"/>
           <a:p xmlns:a="http://schemas.openxmlformats.org/drawingml/2006/main">
             <a:pPr algn="l">
+              <a:buNone/>
               <a:defRPr sz="975" b="1" i="0">
                 <a:solidFill>
                   <a:srgbClr val="56616F"/>
@@ -6720,6 +6875,7 @@
           <a:lstStyle xmlns:a="http://schemas.openxmlformats.org/drawingml/2006/main"/>
           <a:p xmlns:a="http://schemas.openxmlformats.org/drawingml/2006/main">
             <a:pPr algn="r">
+              <a:buNone/>
               <a:defRPr sz="975" b="1" i="0">
                 <a:solidFill>
                   <a:srgbClr val="56616F"/>
@@ -6801,6 +6957,7 @@
           <a:lstStyle xmlns:a="http://schemas.openxmlformats.org/drawingml/2006/main"/>
           <a:p xmlns:a="http://schemas.openxmlformats.org/drawingml/2006/main">
             <a:pPr algn="l">
+              <a:buNone/>
               <a:defRPr sz="825" b="0" i="0">
                 <a:solidFill>
                   <a:srgbClr val="56616F"/>
@@ -6851,6 +7008,7 @@
           <a:lstStyle xmlns:a="http://schemas.openxmlformats.org/drawingml/2006/main"/>
           <a:p xmlns:a="http://schemas.openxmlformats.org/drawingml/2006/main">
             <a:pPr algn="r">
+              <a:buNone/>
               <a:defRPr sz="825" b="0" i="0">
                 <a:solidFill>
                   <a:srgbClr val="56616F"/>
@@ -6901,6 +7059,7 @@
           <a:lstStyle xmlns:a="http://schemas.openxmlformats.org/drawingml/2006/main"/>
           <a:p xmlns:a="http://schemas.openxmlformats.org/drawingml/2006/main">
             <a:pPr algn="l">
+              <a:buNone/>
               <a:defRPr sz="3000" b="1" i="0">
                 <a:solidFill>
                   <a:srgbClr val="101820"/>
@@ -6951,6 +7110,7 @@
           <a:lstStyle xmlns:a="http://schemas.openxmlformats.org/drawingml/2006/main"/>
           <a:p xmlns:a="http://schemas.openxmlformats.org/drawingml/2006/main">
             <a:pPr algn="l">
+              <a:buNone/>
               <a:defRPr sz="1350" b="0" i="0">
                 <a:solidFill>
                   <a:srgbClr val="56616F"/>
@@ -7063,6 +7223,7 @@
           <a:lstStyle xmlns:a="http://schemas.openxmlformats.org/drawingml/2006/main"/>
           <a:p xmlns:a="http://schemas.openxmlformats.org/drawingml/2006/main">
             <a:pPr algn="ctr">
+              <a:buNone/>
               <a:defRPr sz="1200" b="1" i="0">
                 <a:solidFill>
                   <a:srgbClr val="56616F"/>
@@ -7113,6 +7274,7 @@
           <a:lstStyle xmlns:a="http://schemas.openxmlformats.org/drawingml/2006/main"/>
           <a:p xmlns:a="http://schemas.openxmlformats.org/drawingml/2006/main">
             <a:pPr algn="ctr">
+              <a:buNone/>
               <a:defRPr sz="1875" b="1" i="0">
                 <a:solidFill>
                   <a:srgbClr val="101820"/>
@@ -7163,6 +7325,7 @@
           <a:lstStyle xmlns:a="http://schemas.openxmlformats.org/drawingml/2006/main"/>
           <a:p xmlns:a="http://schemas.openxmlformats.org/drawingml/2006/main">
             <a:pPr algn="ctr">
+              <a:buNone/>
               <a:defRPr sz="1500" b="0" i="0">
                 <a:solidFill>
                   <a:srgbClr val="101820"/>
@@ -7180,6 +7343,7 @@
           </a:p>
           <a:p xmlns:a="http://schemas.openxmlformats.org/drawingml/2006/main">
             <a:pPr algn="ctr">
+              <a:buNone/>
               <a:defRPr sz="1500" b="0" i="0">
                 <a:solidFill>
                   <a:srgbClr val="101820"/>
@@ -7197,6 +7361,7 @@
           </a:p>
           <a:p xmlns:a="http://schemas.openxmlformats.org/drawingml/2006/main">
             <a:pPr algn="ctr">
+              <a:buNone/>
               <a:defRPr sz="1500" b="0" i="0">
                 <a:solidFill>
                   <a:srgbClr val="101820"/>
@@ -7278,6 +7443,7 @@
           <a:lstStyle xmlns:a="http://schemas.openxmlformats.org/drawingml/2006/main"/>
           <a:p xmlns:a="http://schemas.openxmlformats.org/drawingml/2006/main">
             <a:pPr algn="ctr">
+              <a:buNone/>
               <a:defRPr sz="1200" b="1" i="0">
                 <a:solidFill>
                   <a:srgbClr val="56616F"/>
@@ -7328,6 +7494,7 @@
           <a:lstStyle xmlns:a="http://schemas.openxmlformats.org/drawingml/2006/main"/>
           <a:p xmlns:a="http://schemas.openxmlformats.org/drawingml/2006/main">
             <a:pPr algn="ctr">
+              <a:buNone/>
               <a:defRPr sz="1875" b="1" i="0">
                 <a:solidFill>
                   <a:srgbClr val="101820"/>
@@ -7340,7 +7507,7 @@
                   <a:srgbClr val="101820"/>
                 </a:solidFill>
               </a:rPr>
-              <a:t>Protect liquidity</a:t>
+              <a:t>Activate rapid-run plan</a:t>
             </a:r>
           </a:p>
         </p:txBody>
@@ -7378,6 +7545,7 @@
           <a:lstStyle xmlns:a="http://schemas.openxmlformats.org/drawingml/2006/main"/>
           <a:p xmlns:a="http://schemas.openxmlformats.org/drawingml/2006/main">
             <a:pPr algn="ctr">
+              <a:buNone/>
               <a:defRPr sz="1500" b="0" i="0">
                 <a:solidFill>
                   <a:srgbClr val="101820"/>
@@ -7395,6 +7563,7 @@
           </a:p>
           <a:p xmlns:a="http://schemas.openxmlformats.org/drawingml/2006/main">
             <a:pPr algn="ctr">
+              <a:buNone/>
               <a:defRPr sz="1500" b="0" i="0">
                 <a:solidFill>
                   <a:srgbClr val="101820"/>
@@ -7412,6 +7581,7 @@
           </a:p>
           <a:p xmlns:a="http://schemas.openxmlformats.org/drawingml/2006/main">
             <a:pPr algn="ctr">
+              <a:buNone/>
               <a:defRPr sz="1500" b="0" i="0">
                 <a:solidFill>
                   <a:srgbClr val="101820"/>
@@ -7424,7 +7594,7 @@
                   <a:srgbClr val="101820"/>
                 </a:solidFill>
               </a:rPr>
-              <a:t>Monitor runoff triggers</a:t>
+              <a:t>Rehearse seven-day response</a:t>
             </a:r>
           </a:p>
         </p:txBody>
@@ -7493,6 +7663,7 @@
           <a:lstStyle xmlns:a="http://schemas.openxmlformats.org/drawingml/2006/main"/>
           <a:p xmlns:a="http://schemas.openxmlformats.org/drawingml/2006/main">
             <a:pPr algn="ctr">
+              <a:buNone/>
               <a:defRPr sz="1200" b="1" i="0">
                 <a:solidFill>
                   <a:srgbClr val="56616F"/>
@@ -7543,6 +7714,7 @@
           <a:lstStyle xmlns:a="http://schemas.openxmlformats.org/drawingml/2006/main"/>
           <a:p xmlns:a="http://schemas.openxmlformats.org/drawingml/2006/main">
             <a:pPr algn="ctr">
+              <a:buNone/>
               <a:defRPr sz="1875" b="1" i="0">
                 <a:solidFill>
                   <a:srgbClr val="101820"/>
@@ -7593,6 +7765,7 @@
           <a:lstStyle xmlns:a="http://schemas.openxmlformats.org/drawingml/2006/main"/>
           <a:p xmlns:a="http://schemas.openxmlformats.org/drawingml/2006/main">
             <a:pPr algn="ctr">
+              <a:buNone/>
               <a:defRPr sz="1500" b="0" i="0">
                 <a:solidFill>
                   <a:srgbClr val="101820"/>
@@ -7610,6 +7783,7 @@
           </a:p>
           <a:p xmlns:a="http://schemas.openxmlformats.org/drawingml/2006/main">
             <a:pPr algn="ctr">
+              <a:buNone/>
               <a:defRPr sz="1500" b="0" i="0">
                 <a:solidFill>
                   <a:srgbClr val="101820"/>
@@ -7627,6 +7801,7 @@
           </a:p>
           <a:p xmlns:a="http://schemas.openxmlformats.org/drawingml/2006/main">
             <a:pPr algn="ctr">
+              <a:buNone/>
               <a:defRPr sz="1500" b="0" i="0">
                 <a:solidFill>
                   <a:srgbClr val="101820"/>
@@ -7708,6 +7883,7 @@
           <a:lstStyle xmlns:a="http://schemas.openxmlformats.org/drawingml/2006/main"/>
           <a:p xmlns:a="http://schemas.openxmlformats.org/drawingml/2006/main">
             <a:pPr algn="ctr">
+              <a:buNone/>
               <a:defRPr sz="1800" b="1" i="0">
                 <a:solidFill>
                   <a:srgbClr val="FFFFFF"/>
@@ -7720,7 +7896,7 @@
                   <a:srgbClr val="FFFFFF"/>
                 </a:solidFill>
               </a:rPr>
-              <a:t>DECISION | Approve the sequence, assign accountable owners, and require post-trade EVE, NII, liquidity and FX revalidation.</a:t>
+              <a:t>DECISION | Approve the sequence, assign owners, activate rapid-run readiness and require post-trade risk revalidation.</a:t>
             </a:r>
           </a:p>
         </p:txBody>
@@ -7787,6 +7963,7 @@
           <a:lstStyle xmlns:a="http://schemas.openxmlformats.org/drawingml/2006/main"/>
           <a:p xmlns:a="http://schemas.openxmlformats.org/drawingml/2006/main">
             <a:pPr algn="l">
+              <a:buNone/>
               <a:defRPr sz="975" b="1" i="0">
                 <a:solidFill>
                   <a:srgbClr val="56616F"/>
@@ -7837,6 +8014,7 @@
           <a:lstStyle xmlns:a="http://schemas.openxmlformats.org/drawingml/2006/main"/>
           <a:p xmlns:a="http://schemas.openxmlformats.org/drawingml/2006/main">
             <a:pPr algn="r">
+              <a:buNone/>
               <a:defRPr sz="975" b="1" i="0">
                 <a:solidFill>
                   <a:srgbClr val="56616F"/>
@@ -7918,6 +8096,7 @@
           <a:lstStyle xmlns:a="http://schemas.openxmlformats.org/drawingml/2006/main"/>
           <a:p xmlns:a="http://schemas.openxmlformats.org/drawingml/2006/main">
             <a:pPr algn="l">
+              <a:buNone/>
               <a:defRPr sz="825" b="0" i="0">
                 <a:solidFill>
                   <a:srgbClr val="56616F"/>
@@ -7968,6 +8147,7 @@
           <a:lstStyle xmlns:a="http://schemas.openxmlformats.org/drawingml/2006/main"/>
           <a:p xmlns:a="http://schemas.openxmlformats.org/drawingml/2006/main">
             <a:pPr algn="r">
+              <a:buNone/>
               <a:defRPr sz="825" b="0" i="0">
                 <a:solidFill>
                   <a:srgbClr val="56616F"/>
@@ -8018,6 +8198,7 @@
           <a:lstStyle xmlns:a="http://schemas.openxmlformats.org/drawingml/2006/main"/>
           <a:p xmlns:a="http://schemas.openxmlformats.org/drawingml/2006/main">
             <a:pPr algn="l">
+              <a:buNone/>
               <a:defRPr sz="3000" b="1" i="0">
                 <a:solidFill>
                   <a:srgbClr val="101820"/>
@@ -8030,7 +8211,7 @@
                   <a:srgbClr val="101820"/>
                 </a:solidFill>
               </a:rPr>
-              <a:t>Hedge FX now; protect liquidity next</a:t>
+              <a:t>Hedge FX now; activate rapid-run readiness next</a:t>
             </a:r>
           </a:p>
         </p:txBody>
@@ -8068,6 +8249,7 @@
           <a:lstStyle xmlns:a="http://schemas.openxmlformats.org/drawingml/2006/main"/>
           <a:p xmlns:a="http://schemas.openxmlformats.org/drawingml/2006/main">
             <a:pPr algn="l">
+              <a:buNone/>
               <a:defRPr sz="1350" b="0" i="0">
                 <a:solidFill>
                   <a:srgbClr val="56616F"/>
@@ -8080,7 +8262,7 @@
                   <a:srgbClr val="56616F"/>
                 </a:solidFill>
               </a:rPr>
-              <a:t>The formal breach is actionable, while liquidity requires a management buffer response.</a:t>
+              <a:t>The formal FX breach is actionable; the severe liquidity test demands operational readiness.</a:t>
             </a:r>
           </a:p>
         </p:txBody>
@@ -8149,6 +8331,7 @@
           <a:lstStyle xmlns:a="http://schemas.openxmlformats.org/drawingml/2006/main"/>
           <a:p xmlns:a="http://schemas.openxmlformats.org/drawingml/2006/main">
             <a:pPr algn="l">
+              <a:buNone/>
               <a:defRPr sz="3600" b="1" i="0">
                 <a:solidFill>
                   <a:srgbClr val="F97316"/>
@@ -8199,6 +8382,7 @@
           <a:lstStyle xmlns:a="http://schemas.openxmlformats.org/drawingml/2006/main"/>
           <a:p xmlns:a="http://schemas.openxmlformats.org/drawingml/2006/main">
             <a:pPr algn="l">
+              <a:buNone/>
               <a:defRPr sz="1650" b="1" i="0">
                 <a:solidFill>
                   <a:srgbClr val="101820"/>
@@ -8280,6 +8464,7 @@
           <a:lstStyle xmlns:a="http://schemas.openxmlformats.org/drawingml/2006/main"/>
           <a:p xmlns:a="http://schemas.openxmlformats.org/drawingml/2006/main">
             <a:pPr algn="l">
+              <a:buNone/>
               <a:defRPr sz="1200" b="0" i="0">
                 <a:solidFill>
                   <a:srgbClr val="56616F"/>
@@ -8361,6 +8546,7 @@
           <a:lstStyle xmlns:a="http://schemas.openxmlformats.org/drawingml/2006/main"/>
           <a:p xmlns:a="http://schemas.openxmlformats.org/drawingml/2006/main">
             <a:pPr algn="l">
+              <a:buNone/>
               <a:defRPr sz="3600" b="1" i="0">
                 <a:solidFill>
                   <a:srgbClr val="F97316"/>
@@ -8373,7 +8559,7 @@
                   <a:srgbClr val="F97316"/>
                 </a:solidFill>
               </a:rPr>
-              <a:t>94.8%</a:t>
+              <a:t>78.1%</a:t>
             </a:r>
           </a:p>
         </p:txBody>
@@ -8411,6 +8597,7 @@
           <a:lstStyle xmlns:a="http://schemas.openxmlformats.org/drawingml/2006/main"/>
           <a:p xmlns:a="http://schemas.openxmlformats.org/drawingml/2006/main">
             <a:pPr algn="l">
+              <a:buNone/>
               <a:defRPr sz="1650" b="1" i="0">
                 <a:solidFill>
                   <a:srgbClr val="101820"/>
@@ -8423,7 +8610,7 @@
                   <a:srgbClr val="101820"/>
                 </a:solidFill>
               </a:rPr>
-              <a:t>Combined LCR proxy</a:t>
+              <a:t>Rapid-run LCR proxy</a:t>
             </a:r>
           </a:p>
         </p:txBody>
@@ -8492,6 +8679,7 @@
           <a:lstStyle xmlns:a="http://schemas.openxmlformats.org/drawingml/2006/main"/>
           <a:p xmlns:a="http://schemas.openxmlformats.org/drawingml/2006/main">
             <a:pPr algn="l">
+              <a:buNone/>
               <a:defRPr sz="1200" b="0" i="0">
                 <a:solidFill>
                   <a:srgbClr val="56616F"/>
@@ -8504,7 +8692,7 @@
                   <a:srgbClr val="56616F"/>
                 </a:solidFill>
               </a:rPr>
-              <a:t>Below 100% in combined stress</a:t>
+              <a:t>7-day survival | exploratory</a:t>
             </a:r>
           </a:p>
         </p:txBody>
@@ -8573,6 +8761,7 @@
           <a:lstStyle xmlns:a="http://schemas.openxmlformats.org/drawingml/2006/main"/>
           <a:p xmlns:a="http://schemas.openxmlformats.org/drawingml/2006/main">
             <a:pPr algn="l">
+              <a:buNone/>
               <a:defRPr sz="3600" b="1" i="0">
                 <a:solidFill>
                   <a:srgbClr val="15803D"/>
@@ -8623,6 +8812,7 @@
           <a:lstStyle xmlns:a="http://schemas.openxmlformats.org/drawingml/2006/main"/>
           <a:p xmlns:a="http://schemas.openxmlformats.org/drawingml/2006/main">
             <a:pPr algn="l">
+              <a:buNone/>
               <a:defRPr sz="1650" b="1" i="0">
                 <a:solidFill>
                   <a:srgbClr val="101820"/>
@@ -8704,6 +8894,7 @@
           <a:lstStyle xmlns:a="http://schemas.openxmlformats.org/drawingml/2006/main"/>
           <a:p xmlns:a="http://schemas.openxmlformats.org/drawingml/2006/main">
             <a:pPr algn="l">
+              <a:buNone/>
               <a:defRPr sz="1200" b="0" i="0">
                 <a:solidFill>
                   <a:srgbClr val="56616F"/>
@@ -8754,6 +8945,7 @@
           <a:lstStyle xmlns:a="http://schemas.openxmlformats.org/drawingml/2006/main"/>
           <a:p xmlns:a="http://schemas.openxmlformats.org/drawingml/2006/main">
             <a:pPr algn="l">
+              <a:buNone/>
               <a:defRPr sz="2100" b="1" i="0">
                 <a:solidFill>
                   <a:srgbClr val="101820"/>
@@ -8766,7 +8958,7 @@
                   <a:srgbClr val="101820"/>
                 </a:solidFill>
               </a:rPr>
-              <a:t>Decision ask | Approve the FX remediation target, preserve the liquidity buffer, and authorize validation of TRY IRS sizing before execution.</a:t>
+              <a:t>Decision ask | Approve FX remediation, preserve the liquidity buffer, activate the rapid-run contingency plan, and validate TRY IRS sizing.</a:t>
             </a:r>
           </a:p>
         </p:txBody>
@@ -8804,6 +8996,7 @@
           <a:lstStyle xmlns:a="http://schemas.openxmlformats.org/drawingml/2006/main"/>
           <a:p xmlns:a="http://schemas.openxmlformats.org/drawingml/2006/main">
             <a:pPr algn="l">
+              <a:buNone/>
               <a:defRPr sz="1275" b="0" i="0">
                 <a:solidFill>
                   <a:srgbClr val="56616F"/>
@@ -8883,6 +9076,7 @@
           <a:lstStyle xmlns:a="http://schemas.openxmlformats.org/drawingml/2006/main"/>
           <a:p xmlns:a="http://schemas.openxmlformats.org/drawingml/2006/main">
             <a:pPr algn="l">
+              <a:buNone/>
               <a:defRPr sz="975" b="1" i="0">
                 <a:solidFill>
                   <a:srgbClr val="56616F"/>
@@ -8933,6 +9127,7 @@
           <a:lstStyle xmlns:a="http://schemas.openxmlformats.org/drawingml/2006/main"/>
           <a:p xmlns:a="http://schemas.openxmlformats.org/drawingml/2006/main">
             <a:pPr algn="r">
+              <a:buNone/>
               <a:defRPr sz="975" b="1" i="0">
                 <a:solidFill>
                   <a:srgbClr val="56616F"/>
@@ -9014,6 +9209,7 @@
           <a:lstStyle xmlns:a="http://schemas.openxmlformats.org/drawingml/2006/main"/>
           <a:p xmlns:a="http://schemas.openxmlformats.org/drawingml/2006/main">
             <a:pPr algn="l">
+              <a:buNone/>
               <a:defRPr sz="825" b="0" i="0">
                 <a:solidFill>
                   <a:srgbClr val="56616F"/>
@@ -9064,6 +9260,7 @@
           <a:lstStyle xmlns:a="http://schemas.openxmlformats.org/drawingml/2006/main"/>
           <a:p xmlns:a="http://schemas.openxmlformats.org/drawingml/2006/main">
             <a:pPr algn="r">
+              <a:buNone/>
               <a:defRPr sz="825" b="0" i="0">
                 <a:solidFill>
                   <a:srgbClr val="56616F"/>
@@ -9114,6 +9311,7 @@
           <a:lstStyle xmlns:a="http://schemas.openxmlformats.org/drawingml/2006/main"/>
           <a:p xmlns:a="http://schemas.openxmlformats.org/drawingml/2006/main">
             <a:pPr algn="l">
+              <a:buNone/>
               <a:defRPr sz="3000" b="1" i="0">
                 <a:solidFill>
                   <a:srgbClr val="101820"/>
@@ -9164,6 +9362,7 @@
           <a:lstStyle xmlns:a="http://schemas.openxmlformats.org/drawingml/2006/main"/>
           <a:p xmlns:a="http://schemas.openxmlformats.org/drawingml/2006/main">
             <a:pPr algn="l">
+              <a:buNone/>
               <a:defRPr sz="1350" b="0" i="0">
                 <a:solidFill>
                   <a:srgbClr val="56616F"/>
@@ -9245,6 +9444,7 @@
           <a:lstStyle xmlns:a="http://schemas.openxmlformats.org/drawingml/2006/main"/>
           <a:p xmlns:a="http://schemas.openxmlformats.org/drawingml/2006/main">
             <a:pPr algn="l">
+              <a:buNone/>
               <a:defRPr sz="1350" b="1" i="0">
                 <a:solidFill>
                   <a:srgbClr val="0B3D52"/>
@@ -9326,6 +9526,7 @@
           <a:lstStyle xmlns:a="http://schemas.openxmlformats.org/drawingml/2006/main"/>
           <a:p xmlns:a="http://schemas.openxmlformats.org/drawingml/2006/main">
             <a:pPr algn="l">
+              <a:buNone/>
               <a:defRPr sz="1650" b="0" i="0">
                 <a:solidFill>
                   <a:srgbClr val="101820"/>
@@ -9343,6 +9544,7 @@
           </a:p>
           <a:p xmlns:a="http://schemas.openxmlformats.org/drawingml/2006/main">
             <a:pPr algn="l">
+              <a:buNone/>
               <a:defRPr sz="1650" b="0" i="0">
                 <a:solidFill>
                   <a:srgbClr val="101820"/>
@@ -9360,6 +9562,7 @@
           </a:p>
           <a:p xmlns:a="http://schemas.openxmlformats.org/drawingml/2006/main">
             <a:pPr algn="l">
+              <a:buNone/>
               <a:defRPr sz="1650" b="0" i="0">
                 <a:solidFill>
                   <a:srgbClr val="101820"/>
@@ -9410,6 +9613,7 @@
           <a:lstStyle xmlns:a="http://schemas.openxmlformats.org/drawingml/2006/main"/>
           <a:p xmlns:a="http://schemas.openxmlformats.org/drawingml/2006/main">
             <a:pPr algn="l">
+              <a:buNone/>
               <a:defRPr sz="1125" b="1" i="0">
                 <a:solidFill>
                   <a:srgbClr val="56616F"/>
@@ -9460,6 +9664,7 @@
           <a:lstStyle xmlns:a="http://schemas.openxmlformats.org/drawingml/2006/main"/>
           <a:p xmlns:a="http://schemas.openxmlformats.org/drawingml/2006/main">
             <a:pPr algn="ctr">
+              <a:buNone/>
               <a:defRPr sz="2550" b="1" i="0">
                 <a:solidFill>
                   <a:srgbClr val="167CA5"/>
@@ -9541,6 +9746,7 @@
           <a:lstStyle xmlns:a="http://schemas.openxmlformats.org/drawingml/2006/main"/>
           <a:p xmlns:a="http://schemas.openxmlformats.org/drawingml/2006/main">
             <a:pPr algn="l">
+              <a:buNone/>
               <a:defRPr sz="1350" b="1" i="0">
                 <a:solidFill>
                   <a:srgbClr val="0B3D52"/>
@@ -9622,6 +9828,7 @@
           <a:lstStyle xmlns:a="http://schemas.openxmlformats.org/drawingml/2006/main"/>
           <a:p xmlns:a="http://schemas.openxmlformats.org/drawingml/2006/main">
             <a:pPr algn="l">
+              <a:buNone/>
               <a:defRPr sz="1650" b="0" i="0">
                 <a:solidFill>
                   <a:srgbClr val="101820"/>
@@ -9639,6 +9846,7 @@
           </a:p>
           <a:p xmlns:a="http://schemas.openxmlformats.org/drawingml/2006/main">
             <a:pPr algn="l">
+              <a:buNone/>
               <a:defRPr sz="1650" b="0" i="0">
                 <a:solidFill>
                   <a:srgbClr val="101820"/>
@@ -9656,6 +9864,7 @@
           </a:p>
           <a:p xmlns:a="http://schemas.openxmlformats.org/drawingml/2006/main">
             <a:pPr algn="l">
+              <a:buNone/>
               <a:defRPr sz="1650" b="0" i="0">
                 <a:solidFill>
                   <a:srgbClr val="101820"/>
@@ -9706,6 +9915,7 @@
           <a:lstStyle xmlns:a="http://schemas.openxmlformats.org/drawingml/2006/main"/>
           <a:p xmlns:a="http://schemas.openxmlformats.org/drawingml/2006/main">
             <a:pPr algn="l">
+              <a:buNone/>
               <a:defRPr sz="1125" b="1" i="0">
                 <a:solidFill>
                   <a:srgbClr val="56616F"/>
@@ -9756,6 +9966,7 @@
           <a:lstStyle xmlns:a="http://schemas.openxmlformats.org/drawingml/2006/main"/>
           <a:p xmlns:a="http://schemas.openxmlformats.org/drawingml/2006/main">
             <a:pPr algn="ctr">
+              <a:buNone/>
               <a:defRPr sz="2550" b="1" i="0">
                 <a:solidFill>
                   <a:srgbClr val="167CA5"/>
@@ -9837,6 +10048,7 @@
           <a:lstStyle xmlns:a="http://schemas.openxmlformats.org/drawingml/2006/main"/>
           <a:p xmlns:a="http://schemas.openxmlformats.org/drawingml/2006/main">
             <a:pPr algn="l">
+              <a:buNone/>
               <a:defRPr sz="1350" b="1" i="0">
                 <a:solidFill>
                   <a:srgbClr val="0B3D52"/>
@@ -9918,6 +10130,7 @@
           <a:lstStyle xmlns:a="http://schemas.openxmlformats.org/drawingml/2006/main"/>
           <a:p xmlns:a="http://schemas.openxmlformats.org/drawingml/2006/main">
             <a:pPr algn="l">
+              <a:buNone/>
               <a:defRPr sz="1650" b="0" i="0">
                 <a:solidFill>
                   <a:srgbClr val="101820"/>
@@ -9935,6 +10148,7 @@
           </a:p>
           <a:p xmlns:a="http://schemas.openxmlformats.org/drawingml/2006/main">
             <a:pPr algn="l">
+              <a:buNone/>
               <a:defRPr sz="1650" b="0" i="0">
                 <a:solidFill>
                   <a:srgbClr val="101820"/>
@@ -9952,6 +10166,7 @@
           </a:p>
           <a:p xmlns:a="http://schemas.openxmlformats.org/drawingml/2006/main">
             <a:pPr algn="l">
+              <a:buNone/>
               <a:defRPr sz="1650" b="0" i="0">
                 <a:solidFill>
                   <a:srgbClr val="101820"/>
@@ -10002,6 +10217,7 @@
           <a:lstStyle xmlns:a="http://schemas.openxmlformats.org/drawingml/2006/main"/>
           <a:p xmlns:a="http://schemas.openxmlformats.org/drawingml/2006/main">
             <a:pPr algn="l">
+              <a:buNone/>
               <a:defRPr sz="1125" b="1" i="0">
                 <a:solidFill>
                   <a:srgbClr val="56616F"/>
@@ -10052,6 +10268,7 @@
           <a:lstStyle xmlns:a="http://schemas.openxmlformats.org/drawingml/2006/main"/>
           <a:p xmlns:a="http://schemas.openxmlformats.org/drawingml/2006/main">
             <a:pPr algn="l">
+              <a:buNone/>
               <a:defRPr sz="1650" b="1" i="0">
                 <a:solidFill>
                   <a:srgbClr val="101820"/>
@@ -10131,6 +10348,7 @@
           <a:lstStyle xmlns:a="http://schemas.openxmlformats.org/drawingml/2006/main"/>
           <a:p xmlns:a="http://schemas.openxmlformats.org/drawingml/2006/main">
             <a:pPr algn="l">
+              <a:buNone/>
               <a:defRPr sz="975" b="1" i="0">
                 <a:solidFill>
                   <a:srgbClr val="56616F"/>
@@ -10181,6 +10399,7 @@
           <a:lstStyle xmlns:a="http://schemas.openxmlformats.org/drawingml/2006/main"/>
           <a:p xmlns:a="http://schemas.openxmlformats.org/drawingml/2006/main">
             <a:pPr algn="r">
+              <a:buNone/>
               <a:defRPr sz="975" b="1" i="0">
                 <a:solidFill>
                   <a:srgbClr val="56616F"/>
@@ -10262,6 +10481,7 @@
           <a:lstStyle xmlns:a="http://schemas.openxmlformats.org/drawingml/2006/main"/>
           <a:p xmlns:a="http://schemas.openxmlformats.org/drawingml/2006/main">
             <a:pPr algn="l">
+              <a:buNone/>
               <a:defRPr sz="825" b="0" i="0">
                 <a:solidFill>
                   <a:srgbClr val="56616F"/>
@@ -10312,6 +10532,7 @@
           <a:lstStyle xmlns:a="http://schemas.openxmlformats.org/drawingml/2006/main"/>
           <a:p xmlns:a="http://schemas.openxmlformats.org/drawingml/2006/main">
             <a:pPr algn="r">
+              <a:buNone/>
               <a:defRPr sz="825" b="0" i="0">
                 <a:solidFill>
                   <a:srgbClr val="56616F"/>
@@ -10362,6 +10583,7 @@
           <a:lstStyle xmlns:a="http://schemas.openxmlformats.org/drawingml/2006/main"/>
           <a:p xmlns:a="http://schemas.openxmlformats.org/drawingml/2006/main">
             <a:pPr algn="l">
+              <a:buNone/>
               <a:defRPr sz="3000" b="1" i="0">
                 <a:solidFill>
                   <a:srgbClr val="101820"/>
@@ -10412,6 +10634,7 @@
           <a:lstStyle xmlns:a="http://schemas.openxmlformats.org/drawingml/2006/main"/>
           <a:p xmlns:a="http://schemas.openxmlformats.org/drawingml/2006/main">
             <a:pPr algn="l">
+              <a:buNone/>
               <a:defRPr sz="1350" b="0" i="0">
                 <a:solidFill>
                   <a:srgbClr val="56616F"/>
@@ -10431,7 +10654,7 @@
       </p:sp>
       <p:graphicFrame>
         <p:nvGraphicFramePr>
-          <p:cNvPr id="22" name="Chart"/>
+          <p:cNvPr id="24" name="Chart"/>
           <p:cNvGraphicFramePr/>
           <p:nvPr/>
         </p:nvGraphicFramePr>
@@ -10441,7 +10664,7 @@
         </p:xfrm>
         <a:graphic xmlns:a="http://schemas.openxmlformats.org/drawingml/2006/main">
           <a:graphicData uri="http://schemas.openxmlformats.org/drawingml/2006/chart">
-            <c:chart xmlns:r="http://schemas.openxmlformats.org/officeDocument/2006/relationships" xmlns:c="http://schemas.openxmlformats.org/drawingml/2006/chart" r:id="R5c48f92ac7774c5a"/>
+            <c:chart xmlns:r="http://schemas.openxmlformats.org/officeDocument/2006/relationships" xmlns:c="http://schemas.openxmlformats.org/drawingml/2006/chart" r:id="R19e00ebbc87340f3"/>
           </a:graphicData>
         </a:graphic>
       </p:graphicFrame>
@@ -10509,6 +10732,7 @@
           <a:lstStyle xmlns:a="http://schemas.openxmlformats.org/drawingml/2006/main"/>
           <a:p xmlns:a="http://schemas.openxmlformats.org/drawingml/2006/main">
             <a:pPr algn="l">
+              <a:buNone/>
               <a:defRPr sz="3150" b="1" i="0">
                 <a:solidFill>
                   <a:srgbClr val="101820"/>
@@ -10559,6 +10783,7 @@
           <a:lstStyle xmlns:a="http://schemas.openxmlformats.org/drawingml/2006/main"/>
           <a:p xmlns:a="http://schemas.openxmlformats.org/drawingml/2006/main">
             <a:pPr algn="l">
+              <a:buNone/>
               <a:defRPr sz="1650" b="1" i="0">
                 <a:solidFill>
                   <a:srgbClr val="0B3D52"/>
@@ -10640,6 +10865,7 @@
           <a:lstStyle xmlns:a="http://schemas.openxmlformats.org/drawingml/2006/main"/>
           <a:p xmlns:a="http://schemas.openxmlformats.org/drawingml/2006/main">
             <a:pPr algn="l">
+              <a:buNone/>
               <a:defRPr sz="1725" b="0" i="0">
                 <a:solidFill>
                   <a:srgbClr val="101820"/>
@@ -10657,6 +10883,7 @@
           </a:p>
           <a:p xmlns:a="http://schemas.openxmlformats.org/drawingml/2006/main">
             <a:pPr algn="l">
+              <a:buNone/>
               <a:defRPr sz="1725" b="0" i="0">
                 <a:solidFill>
                   <a:srgbClr val="101820"/>
@@ -10679,6 +10906,7 @@
           </a:p>
           <a:p xmlns:a="http://schemas.openxmlformats.org/drawingml/2006/main">
             <a:pPr algn="l">
+              <a:buNone/>
               <a:defRPr sz="1725" b="0" i="0">
                 <a:solidFill>
                   <a:srgbClr val="101820"/>
@@ -10696,6 +10924,7 @@
           </a:p>
           <a:p xmlns:a="http://schemas.openxmlformats.org/drawingml/2006/main">
             <a:pPr algn="l">
+              <a:buNone/>
               <a:defRPr sz="1725" b="0" i="0">
                 <a:solidFill>
                   <a:srgbClr val="101820"/>
@@ -10746,6 +10975,7 @@
           <a:lstStyle xmlns:a="http://schemas.openxmlformats.org/drawingml/2006/main"/>
           <a:p xmlns:a="http://schemas.openxmlformats.org/drawingml/2006/main">
             <a:pPr algn="l">
+              <a:buNone/>
               <a:defRPr sz="1500" b="1" i="0">
                 <a:solidFill>
                   <a:srgbClr val="101820"/>
@@ -10825,6 +11055,7 @@
           <a:lstStyle xmlns:a="http://schemas.openxmlformats.org/drawingml/2006/main"/>
           <a:p xmlns:a="http://schemas.openxmlformats.org/drawingml/2006/main">
             <a:pPr algn="l">
+              <a:buNone/>
               <a:defRPr sz="975" b="1" i="0">
                 <a:solidFill>
                   <a:srgbClr val="56616F"/>
@@ -10875,6 +11106,7 @@
           <a:lstStyle xmlns:a="http://schemas.openxmlformats.org/drawingml/2006/main"/>
           <a:p xmlns:a="http://schemas.openxmlformats.org/drawingml/2006/main">
             <a:pPr algn="r">
+              <a:buNone/>
               <a:defRPr sz="975" b="1" i="0">
                 <a:solidFill>
                   <a:srgbClr val="56616F"/>
@@ -10956,6 +11188,7 @@
           <a:lstStyle xmlns:a="http://schemas.openxmlformats.org/drawingml/2006/main"/>
           <a:p xmlns:a="http://schemas.openxmlformats.org/drawingml/2006/main">
             <a:pPr algn="l">
+              <a:buNone/>
               <a:defRPr sz="825" b="0" i="0">
                 <a:solidFill>
                   <a:srgbClr val="56616F"/>
@@ -11006,6 +11239,7 @@
           <a:lstStyle xmlns:a="http://schemas.openxmlformats.org/drawingml/2006/main"/>
           <a:p xmlns:a="http://schemas.openxmlformats.org/drawingml/2006/main">
             <a:pPr algn="r">
+              <a:buNone/>
               <a:defRPr sz="825" b="0" i="0">
                 <a:solidFill>
                   <a:srgbClr val="56616F"/>
@@ -11056,6 +11290,7 @@
           <a:lstStyle xmlns:a="http://schemas.openxmlformats.org/drawingml/2006/main"/>
           <a:p xmlns:a="http://schemas.openxmlformats.org/drawingml/2006/main">
             <a:pPr algn="l">
+              <a:buNone/>
               <a:defRPr sz="3000" b="1" i="0">
                 <a:solidFill>
                   <a:srgbClr val="101820"/>
@@ -11106,6 +11341,7 @@
           <a:lstStyle xmlns:a="http://schemas.openxmlformats.org/drawingml/2006/main"/>
           <a:p xmlns:a="http://schemas.openxmlformats.org/drawingml/2006/main">
             <a:pPr algn="l">
+              <a:buNone/>
               <a:defRPr sz="1350" b="0" i="0">
                 <a:solidFill>
                   <a:srgbClr val="56616F"/>
@@ -11125,7 +11361,7 @@
       </p:sp>
       <p:graphicFrame>
         <p:nvGraphicFramePr>
-          <p:cNvPr id="21" name="Chart"/>
+          <p:cNvPr id="23" name="Chart"/>
           <p:cNvGraphicFramePr/>
           <p:nvPr/>
         </p:nvGraphicFramePr>
@@ -11135,7 +11371,7 @@
         </p:xfrm>
         <a:graphic xmlns:a="http://schemas.openxmlformats.org/drawingml/2006/main">
           <a:graphicData uri="http://schemas.openxmlformats.org/drawingml/2006/chart">
-            <c:chart xmlns:r="http://schemas.openxmlformats.org/officeDocument/2006/relationships" xmlns:c="http://schemas.openxmlformats.org/drawingml/2006/chart" r:id="R749e7649d16a4b78"/>
+            <c:chart xmlns:r="http://schemas.openxmlformats.org/officeDocument/2006/relationships" xmlns:c="http://schemas.openxmlformats.org/drawingml/2006/chart" r:id="R9a1f61d49045497d"/>
           </a:graphicData>
         </a:graphic>
       </p:graphicFrame>
@@ -11203,6 +11439,7 @@
           <a:lstStyle xmlns:a="http://schemas.openxmlformats.org/drawingml/2006/main"/>
           <a:p xmlns:a="http://schemas.openxmlformats.org/drawingml/2006/main">
             <a:pPr algn="l">
+              <a:buNone/>
               <a:defRPr sz="1200" b="1" i="0">
                 <a:solidFill>
                   <a:srgbClr val="0B3D52"/>
@@ -11253,6 +11490,7 @@
           <a:lstStyle xmlns:a="http://schemas.openxmlformats.org/drawingml/2006/main"/>
           <a:p xmlns:a="http://schemas.openxmlformats.org/drawingml/2006/main">
             <a:pPr algn="l">
+              <a:buNone/>
               <a:defRPr sz="1650" b="1" i="0">
                 <a:solidFill>
                   <a:srgbClr val="101820"/>
@@ -11334,6 +11572,7 @@
           <a:lstStyle xmlns:a="http://schemas.openxmlformats.org/drawingml/2006/main"/>
           <a:p xmlns:a="http://schemas.openxmlformats.org/drawingml/2006/main">
             <a:pPr algn="l">
+              <a:buNone/>
               <a:defRPr sz="1350" b="0" i="0">
                 <a:solidFill>
                   <a:srgbClr val="56616F"/>
@@ -11351,6 +11590,7 @@
           </a:p>
           <a:p xmlns:a="http://schemas.openxmlformats.org/drawingml/2006/main">
             <a:pPr algn="l">
+              <a:buNone/>
               <a:defRPr sz="1350" b="0" i="0">
                 <a:solidFill>
                   <a:srgbClr val="56616F"/>
@@ -11430,6 +11670,7 @@
           <a:lstStyle xmlns:a="http://schemas.openxmlformats.org/drawingml/2006/main"/>
           <a:p xmlns:a="http://schemas.openxmlformats.org/drawingml/2006/main">
             <a:pPr algn="l">
+              <a:buNone/>
               <a:defRPr sz="975" b="1" i="0">
                 <a:solidFill>
                   <a:srgbClr val="56616F"/>
@@ -11480,6 +11721,7 @@
           <a:lstStyle xmlns:a="http://schemas.openxmlformats.org/drawingml/2006/main"/>
           <a:p xmlns:a="http://schemas.openxmlformats.org/drawingml/2006/main">
             <a:pPr algn="r">
+              <a:buNone/>
               <a:defRPr sz="975" b="1" i="0">
                 <a:solidFill>
                   <a:srgbClr val="56616F"/>
@@ -11561,6 +11803,7 @@
           <a:lstStyle xmlns:a="http://schemas.openxmlformats.org/drawingml/2006/main"/>
           <a:p xmlns:a="http://schemas.openxmlformats.org/drawingml/2006/main">
             <a:pPr algn="l">
+              <a:buNone/>
               <a:defRPr sz="825" b="0" i="0">
                 <a:solidFill>
                   <a:srgbClr val="56616F"/>
@@ -11611,6 +11854,7 @@
           <a:lstStyle xmlns:a="http://schemas.openxmlformats.org/drawingml/2006/main"/>
           <a:p xmlns:a="http://schemas.openxmlformats.org/drawingml/2006/main">
             <a:pPr algn="r">
+              <a:buNone/>
               <a:defRPr sz="825" b="0" i="0">
                 <a:solidFill>
                   <a:srgbClr val="56616F"/>
@@ -11661,6 +11905,7 @@
           <a:lstStyle xmlns:a="http://schemas.openxmlformats.org/drawingml/2006/main"/>
           <a:p xmlns:a="http://schemas.openxmlformats.org/drawingml/2006/main">
             <a:pPr algn="l">
+              <a:buNone/>
               <a:defRPr sz="3000" b="1" i="0">
                 <a:solidFill>
                   <a:srgbClr val="101820"/>
@@ -11711,6 +11956,7 @@
           <a:lstStyle xmlns:a="http://schemas.openxmlformats.org/drawingml/2006/main"/>
           <a:p xmlns:a="http://schemas.openxmlformats.org/drawingml/2006/main">
             <a:pPr algn="l">
+              <a:buNone/>
               <a:defRPr sz="1350" b="0" i="0">
                 <a:solidFill>
                   <a:srgbClr val="56616F"/>
@@ -11730,7 +11976,7 @@
       </p:sp>
       <p:graphicFrame>
         <p:nvGraphicFramePr>
-          <p:cNvPr id="22" name="Chart"/>
+          <p:cNvPr id="24" name="Chart"/>
           <p:cNvGraphicFramePr/>
           <p:nvPr/>
         </p:nvGraphicFramePr>
@@ -11740,7 +11986,7 @@
         </p:xfrm>
         <a:graphic xmlns:a="http://schemas.openxmlformats.org/drawingml/2006/main">
           <a:graphicData uri="http://schemas.openxmlformats.org/drawingml/2006/chart">
-            <c:chart xmlns:r="http://schemas.openxmlformats.org/officeDocument/2006/relationships" xmlns:c="http://schemas.openxmlformats.org/drawingml/2006/chart" r:id="R9aaec2a0c7d04ecb"/>
+            <c:chart xmlns:r="http://schemas.openxmlformats.org/officeDocument/2006/relationships" xmlns:c="http://schemas.openxmlformats.org/drawingml/2006/chart" r:id="Rd7e966b4c72a4c79"/>
           </a:graphicData>
         </a:graphic>
       </p:graphicFrame>
@@ -11808,6 +12054,7 @@
           <a:lstStyle xmlns:a="http://schemas.openxmlformats.org/drawingml/2006/main"/>
           <a:p xmlns:a="http://schemas.openxmlformats.org/drawingml/2006/main">
             <a:pPr algn="l">
+              <a:buNone/>
               <a:defRPr sz="3450" b="1" i="0">
                 <a:solidFill>
                   <a:srgbClr val="F97316"/>
@@ -11858,6 +12105,7 @@
           <a:lstStyle xmlns:a="http://schemas.openxmlformats.org/drawingml/2006/main"/>
           <a:p xmlns:a="http://schemas.openxmlformats.org/drawingml/2006/main">
             <a:pPr algn="l">
+              <a:buNone/>
               <a:defRPr sz="1425" b="1" i="0">
                 <a:solidFill>
                   <a:srgbClr val="101820"/>
@@ -11875,6 +12123,7 @@
           </a:p>
           <a:p xmlns:a="http://schemas.openxmlformats.org/drawingml/2006/main">
             <a:pPr algn="l">
+              <a:buNone/>
               <a:defRPr sz="1425" b="1" i="0">
                 <a:solidFill>
                   <a:srgbClr val="101820"/>
@@ -11956,6 +12205,7 @@
           <a:lstStyle xmlns:a="http://schemas.openxmlformats.org/drawingml/2006/main"/>
           <a:p xmlns:a="http://schemas.openxmlformats.org/drawingml/2006/main">
             <a:pPr algn="l">
+              <a:buNone/>
               <a:defRPr sz="2550" b="1" i="0">
                 <a:solidFill>
                   <a:srgbClr val="101820"/>
@@ -12006,6 +12256,7 @@
           <a:lstStyle xmlns:a="http://schemas.openxmlformats.org/drawingml/2006/main"/>
           <a:p xmlns:a="http://schemas.openxmlformats.org/drawingml/2006/main">
             <a:pPr algn="l">
+              <a:buNone/>
               <a:defRPr sz="1350" b="0" i="0">
                 <a:solidFill>
                   <a:srgbClr val="56616F"/>
@@ -12023,6 +12274,7 @@
           </a:p>
           <a:p xmlns:a="http://schemas.openxmlformats.org/drawingml/2006/main">
             <a:pPr algn="l">
+              <a:buNone/>
               <a:defRPr sz="1350" b="0" i="0">
                 <a:solidFill>
                   <a:srgbClr val="56616F"/>
@@ -12102,6 +12354,7 @@
           <a:lstStyle xmlns:a="http://schemas.openxmlformats.org/drawingml/2006/main"/>
           <a:p xmlns:a="http://schemas.openxmlformats.org/drawingml/2006/main">
             <a:pPr algn="l">
+              <a:buNone/>
               <a:defRPr sz="975" b="1" i="0">
                 <a:solidFill>
                   <a:srgbClr val="56616F"/>
@@ -12152,6 +12405,7 @@
           <a:lstStyle xmlns:a="http://schemas.openxmlformats.org/drawingml/2006/main"/>
           <a:p xmlns:a="http://schemas.openxmlformats.org/drawingml/2006/main">
             <a:pPr algn="r">
+              <a:buNone/>
               <a:defRPr sz="975" b="1" i="0">
                 <a:solidFill>
                   <a:srgbClr val="56616F"/>
@@ -12233,6 +12487,7 @@
           <a:lstStyle xmlns:a="http://schemas.openxmlformats.org/drawingml/2006/main"/>
           <a:p xmlns:a="http://schemas.openxmlformats.org/drawingml/2006/main">
             <a:pPr algn="l">
+              <a:buNone/>
               <a:defRPr sz="825" b="0" i="0">
                 <a:solidFill>
                   <a:srgbClr val="56616F"/>
@@ -12283,6 +12538,7 @@
           <a:lstStyle xmlns:a="http://schemas.openxmlformats.org/drawingml/2006/main"/>
           <a:p xmlns:a="http://schemas.openxmlformats.org/drawingml/2006/main">
             <a:pPr algn="r">
+              <a:buNone/>
               <a:defRPr sz="825" b="0" i="0">
                 <a:solidFill>
                   <a:srgbClr val="56616F"/>
@@ -12333,6 +12589,7 @@
           <a:lstStyle xmlns:a="http://schemas.openxmlformats.org/drawingml/2006/main"/>
           <a:p xmlns:a="http://schemas.openxmlformats.org/drawingml/2006/main">
             <a:pPr algn="l">
+              <a:buNone/>
               <a:defRPr sz="3000" b="1" i="0">
                 <a:solidFill>
                   <a:srgbClr val="101820"/>
@@ -12383,6 +12640,7 @@
           <a:lstStyle xmlns:a="http://schemas.openxmlformats.org/drawingml/2006/main"/>
           <a:p xmlns:a="http://schemas.openxmlformats.org/drawingml/2006/main">
             <a:pPr algn="l">
+              <a:buNone/>
               <a:defRPr sz="1350" b="0" i="0">
                 <a:solidFill>
                   <a:srgbClr val="56616F"/>
@@ -12402,7 +12660,7 @@
       </p:sp>
       <p:graphicFrame>
         <p:nvGraphicFramePr>
-          <p:cNvPr id="20" name="Chart"/>
+          <p:cNvPr id="22" name="Chart"/>
           <p:cNvGraphicFramePr/>
           <p:nvPr/>
         </p:nvGraphicFramePr>
@@ -12412,7 +12670,7 @@
         </p:xfrm>
         <a:graphic xmlns:a="http://schemas.openxmlformats.org/drawingml/2006/main">
           <a:graphicData uri="http://schemas.openxmlformats.org/drawingml/2006/chart">
-            <c:chart xmlns:r="http://schemas.openxmlformats.org/officeDocument/2006/relationships" xmlns:c="http://schemas.openxmlformats.org/drawingml/2006/chart" r:id="R03986feacf5b438c"/>
+            <c:chart xmlns:r="http://schemas.openxmlformats.org/officeDocument/2006/relationships" xmlns:c="http://schemas.openxmlformats.org/drawingml/2006/chart" r:id="R44f6d60ee55c4309"/>
           </a:graphicData>
         </a:graphic>
       </p:graphicFrame>
@@ -12449,6 +12707,7 @@
           <a:lstStyle xmlns:a="http://schemas.openxmlformats.org/drawingml/2006/main"/>
           <a:p xmlns:a="http://schemas.openxmlformats.org/drawingml/2006/main">
             <a:pPr algn="l">
+              <a:buNone/>
               <a:defRPr sz="2100" b="1" i="0">
                 <a:solidFill>
                   <a:srgbClr val="101820"/>
@@ -12530,6 +12789,7 @@
           <a:lstStyle xmlns:a="http://schemas.openxmlformats.org/drawingml/2006/main"/>
           <a:p xmlns:a="http://schemas.openxmlformats.org/drawingml/2006/main">
             <a:pPr algn="l">
+              <a:buNone/>
               <a:defRPr sz="1650" b="0" i="0">
                 <a:solidFill>
                   <a:srgbClr val="101820"/>
@@ -12552,6 +12812,7 @@
           </a:p>
           <a:p xmlns:a="http://schemas.openxmlformats.org/drawingml/2006/main">
             <a:pPr algn="l">
+              <a:buNone/>
               <a:defRPr sz="1650" b="0" i="0">
                 <a:solidFill>
                   <a:srgbClr val="101820"/>
@@ -12569,6 +12830,7 @@
           </a:p>
           <a:p xmlns:a="http://schemas.openxmlformats.org/drawingml/2006/main">
             <a:pPr algn="l">
+              <a:buNone/>
               <a:defRPr sz="1650" b="0" i="0">
                 <a:solidFill>
                   <a:srgbClr val="101820"/>
@@ -12586,6 +12848,7 @@
           </a:p>
           <a:p xmlns:a="http://schemas.openxmlformats.org/drawingml/2006/main">
             <a:pPr algn="l">
+              <a:buNone/>
               <a:defRPr sz="1650" b="0" i="0">
                 <a:solidFill>
                   <a:srgbClr val="101820"/>
@@ -12603,6 +12866,7 @@
           </a:p>
           <a:p xmlns:a="http://schemas.openxmlformats.org/drawingml/2006/main">
             <a:pPr algn="l">
+              <a:buNone/>
               <a:defRPr sz="1650" b="0" i="0">
                 <a:solidFill>
                   <a:srgbClr val="101820"/>
@@ -12653,6 +12917,7 @@
           <a:lstStyle xmlns:a="http://schemas.openxmlformats.org/drawingml/2006/main"/>
           <a:p xmlns:a="http://schemas.openxmlformats.org/drawingml/2006/main">
             <a:pPr algn="l">
+              <a:buNone/>
               <a:defRPr sz="1350" b="1" i="0">
                 <a:solidFill>
                   <a:srgbClr val="0B3D52"/>
@@ -12732,6 +12997,7 @@
           <a:lstStyle xmlns:a="http://schemas.openxmlformats.org/drawingml/2006/main"/>
           <a:p xmlns:a="http://schemas.openxmlformats.org/drawingml/2006/main">
             <a:pPr algn="l">
+              <a:buNone/>
               <a:defRPr sz="975" b="1" i="0">
                 <a:solidFill>
                   <a:srgbClr val="56616F"/>
@@ -12782,6 +13048,7 @@
           <a:lstStyle xmlns:a="http://schemas.openxmlformats.org/drawingml/2006/main"/>
           <a:p xmlns:a="http://schemas.openxmlformats.org/drawingml/2006/main">
             <a:pPr algn="r">
+              <a:buNone/>
               <a:defRPr sz="975" b="1" i="0">
                 <a:solidFill>
                   <a:srgbClr val="56616F"/>
@@ -12863,6 +13130,7 @@
           <a:lstStyle xmlns:a="http://schemas.openxmlformats.org/drawingml/2006/main"/>
           <a:p xmlns:a="http://schemas.openxmlformats.org/drawingml/2006/main">
             <a:pPr algn="l">
+              <a:buNone/>
               <a:defRPr sz="825" b="0" i="0">
                 <a:solidFill>
                   <a:srgbClr val="56616F"/>
@@ -12913,6 +13181,7 @@
           <a:lstStyle xmlns:a="http://schemas.openxmlformats.org/drawingml/2006/main"/>
           <a:p xmlns:a="http://schemas.openxmlformats.org/drawingml/2006/main">
             <a:pPr algn="r">
+              <a:buNone/>
               <a:defRPr sz="825" b="0" i="0">
                 <a:solidFill>
                   <a:srgbClr val="56616F"/>
@@ -12963,6 +13232,7 @@
           <a:lstStyle xmlns:a="http://schemas.openxmlformats.org/drawingml/2006/main"/>
           <a:p xmlns:a="http://schemas.openxmlformats.org/drawingml/2006/main">
             <a:pPr algn="l">
+              <a:buNone/>
               <a:defRPr sz="3000" b="1" i="0">
                 <a:solidFill>
                   <a:srgbClr val="101820"/>
@@ -12975,7 +13245,7 @@
                   <a:srgbClr val="101820"/>
                 </a:solidFill>
               </a:rPr>
-              <a:t>Combined stress exhausts LCR proxy headroom</a:t>
+              <a:t>Rapid digital run exposes a seven-day survival horizon</a:t>
             </a:r>
           </a:p>
         </p:txBody>
@@ -13013,6 +13283,7 @@
           <a:lstStyle xmlns:a="http://schemas.openxmlformats.org/drawingml/2006/main"/>
           <a:p xmlns:a="http://schemas.openxmlformats.org/drawingml/2006/main">
             <a:pPr algn="l">
+              <a:buNone/>
               <a:defRPr sz="1350" b="0" i="0">
                 <a:solidFill>
                   <a:srgbClr val="56616F"/>
@@ -13025,14 +13296,14 @@
                   <a:srgbClr val="56616F"/>
                 </a:solidFill>
               </a:rPr>
-              <a:t>The proxy falls from 158.7% to 94.8%, while the survival horizon reaches the 30-day floor.</a:t>
+              <a:t>Front-loaded outflows and HQLA stress drive the proxy to 78.1% and exhaust the buffer inside one week.</a:t>
             </a:r>
           </a:p>
         </p:txBody>
       </p:sp>
       <p:graphicFrame>
         <p:nvGraphicFramePr>
-          <p:cNvPr id="23" name="Chart"/>
+          <p:cNvPr id="25" name="Chart"/>
           <p:cNvGraphicFramePr/>
           <p:nvPr/>
         </p:nvGraphicFramePr>
@@ -13042,7 +13313,7 @@
         </p:xfrm>
         <a:graphic xmlns:a="http://schemas.openxmlformats.org/drawingml/2006/main">
           <a:graphicData uri="http://schemas.openxmlformats.org/drawingml/2006/chart">
-            <c:chart xmlns:r="http://schemas.openxmlformats.org/officeDocument/2006/relationships" xmlns:c="http://schemas.openxmlformats.org/drawingml/2006/chart" r:id="Re15898ed86ca464c"/>
+            <c:chart xmlns:r="http://schemas.openxmlformats.org/officeDocument/2006/relationships" xmlns:c="http://schemas.openxmlformats.org/drawingml/2006/chart" r:id="R7de4425024ca440b"/>
           </a:graphicData>
         </a:graphic>
       </p:graphicFrame>
@@ -13110,6 +13381,7 @@
           <a:lstStyle xmlns:a="http://schemas.openxmlformats.org/drawingml/2006/main"/>
           <a:p xmlns:a="http://schemas.openxmlformats.org/drawingml/2006/main">
             <a:pPr algn="l">
+              <a:buNone/>
               <a:defRPr sz="3450" b="1" i="0">
                 <a:solidFill>
                   <a:srgbClr val="F97316"/>
@@ -13122,7 +13394,7 @@
                   <a:srgbClr val="F97316"/>
                 </a:solidFill>
               </a:rPr>
-              <a:t>94.8%</a:t>
+              <a:t>78.1%</a:t>
             </a:r>
           </a:p>
         </p:txBody>
@@ -13160,6 +13432,7 @@
           <a:lstStyle xmlns:a="http://schemas.openxmlformats.org/drawingml/2006/main"/>
           <a:p xmlns:a="http://schemas.openxmlformats.org/drawingml/2006/main">
             <a:pPr algn="l">
+              <a:buNone/>
               <a:defRPr sz="1500" b="1" i="0">
                 <a:solidFill>
                   <a:srgbClr val="101820"/>
@@ -13172,7 +13445,7 @@
                   <a:srgbClr val="101820"/>
                 </a:solidFill>
               </a:rPr>
-              <a:t>combined LCR proxy</a:t>
+              <a:t>rapid-run LCR proxy</a:t>
             </a:r>
           </a:p>
         </p:txBody>
@@ -13241,6 +13514,7 @@
           <a:lstStyle xmlns:a="http://schemas.openxmlformats.org/drawingml/2006/main"/>
           <a:p xmlns:a="http://schemas.openxmlformats.org/drawingml/2006/main">
             <a:pPr algn="l">
+              <a:buNone/>
               <a:defRPr sz="3000" b="1" i="0">
                 <a:solidFill>
                   <a:srgbClr val="101820"/>
@@ -13253,7 +13527,7 @@
                   <a:srgbClr val="101820"/>
                 </a:solidFill>
               </a:rPr>
-              <a:t>30 days</a:t>
+              <a:t>7 days</a:t>
             </a:r>
           </a:p>
         </p:txBody>
@@ -13291,6 +13565,7 @@
           <a:lstStyle xmlns:a="http://schemas.openxmlformats.org/drawingml/2006/main"/>
           <a:p xmlns:a="http://schemas.openxmlformats.org/drawingml/2006/main">
             <a:pPr algn="l">
+              <a:buNone/>
               <a:defRPr sz="1425" b="0" i="0">
                 <a:solidFill>
                   <a:srgbClr val="56616F"/>
@@ -13303,11 +13578,12 @@
                   <a:srgbClr val="56616F"/>
                 </a:solidFill>
               </a:rPr>
-              <a:t>combined survival horizon</a:t>
+              <a:t>rapid-run survival horizon</a:t>
             </a:r>
           </a:p>
           <a:p xmlns:a="http://schemas.openxmlformats.org/drawingml/2006/main">
             <a:pPr algn="l">
+              <a:buNone/>
               <a:defRPr sz="1425" b="0" i="0">
                 <a:solidFill>
                   <a:srgbClr val="56616F"/>
@@ -13320,7 +13596,7 @@
                   <a:srgbClr val="56616F"/>
                 </a:solidFill>
               </a:rPr>
-              <a:t>NSFR proxy: 143.4%</a:t>
+              <a:t>HQLA loss: TRY 1.46bn</a:t>
             </a:r>
           </a:p>
         </p:txBody>
@@ -13358,6 +13634,7 @@
           <a:lstStyle xmlns:a="http://schemas.openxmlformats.org/drawingml/2006/main"/>
           <a:p xmlns:a="http://schemas.openxmlformats.org/drawingml/2006/main">
             <a:pPr algn="l">
+              <a:buNone/>
               <a:defRPr sz="1500" b="1" i="0">
                 <a:solidFill>
                   <a:srgbClr val="101820"/>
@@ -13370,7 +13647,7 @@
                   <a:srgbClr val="101820"/>
                 </a:solidFill>
               </a:rPr>
-              <a:t>Management action | retain HQLA, pre-position contingent funding and monitor deposit runoff triggers daily.</a:t>
+              <a:t>Management action | pre-position funding, protect unencumbered HQLA and rehearse a seven-day contingency response.</a:t>
             </a:r>
           </a:p>
         </p:txBody>
@@ -13437,6 +13714,7 @@
           <a:lstStyle xmlns:a="http://schemas.openxmlformats.org/drawingml/2006/main"/>
           <a:p xmlns:a="http://schemas.openxmlformats.org/drawingml/2006/main">
             <a:pPr algn="l">
+              <a:buNone/>
               <a:defRPr sz="975" b="1" i="0">
                 <a:solidFill>
                   <a:srgbClr val="56616F"/>
@@ -13487,6 +13765,7 @@
           <a:lstStyle xmlns:a="http://schemas.openxmlformats.org/drawingml/2006/main"/>
           <a:p xmlns:a="http://schemas.openxmlformats.org/drawingml/2006/main">
             <a:pPr algn="r">
+              <a:buNone/>
               <a:defRPr sz="975" b="1" i="0">
                 <a:solidFill>
                   <a:srgbClr val="56616F"/>
@@ -13568,6 +13847,7 @@
           <a:lstStyle xmlns:a="http://schemas.openxmlformats.org/drawingml/2006/main"/>
           <a:p xmlns:a="http://schemas.openxmlformats.org/drawingml/2006/main">
             <a:pPr algn="l">
+              <a:buNone/>
               <a:defRPr sz="825" b="0" i="0">
                 <a:solidFill>
                   <a:srgbClr val="56616F"/>
@@ -13618,6 +13898,7 @@
           <a:lstStyle xmlns:a="http://schemas.openxmlformats.org/drawingml/2006/main"/>
           <a:p xmlns:a="http://schemas.openxmlformats.org/drawingml/2006/main">
             <a:pPr algn="r">
+              <a:buNone/>
               <a:defRPr sz="825" b="0" i="0">
                 <a:solidFill>
                   <a:srgbClr val="56616F"/>
@@ -13668,6 +13949,7 @@
           <a:lstStyle xmlns:a="http://schemas.openxmlformats.org/drawingml/2006/main"/>
           <a:p xmlns:a="http://schemas.openxmlformats.org/drawingml/2006/main">
             <a:pPr algn="l">
+              <a:buNone/>
               <a:defRPr sz="3000" b="1" i="0">
                 <a:solidFill>
                   <a:srgbClr val="101820"/>
@@ -13718,6 +14000,7 @@
           <a:lstStyle xmlns:a="http://schemas.openxmlformats.org/drawingml/2006/main"/>
           <a:p xmlns:a="http://schemas.openxmlformats.org/drawingml/2006/main">
             <a:pPr algn="l">
+              <a:buNone/>
               <a:defRPr sz="1350" b="0" i="0">
                 <a:solidFill>
                   <a:srgbClr val="56616F"/>
@@ -13737,7 +14020,7 @@
       </p:sp>
       <p:graphicFrame>
         <p:nvGraphicFramePr>
-          <p:cNvPr id="22" name="Chart"/>
+          <p:cNvPr id="24" name="Chart"/>
           <p:cNvGraphicFramePr/>
           <p:nvPr/>
         </p:nvGraphicFramePr>
@@ -13747,7 +14030,7 @@
         </p:xfrm>
         <a:graphic xmlns:a="http://schemas.openxmlformats.org/drawingml/2006/main">
           <a:graphicData uri="http://schemas.openxmlformats.org/drawingml/2006/chart">
-            <c:chart xmlns:r="http://schemas.openxmlformats.org/officeDocument/2006/relationships" xmlns:c="http://schemas.openxmlformats.org/drawingml/2006/chart" r:id="R8f8daeba432e4b19"/>
+            <c:chart xmlns:r="http://schemas.openxmlformats.org/officeDocument/2006/relationships" xmlns:c="http://schemas.openxmlformats.org/drawingml/2006/chart" r:id="Rccc0a2d8be1d4631"/>
           </a:graphicData>
         </a:graphic>
       </p:graphicFrame>
@@ -13815,6 +14098,7 @@
           <a:lstStyle xmlns:a="http://schemas.openxmlformats.org/drawingml/2006/main"/>
           <a:p xmlns:a="http://schemas.openxmlformats.org/drawingml/2006/main">
             <a:pPr algn="l">
+              <a:buNone/>
               <a:defRPr sz="3000" b="1" i="0">
                 <a:solidFill>
                   <a:srgbClr val="F97316"/>
@@ -13865,6 +14149,7 @@
           <a:lstStyle xmlns:a="http://schemas.openxmlformats.org/drawingml/2006/main"/>
           <a:p xmlns:a="http://schemas.openxmlformats.org/drawingml/2006/main">
             <a:pPr algn="l">
+              <a:buNone/>
               <a:defRPr sz="1725" b="1" i="0">
                 <a:solidFill>
                   <a:srgbClr val="101820"/>
@@ -13946,6 +14231,7 @@
           <a:lstStyle xmlns:a="http://schemas.openxmlformats.org/drawingml/2006/main"/>
           <a:p xmlns:a="http://schemas.openxmlformats.org/drawingml/2006/main">
             <a:pPr algn="l">
+              <a:buNone/>
               <a:defRPr sz="1650" b="0" i="0">
                 <a:solidFill>
                   <a:srgbClr val="101820"/>
@@ -13963,6 +14249,7 @@
           </a:p>
           <a:p xmlns:a="http://schemas.openxmlformats.org/drawingml/2006/main">
             <a:pPr algn="l">
+              <a:buNone/>
               <a:defRPr sz="1650" b="0" i="0">
                 <a:solidFill>
                   <a:srgbClr val="101820"/>
@@ -13980,6 +14267,7 @@
           </a:p>
           <a:p xmlns:a="http://schemas.openxmlformats.org/drawingml/2006/main">
             <a:pPr algn="l">
+              <a:buNone/>
               <a:defRPr sz="1650" b="0" i="0">
                 <a:solidFill>
                   <a:srgbClr val="101820"/>
@@ -14030,6 +14318,7 @@
           <a:lstStyle xmlns:a="http://schemas.openxmlformats.org/drawingml/2006/main"/>
           <a:p xmlns:a="http://schemas.openxmlformats.org/drawingml/2006/main">
             <a:pPr algn="l">
+              <a:buNone/>
               <a:defRPr sz="1950" b="1" i="0">
                 <a:solidFill>
                   <a:srgbClr val="101820"/>

</xml_diff>